<commit_message>
fix: mise à jour du fichier de présentation pour corriger des erreurs
</commit_message>
<xml_diff>
--- a/P2-Backend-Soutenance.pptx
+++ b/P2-Backend-Soutenance.pptx
@@ -19,6 +19,8 @@
     <p:sldId id="267" r:id="rId18"/>
     <p:sldId id="268" r:id="rId19"/>
     <p:sldId id="269" r:id="rId20"/>
+    <p:sldId id="270" r:id="rId21"/>
+    <p:sldId id="271" r:id="rId22"/>
   </p:sldIdLst>
   <p:sldSz cx="12191695" cy="6858000" type="screen4x3"/>
   <p:notesSz cx="6858000" cy="9144000"/>
@@ -5335,6 +5337,50 @@
             <a:avLst/>
           </a:prstGeom>
           <a:solidFill>
+            <a:srgbClr val="FFFFFF"/>
+          </a:solidFill>
+          <a:ln>
+            <a:noFill/>
+          </a:ln>
+          <a:effectLst/>
+        </p:spPr>
+        <p:style>
+          <a:lnRef idx="1">
+            <a:schemeClr val="accent1"/>
+          </a:lnRef>
+          <a:fillRef idx="3">
+            <a:schemeClr val="accent1"/>
+          </a:fillRef>
+          <a:effectRef idx="2">
+            <a:schemeClr val="accent1"/>
+          </a:effectRef>
+          <a:fontRef idx="minor">
+            <a:schemeClr val="lt1"/>
+          </a:fontRef>
+        </p:style>
+        <p:txBody>
+          <a:bodyPr rtlCol="0" anchor="ctr"/>
+          <a:lstStyle/>
+          <a:p>
+            <a:pPr algn="ctr"/>
+          </a:p>
+        </p:txBody>
+      </p:sp>
+      <p:sp>
+        <p:nvSpPr>
+          <p:cNvPr id="3" name="Rectangle 2"/>
+          <p:cNvSpPr/>
+          <p:nvPr/>
+        </p:nvSpPr>
+        <p:spPr>
+          <a:xfrm>
+            <a:off x="0" y="0"/>
+            <a:ext cx="12191695" cy="1051560"/>
+          </a:xfrm>
+          <a:prstGeom prst="rect">
+            <a:avLst/>
+          </a:prstGeom>
+          <a:solidFill>
             <a:srgbClr val="0B1F3A"/>
           </a:solidFill>
           <a:ln>
@@ -5366,13 +5412,13 @@
       </p:sp>
       <p:sp>
         <p:nvSpPr>
-          <p:cNvPr id="3" name="Rectangle 2"/>
+          <p:cNvPr id="4" name="Rectangle 3"/>
           <p:cNvSpPr/>
           <p:nvPr/>
         </p:nvSpPr>
         <p:spPr>
           <a:xfrm>
-            <a:off x="0" y="914400"/>
+            <a:off x="0" y="1051560"/>
             <a:ext cx="12191695" cy="73152"/>
           </a:xfrm>
           <a:prstGeom prst="rect">
@@ -5410,14 +5456,591 @@
       </p:sp>
       <p:sp>
         <p:nvSpPr>
-          <p:cNvPr id="4" name="TextBox 3"/>
+          <p:cNvPr id="5" name="TextBox 4"/>
           <p:cNvSpPr txBox="1"/>
           <p:nvPr/>
         </p:nvSpPr>
         <p:spPr>
           <a:xfrm>
-            <a:off x="822960" y="365760"/>
-            <a:ext cx="10515600" cy="640080"/>
+            <a:off x="548640" y="164592"/>
+            <a:ext cx="11064240" cy="868680"/>
+          </a:xfrm>
+          <a:prstGeom prst="rect">
+            <a:avLst/>
+          </a:prstGeom>
+          <a:noFill/>
+        </p:spPr>
+        <p:txBody>
+          <a:bodyPr wrap="square">
+            <a:spAutoFit/>
+          </a:bodyPr>
+          <a:lstStyle/>
+          <a:p>
+            <a:pPr algn="l">
+              <a:spcAft>
+                <a:spcPts val="600"/>
+              </a:spcAft>
+            </a:pPr>
+            <a:r>
+              <a:rPr sz="2800" b="1">
+                <a:solidFill>
+                  <a:srgbClr val="FFFFFF"/>
+                </a:solidFill>
+                <a:latin typeface="Calibri"/>
+              </a:rPr>
+              <a:t>Back-office &amp; gestion admin</a:t>
+            </a:r>
+          </a:p>
+        </p:txBody>
+      </p:sp>
+      <p:sp>
+        <p:nvSpPr>
+          <p:cNvPr id="6" name="TextBox 5"/>
+          <p:cNvSpPr txBox="1"/>
+          <p:nvPr/>
+        </p:nvSpPr>
+        <p:spPr>
+          <a:xfrm>
+            <a:off x="566928" y="786384"/>
+            <a:ext cx="11064240" cy="365760"/>
+          </a:xfrm>
+          <a:prstGeom prst="rect">
+            <a:avLst/>
+          </a:prstGeom>
+          <a:noFill/>
+        </p:spPr>
+        <p:txBody>
+          <a:bodyPr wrap="square">
+            <a:spAutoFit/>
+          </a:bodyPr>
+          <a:lstStyle/>
+          <a:p>
+            <a:pPr algn="l">
+              <a:spcAft>
+                <a:spcPts val="600"/>
+              </a:spcAft>
+            </a:pPr>
+            <a:r>
+              <a:rPr sz="1200" b="1">
+                <a:solidFill>
+                  <a:srgbClr val="2EC4B6"/>
+                </a:solidFill>
+                <a:latin typeface="Calibri"/>
+              </a:rPr>
+              <a:t>Endpoints /admin protégés (AuthGuard + AdminGuard)</a:t>
+            </a:r>
+          </a:p>
+        </p:txBody>
+      </p:sp>
+      <p:sp>
+        <p:nvSpPr>
+          <p:cNvPr id="7" name="TextBox 6"/>
+          <p:cNvSpPr txBox="1"/>
+          <p:nvPr/>
+        </p:nvSpPr>
+        <p:spPr>
+          <a:xfrm>
+            <a:off x="640080" y="1463040"/>
+            <a:ext cx="10972800" cy="5029200"/>
+          </a:xfrm>
+          <a:prstGeom prst="rect">
+            <a:avLst/>
+          </a:prstGeom>
+          <a:noFill/>
+        </p:spPr>
+        <p:txBody>
+          <a:bodyPr wrap="square">
+            <a:spAutoFit/>
+          </a:bodyPr>
+          <a:lstStyle/>
+          <a:p>
+            <a:pPr algn="l">
+              <a:spcAft>
+                <a:spcPts val="1000"/>
+              </a:spcAft>
+            </a:pPr>
+            <a:r>
+              <a:rPr sz="1600" b="1">
+                <a:solidFill>
+                  <a:srgbClr val="2EC4B6"/>
+                </a:solidFill>
+                <a:latin typeface="Calibri"/>
+              </a:rPr>
+              <a:t>▸  </a:t>
+            </a:r>
+            <a:r>
+              <a:rPr sz="1600" b="1">
+                <a:solidFill>
+                  <a:srgbClr val="17202A"/>
+                </a:solidFill>
+                <a:latin typeface="Calibri"/>
+              </a:rPr>
+              <a:t>ACL dynamique</a:t>
+            </a:r>
+            <a:r>
+              <a:rPr sz="1600" b="0">
+                <a:solidFill>
+                  <a:srgbClr val="52606D"/>
+                </a:solidFill>
+                <a:latin typeface="Calibri"/>
+              </a:rPr>
+              <a:t> — droits par contenu en mémoire (fini l'ACL codée en dur)</a:t>
+            </a:r>
+          </a:p>
+          <a:p>
+            <a:pPr algn="l">
+              <a:spcAft>
+                <a:spcPts val="1000"/>
+              </a:spcAft>
+            </a:pPr>
+            <a:r>
+              <a:rPr sz="1600" b="1">
+                <a:solidFill>
+                  <a:srgbClr val="2EC4B6"/>
+                </a:solidFill>
+                <a:latin typeface="Calibri"/>
+              </a:rPr>
+              <a:t>▸  </a:t>
+            </a:r>
+            <a:r>
+              <a:rPr sz="1600" b="1">
+                <a:solidFill>
+                  <a:srgbClr val="17202A"/>
+                </a:solidFill>
+                <a:latin typeface="Calibri"/>
+              </a:rPr>
+              <a:t>Utilisateurs</a:t>
+            </a:r>
+            <a:r>
+              <a:rPr sz="1600" b="0">
+                <a:solidFill>
+                  <a:srgbClr val="52606D"/>
+                </a:solidFill>
+                <a:latin typeface="Calibri"/>
+              </a:rPr>
+              <a:t> — GET /admin/users — liste des comptes et rôles</a:t>
+            </a:r>
+          </a:p>
+          <a:p>
+            <a:pPr algn="l">
+              <a:spcAft>
+                <a:spcPts val="1000"/>
+              </a:spcAft>
+            </a:pPr>
+            <a:r>
+              <a:rPr sz="1600" b="1">
+                <a:solidFill>
+                  <a:srgbClr val="2EC4B6"/>
+                </a:solidFill>
+                <a:latin typeface="Calibri"/>
+              </a:rPr>
+              <a:t>▸  </a:t>
+            </a:r>
+            <a:r>
+              <a:rPr sz="1600" b="1">
+                <a:solidFill>
+                  <a:srgbClr val="17202A"/>
+                </a:solidFill>
+                <a:latin typeface="Calibri"/>
+              </a:rPr>
+              <a:t>Contenus &amp; droits</a:t>
+            </a:r>
+            <a:r>
+              <a:rPr sz="1600" b="0">
+                <a:solidFill>
+                  <a:srgbClr val="52606D"/>
+                </a:solidFill>
+                <a:latin typeface="Calibri"/>
+              </a:rPr>
+              <a:t> — GET /admin/contents + donner/retirer l'accès d'un user</a:t>
+            </a:r>
+          </a:p>
+          <a:p>
+            <a:pPr algn="l">
+              <a:spcAft>
+                <a:spcPts val="1000"/>
+              </a:spcAft>
+            </a:pPr>
+            <a:r>
+              <a:rPr sz="1600" b="1">
+                <a:solidFill>
+                  <a:srgbClr val="2EC4B6"/>
+                </a:solidFill>
+                <a:latin typeface="Calibri"/>
+              </a:rPr>
+              <a:t>▸  </a:t>
+            </a:r>
+            <a:r>
+              <a:rPr sz="1600" b="1">
+                <a:solidFill>
+                  <a:srgbClr val="17202A"/>
+                </a:solidFill>
+                <a:latin typeface="Calibri"/>
+              </a:rPr>
+              <a:t>Révocation de clé EN DIRECT</a:t>
+            </a:r>
+            <a:r>
+              <a:rPr sz="1600" b="0">
+                <a:solidFill>
+                  <a:srgbClr val="52606D"/>
+                </a:solidFill>
+                <a:latin typeface="Calibri"/>
+              </a:rPr>
+              <a:t> — POST /admin/contents/:id/revoke -&gt; /keys passe à 403</a:t>
+            </a:r>
+          </a:p>
+          <a:p>
+            <a:pPr algn="l">
+              <a:spcAft>
+                <a:spcPts val="1000"/>
+              </a:spcAft>
+            </a:pPr>
+            <a:r>
+              <a:rPr sz="1600" b="1">
+                <a:solidFill>
+                  <a:srgbClr val="2EC4B6"/>
+                </a:solidFill>
+                <a:latin typeface="Calibri"/>
+              </a:rPr>
+              <a:t>▸  </a:t>
+            </a:r>
+            <a:r>
+              <a:rPr sz="1600" b="1">
+                <a:solidFill>
+                  <a:srgbClr val="17202A"/>
+                </a:solidFill>
+                <a:latin typeface="Calibri"/>
+              </a:rPr>
+              <a:t>Restauration</a:t>
+            </a:r>
+            <a:r>
+              <a:rPr sz="1600" b="0">
+                <a:solidFill>
+                  <a:srgbClr val="52606D"/>
+                </a:solidFill>
+                <a:latin typeface="Calibri"/>
+              </a:rPr>
+              <a:t> — POST .../restore -&gt; la lecture repart</a:t>
+            </a:r>
+          </a:p>
+          <a:p>
+            <a:pPr algn="l">
+              <a:spcAft>
+                <a:spcPts val="1000"/>
+              </a:spcAft>
+            </a:pPr>
+            <a:r>
+              <a:rPr sz="1600" b="1">
+                <a:solidFill>
+                  <a:srgbClr val="2EC4B6"/>
+                </a:solidFill>
+                <a:latin typeface="Calibri"/>
+              </a:rPr>
+              <a:t>▸  </a:t>
+            </a:r>
+            <a:r>
+              <a:rPr sz="1600" b="1">
+                <a:solidFill>
+                  <a:srgbClr val="17202A"/>
+                </a:solidFill>
+                <a:latin typeface="Calibri"/>
+              </a:rPr>
+              <a:t>Démo</a:t>
+            </a:r>
+            <a:r>
+              <a:rPr sz="1600" b="0">
+                <a:solidFill>
+                  <a:srgbClr val="52606D"/>
+                </a:solidFill>
+                <a:latin typeface="Calibri"/>
+              </a:rPr>
+              <a:t> — couper l'accès d'un spectateur devant le jury, en live</a:t>
+            </a:r>
+          </a:p>
+        </p:txBody>
+      </p:sp>
+    </p:spTree>
+  </p:cSld>
+  <p:clrMapOvr>
+    <a:masterClrMapping/>
+  </p:clrMapOvr>
+</p:sld>
+</file>
+
+<file path=ppt/slides/slide15.xml><?xml version="1.0" encoding="utf-8"?>
+<p:sld xmlns:a="http://schemas.openxmlformats.org/drawingml/2006/main" xmlns:p="http://schemas.openxmlformats.org/presentationml/2006/main" xmlns:r="http://schemas.openxmlformats.org/officeDocument/2006/relationships">
+  <p:cSld>
+    <p:spTree>
+      <p:nvGrpSpPr>
+        <p:cNvPr id="1" name=""/>
+        <p:cNvGrpSpPr/>
+        <p:nvPr/>
+      </p:nvGrpSpPr>
+      <p:grpSpPr/>
+      <p:sp>
+        <p:nvSpPr>
+          <p:cNvPr id="2" name="Rectangle 1"/>
+          <p:cNvSpPr/>
+          <p:nvPr/>
+        </p:nvSpPr>
+        <p:spPr>
+          <a:xfrm>
+            <a:off x="-91440" y="-91440"/>
+            <a:ext cx="12435840" cy="7040880"/>
+          </a:xfrm>
+          <a:prstGeom prst="rect">
+            <a:avLst/>
+          </a:prstGeom>
+          <a:solidFill>
+            <a:srgbClr val="FFFFFF"/>
+          </a:solidFill>
+          <a:ln>
+            <a:noFill/>
+          </a:ln>
+          <a:effectLst/>
+        </p:spPr>
+        <p:style>
+          <a:lnRef idx="1">
+            <a:schemeClr val="accent1"/>
+          </a:lnRef>
+          <a:fillRef idx="3">
+            <a:schemeClr val="accent1"/>
+          </a:fillRef>
+          <a:effectRef idx="2">
+            <a:schemeClr val="accent1"/>
+          </a:effectRef>
+          <a:fontRef idx="minor">
+            <a:schemeClr val="lt1"/>
+          </a:fontRef>
+        </p:style>
+        <p:txBody>
+          <a:bodyPr rtlCol="0" anchor="ctr"/>
+          <a:lstStyle/>
+          <a:p>
+            <a:pPr algn="ctr"/>
+          </a:p>
+        </p:txBody>
+      </p:sp>
+      <p:sp>
+        <p:nvSpPr>
+          <p:cNvPr id="3" name="Rectangle 2"/>
+          <p:cNvSpPr/>
+          <p:nvPr/>
+        </p:nvSpPr>
+        <p:spPr>
+          <a:xfrm>
+            <a:off x="0" y="0"/>
+            <a:ext cx="12191695" cy="1051560"/>
+          </a:xfrm>
+          <a:prstGeom prst="rect">
+            <a:avLst/>
+          </a:prstGeom>
+          <a:solidFill>
+            <a:srgbClr val="0B1F3A"/>
+          </a:solidFill>
+          <a:ln>
+            <a:noFill/>
+          </a:ln>
+          <a:effectLst/>
+        </p:spPr>
+        <p:style>
+          <a:lnRef idx="1">
+            <a:schemeClr val="accent1"/>
+          </a:lnRef>
+          <a:fillRef idx="3">
+            <a:schemeClr val="accent1"/>
+          </a:fillRef>
+          <a:effectRef idx="2">
+            <a:schemeClr val="accent1"/>
+          </a:effectRef>
+          <a:fontRef idx="minor">
+            <a:schemeClr val="lt1"/>
+          </a:fontRef>
+        </p:style>
+        <p:txBody>
+          <a:bodyPr rtlCol="0" anchor="ctr"/>
+          <a:lstStyle/>
+          <a:p>
+            <a:pPr algn="ctr"/>
+          </a:p>
+        </p:txBody>
+      </p:sp>
+      <p:sp>
+        <p:nvSpPr>
+          <p:cNvPr id="4" name="Rectangle 3"/>
+          <p:cNvSpPr/>
+          <p:nvPr/>
+        </p:nvSpPr>
+        <p:spPr>
+          <a:xfrm>
+            <a:off x="0" y="1051560"/>
+            <a:ext cx="12191695" cy="73152"/>
+          </a:xfrm>
+          <a:prstGeom prst="rect">
+            <a:avLst/>
+          </a:prstGeom>
+          <a:solidFill>
+            <a:srgbClr val="2EC4B6"/>
+          </a:solidFill>
+          <a:ln>
+            <a:noFill/>
+          </a:ln>
+          <a:effectLst/>
+        </p:spPr>
+        <p:style>
+          <a:lnRef idx="1">
+            <a:schemeClr val="accent1"/>
+          </a:lnRef>
+          <a:fillRef idx="3">
+            <a:schemeClr val="accent1"/>
+          </a:fillRef>
+          <a:effectRef idx="2">
+            <a:schemeClr val="accent1"/>
+          </a:effectRef>
+          <a:fontRef idx="minor">
+            <a:schemeClr val="lt1"/>
+          </a:fontRef>
+        </p:style>
+        <p:txBody>
+          <a:bodyPr rtlCol="0" anchor="ctr"/>
+          <a:lstStyle/>
+          <a:p>
+            <a:pPr algn="ctr"/>
+          </a:p>
+        </p:txBody>
+      </p:sp>
+      <p:sp>
+        <p:nvSpPr>
+          <p:cNvPr id="5" name="TextBox 4"/>
+          <p:cNvSpPr txBox="1"/>
+          <p:nvPr/>
+        </p:nvSpPr>
+        <p:spPr>
+          <a:xfrm>
+            <a:off x="548640" y="164592"/>
+            <a:ext cx="11064240" cy="868680"/>
+          </a:xfrm>
+          <a:prstGeom prst="rect">
+            <a:avLst/>
+          </a:prstGeom>
+          <a:noFill/>
+        </p:spPr>
+        <p:txBody>
+          <a:bodyPr wrap="square">
+            <a:spAutoFit/>
+          </a:bodyPr>
+          <a:lstStyle/>
+          <a:p>
+            <a:pPr algn="l">
+              <a:spcAft>
+                <a:spcPts val="600"/>
+              </a:spcAft>
+            </a:pPr>
+            <a:r>
+              <a:rPr sz="2800" b="1">
+                <a:solidFill>
+                  <a:srgbClr val="FFFFFF"/>
+                </a:solidFill>
+                <a:latin typeface="Calibri"/>
+              </a:rPr>
+              <a:t>Récap des routes backend</a:t>
+            </a:r>
+          </a:p>
+        </p:txBody>
+      </p:sp>
+      <p:sp>
+        <p:nvSpPr>
+          <p:cNvPr id="6" name="TextBox 5"/>
+          <p:cNvSpPr txBox="1"/>
+          <p:nvPr/>
+        </p:nvSpPr>
+        <p:spPr>
+          <a:xfrm>
+            <a:off x="566928" y="786384"/>
+            <a:ext cx="11064240" cy="365760"/>
+          </a:xfrm>
+          <a:prstGeom prst="rect">
+            <a:avLst/>
+          </a:prstGeom>
+          <a:noFill/>
+        </p:spPr>
+        <p:txBody>
+          <a:bodyPr wrap="square">
+            <a:spAutoFit/>
+          </a:bodyPr>
+          <a:lstStyle/>
+          <a:p>
+            <a:pPr algn="l">
+              <a:spcAft>
+                <a:spcPts val="600"/>
+              </a:spcAft>
+            </a:pPr>
+            <a:r>
+              <a:rPr sz="1200" b="1">
+                <a:solidFill>
+                  <a:srgbClr val="2EC4B6"/>
+                </a:solidFill>
+                <a:latin typeface="Calibri"/>
+              </a:rPr>
+              <a:t>Surface d'API exposée par le Core</a:t>
+            </a:r>
+          </a:p>
+        </p:txBody>
+      </p:sp>
+      <p:sp>
+        <p:nvSpPr>
+          <p:cNvPr id="7" name="Rectangle 6"/>
+          <p:cNvSpPr/>
+          <p:nvPr/>
+        </p:nvSpPr>
+        <p:spPr>
+          <a:xfrm>
+            <a:off x="640080" y="1371600"/>
+            <a:ext cx="1554480" cy="420624"/>
+          </a:xfrm>
+          <a:prstGeom prst="rect">
+            <a:avLst/>
+          </a:prstGeom>
+          <a:solidFill>
+            <a:srgbClr val="155FA0"/>
+          </a:solidFill>
+          <a:ln>
+            <a:noFill/>
+          </a:ln>
+          <a:effectLst/>
+        </p:spPr>
+        <p:style>
+          <a:lnRef idx="1">
+            <a:schemeClr val="accent1"/>
+          </a:lnRef>
+          <a:fillRef idx="3">
+            <a:schemeClr val="accent1"/>
+          </a:fillRef>
+          <a:effectRef idx="2">
+            <a:schemeClr val="accent1"/>
+          </a:effectRef>
+          <a:fontRef idx="minor">
+            <a:schemeClr val="lt1"/>
+          </a:fontRef>
+        </p:style>
+        <p:txBody>
+          <a:bodyPr rtlCol="0" anchor="ctr"/>
+          <a:lstStyle/>
+          <a:p>
+            <a:pPr algn="ctr"/>
+          </a:p>
+        </p:txBody>
+      </p:sp>
+      <p:sp>
+        <p:nvSpPr>
+          <p:cNvPr id="8" name="TextBox 7"/>
+          <p:cNvSpPr txBox="1"/>
+          <p:nvPr/>
+        </p:nvSpPr>
+        <p:spPr>
+          <a:xfrm>
+            <a:off x="658368" y="1426464"/>
+            <a:ext cx="1517904" cy="310896"/>
           </a:xfrm>
           <a:prstGeom prst="rect">
             <a:avLst/>
@@ -5430,6 +6053,1678 @@
           </a:bodyPr>
           <a:lstStyle/>
           <a:p>
+            <a:pPr algn="ctr">
+              <a:spcAft>
+                <a:spcPts val="600"/>
+              </a:spcAft>
+            </a:pPr>
+            <a:r>
+              <a:rPr sz="1100" b="1">
+                <a:solidFill>
+                  <a:srgbClr val="FFFFFF"/>
+                </a:solidFill>
+                <a:latin typeface="Calibri"/>
+              </a:rPr>
+              <a:t>POST</a:t>
+            </a:r>
+          </a:p>
+        </p:txBody>
+      </p:sp>
+      <p:sp>
+        <p:nvSpPr>
+          <p:cNvPr id="9" name="TextBox 8"/>
+          <p:cNvSpPr txBox="1"/>
+          <p:nvPr/>
+        </p:nvSpPr>
+        <p:spPr>
+          <a:xfrm>
+            <a:off x="2331720" y="1417320"/>
+            <a:ext cx="5577840" cy="365760"/>
+          </a:xfrm>
+          <a:prstGeom prst="rect">
+            <a:avLst/>
+          </a:prstGeom>
+          <a:noFill/>
+        </p:spPr>
+        <p:txBody>
+          <a:bodyPr wrap="none">
+            <a:spAutoFit/>
+          </a:bodyPr>
+          <a:lstStyle/>
+          <a:p>
+            <a:pPr algn="l">
+              <a:spcAft>
+                <a:spcPts val="600"/>
+              </a:spcAft>
+            </a:pPr>
+            <a:r>
+              <a:rPr sz="1300" b="1">
+                <a:solidFill>
+                  <a:srgbClr val="17202A"/>
+                </a:solidFill>
+                <a:latin typeface="Calibri"/>
+              </a:rPr>
+              <a:t>/auth/login</a:t>
+            </a:r>
+          </a:p>
+        </p:txBody>
+      </p:sp>
+      <p:sp>
+        <p:nvSpPr>
+          <p:cNvPr id="10" name="TextBox 9"/>
+          <p:cNvSpPr txBox="1"/>
+          <p:nvPr/>
+        </p:nvSpPr>
+        <p:spPr>
+          <a:xfrm>
+            <a:off x="8092440" y="1426464"/>
+            <a:ext cx="3566160" cy="365760"/>
+          </a:xfrm>
+          <a:prstGeom prst="rect">
+            <a:avLst/>
+          </a:prstGeom>
+          <a:noFill/>
+        </p:spPr>
+        <p:txBody>
+          <a:bodyPr wrap="none">
+            <a:spAutoFit/>
+          </a:bodyPr>
+          <a:lstStyle/>
+          <a:p>
+            <a:pPr algn="l">
+              <a:spcAft>
+                <a:spcPts val="600"/>
+              </a:spcAft>
+            </a:pPr>
+            <a:r>
+              <a:rPr sz="1200" b="0">
+                <a:solidFill>
+                  <a:srgbClr val="52606D"/>
+                </a:solidFill>
+                <a:latin typeface="Calibri"/>
+              </a:rPr>
+              <a:t>public (10/min + lockout)</a:t>
+            </a:r>
+          </a:p>
+        </p:txBody>
+      </p:sp>
+      <p:sp>
+        <p:nvSpPr>
+          <p:cNvPr id="11" name="Rectangle 10"/>
+          <p:cNvSpPr/>
+          <p:nvPr/>
+        </p:nvSpPr>
+        <p:spPr>
+          <a:xfrm>
+            <a:off x="640080" y="1874519"/>
+            <a:ext cx="1554480" cy="420624"/>
+          </a:xfrm>
+          <a:prstGeom prst="rect">
+            <a:avLst/>
+          </a:prstGeom>
+          <a:solidFill>
+            <a:srgbClr val="155FA0"/>
+          </a:solidFill>
+          <a:ln>
+            <a:noFill/>
+          </a:ln>
+          <a:effectLst/>
+        </p:spPr>
+        <p:style>
+          <a:lnRef idx="1">
+            <a:schemeClr val="accent1"/>
+          </a:lnRef>
+          <a:fillRef idx="3">
+            <a:schemeClr val="accent1"/>
+          </a:fillRef>
+          <a:effectRef idx="2">
+            <a:schemeClr val="accent1"/>
+          </a:effectRef>
+          <a:fontRef idx="minor">
+            <a:schemeClr val="lt1"/>
+          </a:fontRef>
+        </p:style>
+        <p:txBody>
+          <a:bodyPr rtlCol="0" anchor="ctr"/>
+          <a:lstStyle/>
+          <a:p>
+            <a:pPr algn="ctr"/>
+          </a:p>
+        </p:txBody>
+      </p:sp>
+      <p:sp>
+        <p:nvSpPr>
+          <p:cNvPr id="12" name="TextBox 11"/>
+          <p:cNvSpPr txBox="1"/>
+          <p:nvPr/>
+        </p:nvSpPr>
+        <p:spPr>
+          <a:xfrm>
+            <a:off x="658368" y="1929384"/>
+            <a:ext cx="1517904" cy="310896"/>
+          </a:xfrm>
+          <a:prstGeom prst="rect">
+            <a:avLst/>
+          </a:prstGeom>
+          <a:noFill/>
+        </p:spPr>
+        <p:txBody>
+          <a:bodyPr wrap="none">
+            <a:spAutoFit/>
+          </a:bodyPr>
+          <a:lstStyle/>
+          <a:p>
+            <a:pPr algn="ctr">
+              <a:spcAft>
+                <a:spcPts val="600"/>
+              </a:spcAft>
+            </a:pPr>
+            <a:r>
+              <a:rPr sz="1100" b="1">
+                <a:solidFill>
+                  <a:srgbClr val="FFFFFF"/>
+                </a:solidFill>
+                <a:latin typeface="Calibri"/>
+              </a:rPr>
+              <a:t>GET</a:t>
+            </a:r>
+          </a:p>
+        </p:txBody>
+      </p:sp>
+      <p:sp>
+        <p:nvSpPr>
+          <p:cNvPr id="13" name="TextBox 12"/>
+          <p:cNvSpPr txBox="1"/>
+          <p:nvPr/>
+        </p:nvSpPr>
+        <p:spPr>
+          <a:xfrm>
+            <a:off x="2331720" y="1920239"/>
+            <a:ext cx="5577840" cy="365760"/>
+          </a:xfrm>
+          <a:prstGeom prst="rect">
+            <a:avLst/>
+          </a:prstGeom>
+          <a:noFill/>
+        </p:spPr>
+        <p:txBody>
+          <a:bodyPr wrap="none">
+            <a:spAutoFit/>
+          </a:bodyPr>
+          <a:lstStyle/>
+          <a:p>
+            <a:pPr algn="l">
+              <a:spcAft>
+                <a:spcPts val="600"/>
+              </a:spcAft>
+            </a:pPr>
+            <a:r>
+              <a:rPr sz="1300" b="1">
+                <a:solidFill>
+                  <a:srgbClr val="17202A"/>
+                </a:solidFill>
+                <a:latin typeface="Calibri"/>
+              </a:rPr>
+              <a:t>/auth/me</a:t>
+            </a:r>
+          </a:p>
+        </p:txBody>
+      </p:sp>
+      <p:sp>
+        <p:nvSpPr>
+          <p:cNvPr id="14" name="TextBox 13"/>
+          <p:cNvSpPr txBox="1"/>
+          <p:nvPr/>
+        </p:nvSpPr>
+        <p:spPr>
+          <a:xfrm>
+            <a:off x="8092440" y="1929384"/>
+            <a:ext cx="3566160" cy="365760"/>
+          </a:xfrm>
+          <a:prstGeom prst="rect">
+            <a:avLst/>
+          </a:prstGeom>
+          <a:noFill/>
+        </p:spPr>
+        <p:txBody>
+          <a:bodyPr wrap="none">
+            <a:spAutoFit/>
+          </a:bodyPr>
+          <a:lstStyle/>
+          <a:p>
+            <a:pPr algn="l">
+              <a:spcAft>
+                <a:spcPts val="600"/>
+              </a:spcAft>
+            </a:pPr>
+            <a:r>
+              <a:rPr sz="1200" b="0">
+                <a:solidFill>
+                  <a:srgbClr val="52606D"/>
+                </a:solidFill>
+                <a:latin typeface="Calibri"/>
+              </a:rPr>
+              <a:t>Bearer</a:t>
+            </a:r>
+          </a:p>
+        </p:txBody>
+      </p:sp>
+      <p:sp>
+        <p:nvSpPr>
+          <p:cNvPr id="15" name="Rectangle 14"/>
+          <p:cNvSpPr/>
+          <p:nvPr/>
+        </p:nvSpPr>
+        <p:spPr>
+          <a:xfrm>
+            <a:off x="640080" y="2377439"/>
+            <a:ext cx="1554480" cy="420624"/>
+          </a:xfrm>
+          <a:prstGeom prst="rect">
+            <a:avLst/>
+          </a:prstGeom>
+          <a:solidFill>
+            <a:srgbClr val="155FA0"/>
+          </a:solidFill>
+          <a:ln>
+            <a:noFill/>
+          </a:ln>
+          <a:effectLst/>
+        </p:spPr>
+        <p:style>
+          <a:lnRef idx="1">
+            <a:schemeClr val="accent1"/>
+          </a:lnRef>
+          <a:fillRef idx="3">
+            <a:schemeClr val="accent1"/>
+          </a:fillRef>
+          <a:effectRef idx="2">
+            <a:schemeClr val="accent1"/>
+          </a:effectRef>
+          <a:fontRef idx="minor">
+            <a:schemeClr val="lt1"/>
+          </a:fontRef>
+        </p:style>
+        <p:txBody>
+          <a:bodyPr rtlCol="0" anchor="ctr"/>
+          <a:lstStyle/>
+          <a:p>
+            <a:pPr algn="ctr"/>
+          </a:p>
+        </p:txBody>
+      </p:sp>
+      <p:sp>
+        <p:nvSpPr>
+          <p:cNvPr id="16" name="TextBox 15"/>
+          <p:cNvSpPr txBox="1"/>
+          <p:nvPr/>
+        </p:nvSpPr>
+        <p:spPr>
+          <a:xfrm>
+            <a:off x="658368" y="2432303"/>
+            <a:ext cx="1517904" cy="310896"/>
+          </a:xfrm>
+          <a:prstGeom prst="rect">
+            <a:avLst/>
+          </a:prstGeom>
+          <a:noFill/>
+        </p:spPr>
+        <p:txBody>
+          <a:bodyPr wrap="none">
+            <a:spAutoFit/>
+          </a:bodyPr>
+          <a:lstStyle/>
+          <a:p>
+            <a:pPr algn="ctr">
+              <a:spcAft>
+                <a:spcPts val="600"/>
+              </a:spcAft>
+            </a:pPr>
+            <a:r>
+              <a:rPr sz="1100" b="1">
+                <a:solidFill>
+                  <a:srgbClr val="FFFFFF"/>
+                </a:solidFill>
+                <a:latin typeface="Calibri"/>
+              </a:rPr>
+              <a:t>GET</a:t>
+            </a:r>
+          </a:p>
+        </p:txBody>
+      </p:sp>
+      <p:sp>
+        <p:nvSpPr>
+          <p:cNvPr id="17" name="TextBox 16"/>
+          <p:cNvSpPr txBox="1"/>
+          <p:nvPr/>
+        </p:nvSpPr>
+        <p:spPr>
+          <a:xfrm>
+            <a:off x="2331720" y="2423159"/>
+            <a:ext cx="5577840" cy="365760"/>
+          </a:xfrm>
+          <a:prstGeom prst="rect">
+            <a:avLst/>
+          </a:prstGeom>
+          <a:noFill/>
+        </p:spPr>
+        <p:txBody>
+          <a:bodyPr wrap="none">
+            <a:spAutoFit/>
+          </a:bodyPr>
+          <a:lstStyle/>
+          <a:p>
+            <a:pPr algn="l">
+              <a:spcAft>
+                <a:spcPts val="600"/>
+              </a:spcAft>
+            </a:pPr>
+            <a:r>
+              <a:rPr sz="1300" b="1">
+                <a:solidFill>
+                  <a:srgbClr val="17202A"/>
+                </a:solidFill>
+                <a:latin typeface="Calibri"/>
+              </a:rPr>
+              <a:t>/keys/:contentId</a:t>
+            </a:r>
+          </a:p>
+        </p:txBody>
+      </p:sp>
+      <p:sp>
+        <p:nvSpPr>
+          <p:cNvPr id="18" name="TextBox 17"/>
+          <p:cNvSpPr txBox="1"/>
+          <p:nvPr/>
+        </p:nvSpPr>
+        <p:spPr>
+          <a:xfrm>
+            <a:off x="8092440" y="2432303"/>
+            <a:ext cx="3566160" cy="365760"/>
+          </a:xfrm>
+          <a:prstGeom prst="rect">
+            <a:avLst/>
+          </a:prstGeom>
+          <a:noFill/>
+        </p:spPr>
+        <p:txBody>
+          <a:bodyPr wrap="none">
+            <a:spAutoFit/>
+          </a:bodyPr>
+          <a:lstStyle/>
+          <a:p>
+            <a:pPr algn="l">
+              <a:spcAft>
+                <a:spcPts val="600"/>
+              </a:spcAft>
+            </a:pPr>
+            <a:r>
+              <a:rPr sz="1200" b="0">
+                <a:solidFill>
+                  <a:srgbClr val="52606D"/>
+                </a:solidFill>
+                <a:latin typeface="Calibri"/>
+              </a:rPr>
+              <a:t>Bearer + droits + non révoqué</a:t>
+            </a:r>
+          </a:p>
+        </p:txBody>
+      </p:sp>
+      <p:sp>
+        <p:nvSpPr>
+          <p:cNvPr id="19" name="Rectangle 18"/>
+          <p:cNvSpPr/>
+          <p:nvPr/>
+        </p:nvSpPr>
+        <p:spPr>
+          <a:xfrm>
+            <a:off x="640080" y="2880359"/>
+            <a:ext cx="1554480" cy="420624"/>
+          </a:xfrm>
+          <a:prstGeom prst="rect">
+            <a:avLst/>
+          </a:prstGeom>
+          <a:solidFill>
+            <a:srgbClr val="155FA0"/>
+          </a:solidFill>
+          <a:ln>
+            <a:noFill/>
+          </a:ln>
+          <a:effectLst/>
+        </p:spPr>
+        <p:style>
+          <a:lnRef idx="1">
+            <a:schemeClr val="accent1"/>
+          </a:lnRef>
+          <a:fillRef idx="3">
+            <a:schemeClr val="accent1"/>
+          </a:fillRef>
+          <a:effectRef idx="2">
+            <a:schemeClr val="accent1"/>
+          </a:effectRef>
+          <a:fontRef idx="minor">
+            <a:schemeClr val="lt1"/>
+          </a:fontRef>
+        </p:style>
+        <p:txBody>
+          <a:bodyPr rtlCol="0" anchor="ctr"/>
+          <a:lstStyle/>
+          <a:p>
+            <a:pPr algn="ctr"/>
+          </a:p>
+        </p:txBody>
+      </p:sp>
+      <p:sp>
+        <p:nvSpPr>
+          <p:cNvPr id="20" name="TextBox 19"/>
+          <p:cNvSpPr txBox="1"/>
+          <p:nvPr/>
+        </p:nvSpPr>
+        <p:spPr>
+          <a:xfrm>
+            <a:off x="658368" y="2935223"/>
+            <a:ext cx="1517904" cy="310896"/>
+          </a:xfrm>
+          <a:prstGeom prst="rect">
+            <a:avLst/>
+          </a:prstGeom>
+          <a:noFill/>
+        </p:spPr>
+        <p:txBody>
+          <a:bodyPr wrap="none">
+            <a:spAutoFit/>
+          </a:bodyPr>
+          <a:lstStyle/>
+          <a:p>
+            <a:pPr algn="ctr">
+              <a:spcAft>
+                <a:spcPts val="600"/>
+              </a:spcAft>
+            </a:pPr>
+            <a:r>
+              <a:rPr sz="1100" b="1">
+                <a:solidFill>
+                  <a:srgbClr val="FFFFFF"/>
+                </a:solidFill>
+                <a:latin typeface="Calibri"/>
+              </a:rPr>
+              <a:t>GET</a:t>
+            </a:r>
+          </a:p>
+        </p:txBody>
+      </p:sp>
+      <p:sp>
+        <p:nvSpPr>
+          <p:cNvPr id="21" name="TextBox 20"/>
+          <p:cNvSpPr txBox="1"/>
+          <p:nvPr/>
+        </p:nvSpPr>
+        <p:spPr>
+          <a:xfrm>
+            <a:off x="2331720" y="2926079"/>
+            <a:ext cx="5577840" cy="365760"/>
+          </a:xfrm>
+          <a:prstGeom prst="rect">
+            <a:avLst/>
+          </a:prstGeom>
+          <a:noFill/>
+        </p:spPr>
+        <p:txBody>
+          <a:bodyPr wrap="none">
+            <a:spAutoFit/>
+          </a:bodyPr>
+          <a:lstStyle/>
+          <a:p>
+            <a:pPr algn="l">
+              <a:spcAft>
+                <a:spcPts val="600"/>
+              </a:spcAft>
+            </a:pPr>
+            <a:r>
+              <a:rPr sz="1300" b="1">
+                <a:solidFill>
+                  <a:srgbClr val="17202A"/>
+                </a:solidFill>
+                <a:latin typeface="Calibri"/>
+              </a:rPr>
+              <a:t>/security/dashboard</a:t>
+            </a:r>
+          </a:p>
+        </p:txBody>
+      </p:sp>
+      <p:sp>
+        <p:nvSpPr>
+          <p:cNvPr id="22" name="TextBox 21"/>
+          <p:cNvSpPr txBox="1"/>
+          <p:nvPr/>
+        </p:nvSpPr>
+        <p:spPr>
+          <a:xfrm>
+            <a:off x="8092440" y="2935223"/>
+            <a:ext cx="3566160" cy="365760"/>
+          </a:xfrm>
+          <a:prstGeom prst="rect">
+            <a:avLst/>
+          </a:prstGeom>
+          <a:noFill/>
+        </p:spPr>
+        <p:txBody>
+          <a:bodyPr wrap="none">
+            <a:spAutoFit/>
+          </a:bodyPr>
+          <a:lstStyle/>
+          <a:p>
+            <a:pPr algn="l">
+              <a:spcAft>
+                <a:spcPts val="600"/>
+              </a:spcAft>
+            </a:pPr>
+            <a:r>
+              <a:rPr sz="1200" b="0">
+                <a:solidFill>
+                  <a:srgbClr val="52606D"/>
+                </a:solidFill>
+                <a:latin typeface="Calibri"/>
+              </a:rPr>
+              <a:t>Bearer admin</a:t>
+            </a:r>
+          </a:p>
+        </p:txBody>
+      </p:sp>
+      <p:sp>
+        <p:nvSpPr>
+          <p:cNvPr id="23" name="Rectangle 22"/>
+          <p:cNvSpPr/>
+          <p:nvPr/>
+        </p:nvSpPr>
+        <p:spPr>
+          <a:xfrm>
+            <a:off x="640080" y="3383279"/>
+            <a:ext cx="1554480" cy="420624"/>
+          </a:xfrm>
+          <a:prstGeom prst="rect">
+            <a:avLst/>
+          </a:prstGeom>
+          <a:solidFill>
+            <a:srgbClr val="155FA0"/>
+          </a:solidFill>
+          <a:ln>
+            <a:noFill/>
+          </a:ln>
+          <a:effectLst/>
+        </p:spPr>
+        <p:style>
+          <a:lnRef idx="1">
+            <a:schemeClr val="accent1"/>
+          </a:lnRef>
+          <a:fillRef idx="3">
+            <a:schemeClr val="accent1"/>
+          </a:fillRef>
+          <a:effectRef idx="2">
+            <a:schemeClr val="accent1"/>
+          </a:effectRef>
+          <a:fontRef idx="minor">
+            <a:schemeClr val="lt1"/>
+          </a:fontRef>
+        </p:style>
+        <p:txBody>
+          <a:bodyPr rtlCol="0" anchor="ctr"/>
+          <a:lstStyle/>
+          <a:p>
+            <a:pPr algn="ctr"/>
+          </a:p>
+        </p:txBody>
+      </p:sp>
+      <p:sp>
+        <p:nvSpPr>
+          <p:cNvPr id="24" name="TextBox 23"/>
+          <p:cNvSpPr txBox="1"/>
+          <p:nvPr/>
+        </p:nvSpPr>
+        <p:spPr>
+          <a:xfrm>
+            <a:off x="658368" y="3438143"/>
+            <a:ext cx="1517904" cy="310896"/>
+          </a:xfrm>
+          <a:prstGeom prst="rect">
+            <a:avLst/>
+          </a:prstGeom>
+          <a:noFill/>
+        </p:spPr>
+        <p:txBody>
+          <a:bodyPr wrap="none">
+            <a:spAutoFit/>
+          </a:bodyPr>
+          <a:lstStyle/>
+          <a:p>
+            <a:pPr algn="ctr">
+              <a:spcAft>
+                <a:spcPts val="600"/>
+              </a:spcAft>
+            </a:pPr>
+            <a:r>
+              <a:rPr sz="1100" b="1">
+                <a:solidFill>
+                  <a:srgbClr val="FFFFFF"/>
+                </a:solidFill>
+                <a:latin typeface="Calibri"/>
+              </a:rPr>
+              <a:t>GET</a:t>
+            </a:r>
+          </a:p>
+        </p:txBody>
+      </p:sp>
+      <p:sp>
+        <p:nvSpPr>
+          <p:cNvPr id="25" name="TextBox 24"/>
+          <p:cNvSpPr txBox="1"/>
+          <p:nvPr/>
+        </p:nvSpPr>
+        <p:spPr>
+          <a:xfrm>
+            <a:off x="2331720" y="3428999"/>
+            <a:ext cx="5577840" cy="365760"/>
+          </a:xfrm>
+          <a:prstGeom prst="rect">
+            <a:avLst/>
+          </a:prstGeom>
+          <a:noFill/>
+        </p:spPr>
+        <p:txBody>
+          <a:bodyPr wrap="none">
+            <a:spAutoFit/>
+          </a:bodyPr>
+          <a:lstStyle/>
+          <a:p>
+            <a:pPr algn="l">
+              <a:spcAft>
+                <a:spcPts val="600"/>
+              </a:spcAft>
+            </a:pPr>
+            <a:r>
+              <a:rPr sz="1300" b="1">
+                <a:solidFill>
+                  <a:srgbClr val="17202A"/>
+                </a:solidFill>
+                <a:latin typeface="Calibri"/>
+              </a:rPr>
+              <a:t>/security/watermark</a:t>
+            </a:r>
+          </a:p>
+        </p:txBody>
+      </p:sp>
+      <p:sp>
+        <p:nvSpPr>
+          <p:cNvPr id="26" name="TextBox 25"/>
+          <p:cNvSpPr txBox="1"/>
+          <p:nvPr/>
+        </p:nvSpPr>
+        <p:spPr>
+          <a:xfrm>
+            <a:off x="8092440" y="3438143"/>
+            <a:ext cx="3566160" cy="365760"/>
+          </a:xfrm>
+          <a:prstGeom prst="rect">
+            <a:avLst/>
+          </a:prstGeom>
+          <a:noFill/>
+        </p:spPr>
+        <p:txBody>
+          <a:bodyPr wrap="none">
+            <a:spAutoFit/>
+          </a:bodyPr>
+          <a:lstStyle/>
+          <a:p>
+            <a:pPr algn="l">
+              <a:spcAft>
+                <a:spcPts val="600"/>
+              </a:spcAft>
+            </a:pPr>
+            <a:r>
+              <a:rPr sz="1200" b="0">
+                <a:solidFill>
+                  <a:srgbClr val="52606D"/>
+                </a:solidFill>
+                <a:latin typeface="Calibri"/>
+              </a:rPr>
+              <a:t>Bearer</a:t>
+            </a:r>
+          </a:p>
+        </p:txBody>
+      </p:sp>
+      <p:sp>
+        <p:nvSpPr>
+          <p:cNvPr id="27" name="Rectangle 26"/>
+          <p:cNvSpPr/>
+          <p:nvPr/>
+        </p:nvSpPr>
+        <p:spPr>
+          <a:xfrm>
+            <a:off x="640080" y="3886199"/>
+            <a:ext cx="1554480" cy="420624"/>
+          </a:xfrm>
+          <a:prstGeom prst="rect">
+            <a:avLst/>
+          </a:prstGeom>
+          <a:solidFill>
+            <a:srgbClr val="155FA0"/>
+          </a:solidFill>
+          <a:ln>
+            <a:noFill/>
+          </a:ln>
+          <a:effectLst/>
+        </p:spPr>
+        <p:style>
+          <a:lnRef idx="1">
+            <a:schemeClr val="accent1"/>
+          </a:lnRef>
+          <a:fillRef idx="3">
+            <a:schemeClr val="accent1"/>
+          </a:fillRef>
+          <a:effectRef idx="2">
+            <a:schemeClr val="accent1"/>
+          </a:effectRef>
+          <a:fontRef idx="minor">
+            <a:schemeClr val="lt1"/>
+          </a:fontRef>
+        </p:style>
+        <p:txBody>
+          <a:bodyPr rtlCol="0" anchor="ctr"/>
+          <a:lstStyle/>
+          <a:p>
+            <a:pPr algn="ctr"/>
+          </a:p>
+        </p:txBody>
+      </p:sp>
+      <p:sp>
+        <p:nvSpPr>
+          <p:cNvPr id="28" name="TextBox 27"/>
+          <p:cNvSpPr txBox="1"/>
+          <p:nvPr/>
+        </p:nvSpPr>
+        <p:spPr>
+          <a:xfrm>
+            <a:off x="658368" y="3941063"/>
+            <a:ext cx="1517904" cy="310896"/>
+          </a:xfrm>
+          <a:prstGeom prst="rect">
+            <a:avLst/>
+          </a:prstGeom>
+          <a:noFill/>
+        </p:spPr>
+        <p:txBody>
+          <a:bodyPr wrap="none">
+            <a:spAutoFit/>
+          </a:bodyPr>
+          <a:lstStyle/>
+          <a:p>
+            <a:pPr algn="ctr">
+              <a:spcAft>
+                <a:spcPts val="600"/>
+              </a:spcAft>
+            </a:pPr>
+            <a:r>
+              <a:rPr sz="1100" b="1">
+                <a:solidFill>
+                  <a:srgbClr val="FFFFFF"/>
+                </a:solidFill>
+                <a:latin typeface="Calibri"/>
+              </a:rPr>
+              <a:t>ALL</a:t>
+            </a:r>
+          </a:p>
+        </p:txBody>
+      </p:sp>
+      <p:sp>
+        <p:nvSpPr>
+          <p:cNvPr id="29" name="TextBox 28"/>
+          <p:cNvSpPr txBox="1"/>
+          <p:nvPr/>
+        </p:nvSpPr>
+        <p:spPr>
+          <a:xfrm>
+            <a:off x="2331720" y="3931919"/>
+            <a:ext cx="5577840" cy="365760"/>
+          </a:xfrm>
+          <a:prstGeom prst="rect">
+            <a:avLst/>
+          </a:prstGeom>
+          <a:noFill/>
+        </p:spPr>
+        <p:txBody>
+          <a:bodyPr wrap="none">
+            <a:spAutoFit/>
+          </a:bodyPr>
+          <a:lstStyle/>
+          <a:p>
+            <a:pPr algn="l">
+              <a:spcAft>
+                <a:spcPts val="600"/>
+              </a:spcAft>
+            </a:pPr>
+            <a:r>
+              <a:rPr sz="1300" b="1">
+                <a:solidFill>
+                  <a:srgbClr val="17202A"/>
+                </a:solidFill>
+                <a:latin typeface="Calibri"/>
+              </a:rPr>
+              <a:t>/security/ingest</a:t>
+            </a:r>
+          </a:p>
+        </p:txBody>
+      </p:sp>
+      <p:sp>
+        <p:nvSpPr>
+          <p:cNvPr id="30" name="TextBox 29"/>
+          <p:cNvSpPr txBox="1"/>
+          <p:nvPr/>
+        </p:nvSpPr>
+        <p:spPr>
+          <a:xfrm>
+            <a:off x="8092440" y="3941063"/>
+            <a:ext cx="3566160" cy="365760"/>
+          </a:xfrm>
+          <a:prstGeom prst="rect">
+            <a:avLst/>
+          </a:prstGeom>
+          <a:noFill/>
+        </p:spPr>
+        <p:txBody>
+          <a:bodyPr wrap="none">
+            <a:spAutoFit/>
+          </a:bodyPr>
+          <a:lstStyle/>
+          <a:p>
+            <a:pPr algn="l">
+              <a:spcAft>
+                <a:spcPts val="600"/>
+              </a:spcAft>
+            </a:pPr>
+            <a:r>
+              <a:rPr sz="1200" b="0">
+                <a:solidFill>
+                  <a:srgbClr val="52606D"/>
+                </a:solidFill>
+                <a:latin typeface="Calibri"/>
+              </a:rPr>
+              <a:t>interne (nginx/loopback)</a:t>
+            </a:r>
+          </a:p>
+        </p:txBody>
+      </p:sp>
+      <p:sp>
+        <p:nvSpPr>
+          <p:cNvPr id="31" name="Rectangle 30"/>
+          <p:cNvSpPr/>
+          <p:nvPr/>
+        </p:nvSpPr>
+        <p:spPr>
+          <a:xfrm>
+            <a:off x="640080" y="4389119"/>
+            <a:ext cx="1554480" cy="420624"/>
+          </a:xfrm>
+          <a:prstGeom prst="rect">
+            <a:avLst/>
+          </a:prstGeom>
+          <a:solidFill>
+            <a:srgbClr val="155FA0"/>
+          </a:solidFill>
+          <a:ln>
+            <a:noFill/>
+          </a:ln>
+          <a:effectLst/>
+        </p:spPr>
+        <p:style>
+          <a:lnRef idx="1">
+            <a:schemeClr val="accent1"/>
+          </a:lnRef>
+          <a:fillRef idx="3">
+            <a:schemeClr val="accent1"/>
+          </a:fillRef>
+          <a:effectRef idx="2">
+            <a:schemeClr val="accent1"/>
+          </a:effectRef>
+          <a:fontRef idx="minor">
+            <a:schemeClr val="lt1"/>
+          </a:fontRef>
+        </p:style>
+        <p:txBody>
+          <a:bodyPr rtlCol="0" anchor="ctr"/>
+          <a:lstStyle/>
+          <a:p>
+            <a:pPr algn="ctr"/>
+          </a:p>
+        </p:txBody>
+      </p:sp>
+      <p:sp>
+        <p:nvSpPr>
+          <p:cNvPr id="32" name="TextBox 31"/>
+          <p:cNvSpPr txBox="1"/>
+          <p:nvPr/>
+        </p:nvSpPr>
+        <p:spPr>
+          <a:xfrm>
+            <a:off x="658368" y="4443983"/>
+            <a:ext cx="1517904" cy="310896"/>
+          </a:xfrm>
+          <a:prstGeom prst="rect">
+            <a:avLst/>
+          </a:prstGeom>
+          <a:noFill/>
+        </p:spPr>
+        <p:txBody>
+          <a:bodyPr wrap="none">
+            <a:spAutoFit/>
+          </a:bodyPr>
+          <a:lstStyle/>
+          <a:p>
+            <a:pPr algn="ctr">
+              <a:spcAft>
+                <a:spcPts val="600"/>
+              </a:spcAft>
+            </a:pPr>
+            <a:r>
+              <a:rPr sz="1100" b="1">
+                <a:solidFill>
+                  <a:srgbClr val="FFFFFF"/>
+                </a:solidFill>
+                <a:latin typeface="Calibri"/>
+              </a:rPr>
+              <a:t>GET</a:t>
+            </a:r>
+          </a:p>
+        </p:txBody>
+      </p:sp>
+      <p:sp>
+        <p:nvSpPr>
+          <p:cNvPr id="33" name="TextBox 32"/>
+          <p:cNvSpPr txBox="1"/>
+          <p:nvPr/>
+        </p:nvSpPr>
+        <p:spPr>
+          <a:xfrm>
+            <a:off x="2331720" y="4434839"/>
+            <a:ext cx="5577840" cy="365760"/>
+          </a:xfrm>
+          <a:prstGeom prst="rect">
+            <a:avLst/>
+          </a:prstGeom>
+          <a:noFill/>
+        </p:spPr>
+        <p:txBody>
+          <a:bodyPr wrap="none">
+            <a:spAutoFit/>
+          </a:bodyPr>
+          <a:lstStyle/>
+          <a:p>
+            <a:pPr algn="l">
+              <a:spcAft>
+                <a:spcPts val="600"/>
+              </a:spcAft>
+            </a:pPr>
+            <a:r>
+              <a:rPr sz="1300" b="1">
+                <a:solidFill>
+                  <a:srgbClr val="17202A"/>
+                </a:solidFill>
+                <a:latin typeface="Calibri"/>
+              </a:rPr>
+              <a:t>/admin/users</a:t>
+            </a:r>
+          </a:p>
+        </p:txBody>
+      </p:sp>
+      <p:sp>
+        <p:nvSpPr>
+          <p:cNvPr id="34" name="TextBox 33"/>
+          <p:cNvSpPr txBox="1"/>
+          <p:nvPr/>
+        </p:nvSpPr>
+        <p:spPr>
+          <a:xfrm>
+            <a:off x="8092440" y="4443983"/>
+            <a:ext cx="3566160" cy="365760"/>
+          </a:xfrm>
+          <a:prstGeom prst="rect">
+            <a:avLst/>
+          </a:prstGeom>
+          <a:noFill/>
+        </p:spPr>
+        <p:txBody>
+          <a:bodyPr wrap="none">
+            <a:spAutoFit/>
+          </a:bodyPr>
+          <a:lstStyle/>
+          <a:p>
+            <a:pPr algn="l">
+              <a:spcAft>
+                <a:spcPts val="600"/>
+              </a:spcAft>
+            </a:pPr>
+            <a:r>
+              <a:rPr sz="1200" b="0">
+                <a:solidFill>
+                  <a:srgbClr val="52606D"/>
+                </a:solidFill>
+                <a:latin typeface="Calibri"/>
+              </a:rPr>
+              <a:t>Bearer admin</a:t>
+            </a:r>
+          </a:p>
+        </p:txBody>
+      </p:sp>
+      <p:sp>
+        <p:nvSpPr>
+          <p:cNvPr id="35" name="Rectangle 34"/>
+          <p:cNvSpPr/>
+          <p:nvPr/>
+        </p:nvSpPr>
+        <p:spPr>
+          <a:xfrm>
+            <a:off x="640080" y="4892039"/>
+            <a:ext cx="1554480" cy="420624"/>
+          </a:xfrm>
+          <a:prstGeom prst="rect">
+            <a:avLst/>
+          </a:prstGeom>
+          <a:solidFill>
+            <a:srgbClr val="155FA0"/>
+          </a:solidFill>
+          <a:ln>
+            <a:noFill/>
+          </a:ln>
+          <a:effectLst/>
+        </p:spPr>
+        <p:style>
+          <a:lnRef idx="1">
+            <a:schemeClr val="accent1"/>
+          </a:lnRef>
+          <a:fillRef idx="3">
+            <a:schemeClr val="accent1"/>
+          </a:fillRef>
+          <a:effectRef idx="2">
+            <a:schemeClr val="accent1"/>
+          </a:effectRef>
+          <a:fontRef idx="minor">
+            <a:schemeClr val="lt1"/>
+          </a:fontRef>
+        </p:style>
+        <p:txBody>
+          <a:bodyPr rtlCol="0" anchor="ctr"/>
+          <a:lstStyle/>
+          <a:p>
+            <a:pPr algn="ctr"/>
+          </a:p>
+        </p:txBody>
+      </p:sp>
+      <p:sp>
+        <p:nvSpPr>
+          <p:cNvPr id="36" name="TextBox 35"/>
+          <p:cNvSpPr txBox="1"/>
+          <p:nvPr/>
+        </p:nvSpPr>
+        <p:spPr>
+          <a:xfrm>
+            <a:off x="658368" y="4946903"/>
+            <a:ext cx="1517904" cy="310896"/>
+          </a:xfrm>
+          <a:prstGeom prst="rect">
+            <a:avLst/>
+          </a:prstGeom>
+          <a:noFill/>
+        </p:spPr>
+        <p:txBody>
+          <a:bodyPr wrap="none">
+            <a:spAutoFit/>
+          </a:bodyPr>
+          <a:lstStyle/>
+          <a:p>
+            <a:pPr algn="ctr">
+              <a:spcAft>
+                <a:spcPts val="600"/>
+              </a:spcAft>
+            </a:pPr>
+            <a:r>
+              <a:rPr sz="1100" b="1">
+                <a:solidFill>
+                  <a:srgbClr val="FFFFFF"/>
+                </a:solidFill>
+                <a:latin typeface="Calibri"/>
+              </a:rPr>
+              <a:t>GET</a:t>
+            </a:r>
+          </a:p>
+        </p:txBody>
+      </p:sp>
+      <p:sp>
+        <p:nvSpPr>
+          <p:cNvPr id="37" name="TextBox 36"/>
+          <p:cNvSpPr txBox="1"/>
+          <p:nvPr/>
+        </p:nvSpPr>
+        <p:spPr>
+          <a:xfrm>
+            <a:off x="2331720" y="4937759"/>
+            <a:ext cx="5577840" cy="365760"/>
+          </a:xfrm>
+          <a:prstGeom prst="rect">
+            <a:avLst/>
+          </a:prstGeom>
+          <a:noFill/>
+        </p:spPr>
+        <p:txBody>
+          <a:bodyPr wrap="none">
+            <a:spAutoFit/>
+          </a:bodyPr>
+          <a:lstStyle/>
+          <a:p>
+            <a:pPr algn="l">
+              <a:spcAft>
+                <a:spcPts val="600"/>
+              </a:spcAft>
+            </a:pPr>
+            <a:r>
+              <a:rPr sz="1300" b="1">
+                <a:solidFill>
+                  <a:srgbClr val="17202A"/>
+                </a:solidFill>
+                <a:latin typeface="Calibri"/>
+              </a:rPr>
+              <a:t>/admin/contents</a:t>
+            </a:r>
+          </a:p>
+        </p:txBody>
+      </p:sp>
+      <p:sp>
+        <p:nvSpPr>
+          <p:cNvPr id="38" name="TextBox 37"/>
+          <p:cNvSpPr txBox="1"/>
+          <p:nvPr/>
+        </p:nvSpPr>
+        <p:spPr>
+          <a:xfrm>
+            <a:off x="8092440" y="4946903"/>
+            <a:ext cx="3566160" cy="365760"/>
+          </a:xfrm>
+          <a:prstGeom prst="rect">
+            <a:avLst/>
+          </a:prstGeom>
+          <a:noFill/>
+        </p:spPr>
+        <p:txBody>
+          <a:bodyPr wrap="none">
+            <a:spAutoFit/>
+          </a:bodyPr>
+          <a:lstStyle/>
+          <a:p>
+            <a:pPr algn="l">
+              <a:spcAft>
+                <a:spcPts val="600"/>
+              </a:spcAft>
+            </a:pPr>
+            <a:r>
+              <a:rPr sz="1200" b="0">
+                <a:solidFill>
+                  <a:srgbClr val="52606D"/>
+                </a:solidFill>
+                <a:latin typeface="Calibri"/>
+              </a:rPr>
+              <a:t>Bearer admin</a:t>
+            </a:r>
+          </a:p>
+        </p:txBody>
+      </p:sp>
+      <p:sp>
+        <p:nvSpPr>
+          <p:cNvPr id="39" name="Rectangle 38"/>
+          <p:cNvSpPr/>
+          <p:nvPr/>
+        </p:nvSpPr>
+        <p:spPr>
+          <a:xfrm>
+            <a:off x="640080" y="5394959"/>
+            <a:ext cx="1554480" cy="420624"/>
+          </a:xfrm>
+          <a:prstGeom prst="rect">
+            <a:avLst/>
+          </a:prstGeom>
+          <a:solidFill>
+            <a:srgbClr val="155FA0"/>
+          </a:solidFill>
+          <a:ln>
+            <a:noFill/>
+          </a:ln>
+          <a:effectLst/>
+        </p:spPr>
+        <p:style>
+          <a:lnRef idx="1">
+            <a:schemeClr val="accent1"/>
+          </a:lnRef>
+          <a:fillRef idx="3">
+            <a:schemeClr val="accent1"/>
+          </a:fillRef>
+          <a:effectRef idx="2">
+            <a:schemeClr val="accent1"/>
+          </a:effectRef>
+          <a:fontRef idx="minor">
+            <a:schemeClr val="lt1"/>
+          </a:fontRef>
+        </p:style>
+        <p:txBody>
+          <a:bodyPr rtlCol="0" anchor="ctr"/>
+          <a:lstStyle/>
+          <a:p>
+            <a:pPr algn="ctr"/>
+          </a:p>
+        </p:txBody>
+      </p:sp>
+      <p:sp>
+        <p:nvSpPr>
+          <p:cNvPr id="40" name="TextBox 39"/>
+          <p:cNvSpPr txBox="1"/>
+          <p:nvPr/>
+        </p:nvSpPr>
+        <p:spPr>
+          <a:xfrm>
+            <a:off x="658368" y="5449823"/>
+            <a:ext cx="1517904" cy="310896"/>
+          </a:xfrm>
+          <a:prstGeom prst="rect">
+            <a:avLst/>
+          </a:prstGeom>
+          <a:noFill/>
+        </p:spPr>
+        <p:txBody>
+          <a:bodyPr wrap="none">
+            <a:spAutoFit/>
+          </a:bodyPr>
+          <a:lstStyle/>
+          <a:p>
+            <a:pPr algn="ctr">
+              <a:spcAft>
+                <a:spcPts val="600"/>
+              </a:spcAft>
+            </a:pPr>
+            <a:r>
+              <a:rPr sz="1100" b="1">
+                <a:solidFill>
+                  <a:srgbClr val="FFFFFF"/>
+                </a:solidFill>
+                <a:latin typeface="Calibri"/>
+              </a:rPr>
+              <a:t>POST/DELETE</a:t>
+            </a:r>
+          </a:p>
+        </p:txBody>
+      </p:sp>
+      <p:sp>
+        <p:nvSpPr>
+          <p:cNvPr id="41" name="TextBox 40"/>
+          <p:cNvSpPr txBox="1"/>
+          <p:nvPr/>
+        </p:nvSpPr>
+        <p:spPr>
+          <a:xfrm>
+            <a:off x="2331720" y="5440679"/>
+            <a:ext cx="5577840" cy="365760"/>
+          </a:xfrm>
+          <a:prstGeom prst="rect">
+            <a:avLst/>
+          </a:prstGeom>
+          <a:noFill/>
+        </p:spPr>
+        <p:txBody>
+          <a:bodyPr wrap="none">
+            <a:spAutoFit/>
+          </a:bodyPr>
+          <a:lstStyle/>
+          <a:p>
+            <a:pPr algn="l">
+              <a:spcAft>
+                <a:spcPts val="600"/>
+              </a:spcAft>
+            </a:pPr>
+            <a:r>
+              <a:rPr sz="1300" b="1">
+                <a:solidFill>
+                  <a:srgbClr val="17202A"/>
+                </a:solidFill>
+                <a:latin typeface="Calibri"/>
+              </a:rPr>
+              <a:t>/admin/contents/:id/access</a:t>
+            </a:r>
+          </a:p>
+        </p:txBody>
+      </p:sp>
+      <p:sp>
+        <p:nvSpPr>
+          <p:cNvPr id="42" name="TextBox 41"/>
+          <p:cNvSpPr txBox="1"/>
+          <p:nvPr/>
+        </p:nvSpPr>
+        <p:spPr>
+          <a:xfrm>
+            <a:off x="8092440" y="5449823"/>
+            <a:ext cx="3566160" cy="365760"/>
+          </a:xfrm>
+          <a:prstGeom prst="rect">
+            <a:avLst/>
+          </a:prstGeom>
+          <a:noFill/>
+        </p:spPr>
+        <p:txBody>
+          <a:bodyPr wrap="none">
+            <a:spAutoFit/>
+          </a:bodyPr>
+          <a:lstStyle/>
+          <a:p>
+            <a:pPr algn="l">
+              <a:spcAft>
+                <a:spcPts val="600"/>
+              </a:spcAft>
+            </a:pPr>
+            <a:r>
+              <a:rPr sz="1200" b="0">
+                <a:solidFill>
+                  <a:srgbClr val="52606D"/>
+                </a:solidFill>
+                <a:latin typeface="Calibri"/>
+              </a:rPr>
+              <a:t>Bearer admin</a:t>
+            </a:r>
+          </a:p>
+        </p:txBody>
+      </p:sp>
+      <p:sp>
+        <p:nvSpPr>
+          <p:cNvPr id="43" name="Rectangle 42"/>
+          <p:cNvSpPr/>
+          <p:nvPr/>
+        </p:nvSpPr>
+        <p:spPr>
+          <a:xfrm>
+            <a:off x="640080" y="5897879"/>
+            <a:ext cx="1554480" cy="420624"/>
+          </a:xfrm>
+          <a:prstGeom prst="rect">
+            <a:avLst/>
+          </a:prstGeom>
+          <a:solidFill>
+            <a:srgbClr val="155FA0"/>
+          </a:solidFill>
+          <a:ln>
+            <a:noFill/>
+          </a:ln>
+          <a:effectLst/>
+        </p:spPr>
+        <p:style>
+          <a:lnRef idx="1">
+            <a:schemeClr val="accent1"/>
+          </a:lnRef>
+          <a:fillRef idx="3">
+            <a:schemeClr val="accent1"/>
+          </a:fillRef>
+          <a:effectRef idx="2">
+            <a:schemeClr val="accent1"/>
+          </a:effectRef>
+          <a:fontRef idx="minor">
+            <a:schemeClr val="lt1"/>
+          </a:fontRef>
+        </p:style>
+        <p:txBody>
+          <a:bodyPr rtlCol="0" anchor="ctr"/>
+          <a:lstStyle/>
+          <a:p>
+            <a:pPr algn="ctr"/>
+          </a:p>
+        </p:txBody>
+      </p:sp>
+      <p:sp>
+        <p:nvSpPr>
+          <p:cNvPr id="44" name="TextBox 43"/>
+          <p:cNvSpPr txBox="1"/>
+          <p:nvPr/>
+        </p:nvSpPr>
+        <p:spPr>
+          <a:xfrm>
+            <a:off x="658368" y="5952743"/>
+            <a:ext cx="1517904" cy="310896"/>
+          </a:xfrm>
+          <a:prstGeom prst="rect">
+            <a:avLst/>
+          </a:prstGeom>
+          <a:noFill/>
+        </p:spPr>
+        <p:txBody>
+          <a:bodyPr wrap="none">
+            <a:spAutoFit/>
+          </a:bodyPr>
+          <a:lstStyle/>
+          <a:p>
+            <a:pPr algn="ctr">
+              <a:spcAft>
+                <a:spcPts val="600"/>
+              </a:spcAft>
+            </a:pPr>
+            <a:r>
+              <a:rPr sz="1100" b="1">
+                <a:solidFill>
+                  <a:srgbClr val="FFFFFF"/>
+                </a:solidFill>
+                <a:latin typeface="Calibri"/>
+              </a:rPr>
+              <a:t>POST</a:t>
+            </a:r>
+          </a:p>
+        </p:txBody>
+      </p:sp>
+      <p:sp>
+        <p:nvSpPr>
+          <p:cNvPr id="45" name="TextBox 44"/>
+          <p:cNvSpPr txBox="1"/>
+          <p:nvPr/>
+        </p:nvSpPr>
+        <p:spPr>
+          <a:xfrm>
+            <a:off x="2331720" y="5943599"/>
+            <a:ext cx="5577840" cy="365760"/>
+          </a:xfrm>
+          <a:prstGeom prst="rect">
+            <a:avLst/>
+          </a:prstGeom>
+          <a:noFill/>
+        </p:spPr>
+        <p:txBody>
+          <a:bodyPr wrap="none">
+            <a:spAutoFit/>
+          </a:bodyPr>
+          <a:lstStyle/>
+          <a:p>
+            <a:pPr algn="l">
+              <a:spcAft>
+                <a:spcPts val="600"/>
+              </a:spcAft>
+            </a:pPr>
+            <a:r>
+              <a:rPr sz="1300" b="1">
+                <a:solidFill>
+                  <a:srgbClr val="17202A"/>
+                </a:solidFill>
+                <a:latin typeface="Calibri"/>
+              </a:rPr>
+              <a:t>/admin/contents/:id/revoke | restore</a:t>
+            </a:r>
+          </a:p>
+        </p:txBody>
+      </p:sp>
+      <p:sp>
+        <p:nvSpPr>
+          <p:cNvPr id="46" name="TextBox 45"/>
+          <p:cNvSpPr txBox="1"/>
+          <p:nvPr/>
+        </p:nvSpPr>
+        <p:spPr>
+          <a:xfrm>
+            <a:off x="8092440" y="5952743"/>
+            <a:ext cx="3566160" cy="365760"/>
+          </a:xfrm>
+          <a:prstGeom prst="rect">
+            <a:avLst/>
+          </a:prstGeom>
+          <a:noFill/>
+        </p:spPr>
+        <p:txBody>
+          <a:bodyPr wrap="none">
+            <a:spAutoFit/>
+          </a:bodyPr>
+          <a:lstStyle/>
+          <a:p>
+            <a:pPr algn="l">
+              <a:spcAft>
+                <a:spcPts val="600"/>
+              </a:spcAft>
+            </a:pPr>
+            <a:r>
+              <a:rPr sz="1200" b="0">
+                <a:solidFill>
+                  <a:srgbClr val="52606D"/>
+                </a:solidFill>
+                <a:latin typeface="Calibri"/>
+              </a:rPr>
+              <a:t>Bearer admin</a:t>
+            </a:r>
+          </a:p>
+        </p:txBody>
+      </p:sp>
+    </p:spTree>
+  </p:cSld>
+  <p:clrMapOvr>
+    <a:masterClrMapping/>
+  </p:clrMapOvr>
+</p:sld>
+</file>
+
+<file path=ppt/slides/slide16.xml><?xml version="1.0" encoding="utf-8"?>
+<p:sld xmlns:a="http://schemas.openxmlformats.org/drawingml/2006/main" xmlns:p="http://schemas.openxmlformats.org/presentationml/2006/main" xmlns:r="http://schemas.openxmlformats.org/officeDocument/2006/relationships">
+  <p:cSld>
+    <p:spTree>
+      <p:nvGrpSpPr>
+        <p:cNvPr id="1" name=""/>
+        <p:cNvGrpSpPr/>
+        <p:nvPr/>
+      </p:nvGrpSpPr>
+      <p:grpSpPr/>
+      <p:sp>
+        <p:nvSpPr>
+          <p:cNvPr id="2" name="Rectangle 1"/>
+          <p:cNvSpPr/>
+          <p:nvPr/>
+        </p:nvSpPr>
+        <p:spPr>
+          <a:xfrm>
+            <a:off x="-91440" y="-91440"/>
+            <a:ext cx="12435840" cy="7040880"/>
+          </a:xfrm>
+          <a:prstGeom prst="rect">
+            <a:avLst/>
+          </a:prstGeom>
+          <a:solidFill>
+            <a:srgbClr val="0B1F3A"/>
+          </a:solidFill>
+          <a:ln>
+            <a:noFill/>
+          </a:ln>
+          <a:effectLst/>
+        </p:spPr>
+        <p:style>
+          <a:lnRef idx="1">
+            <a:schemeClr val="accent1"/>
+          </a:lnRef>
+          <a:fillRef idx="3">
+            <a:schemeClr val="accent1"/>
+          </a:fillRef>
+          <a:effectRef idx="2">
+            <a:schemeClr val="accent1"/>
+          </a:effectRef>
+          <a:fontRef idx="minor">
+            <a:schemeClr val="lt1"/>
+          </a:fontRef>
+        </p:style>
+        <p:txBody>
+          <a:bodyPr rtlCol="0" anchor="ctr"/>
+          <a:lstStyle/>
+          <a:p>
+            <a:pPr algn="ctr"/>
+          </a:p>
+        </p:txBody>
+      </p:sp>
+      <p:sp>
+        <p:nvSpPr>
+          <p:cNvPr id="3" name="Rectangle 2"/>
+          <p:cNvSpPr/>
+          <p:nvPr/>
+        </p:nvSpPr>
+        <p:spPr>
+          <a:xfrm>
+            <a:off x="0" y="914400"/>
+            <a:ext cx="12191695" cy="73152"/>
+          </a:xfrm>
+          <a:prstGeom prst="rect">
+            <a:avLst/>
+          </a:prstGeom>
+          <a:solidFill>
+            <a:srgbClr val="2EC4B6"/>
+          </a:solidFill>
+          <a:ln>
+            <a:noFill/>
+          </a:ln>
+          <a:effectLst/>
+        </p:spPr>
+        <p:style>
+          <a:lnRef idx="1">
+            <a:schemeClr val="accent1"/>
+          </a:lnRef>
+          <a:fillRef idx="3">
+            <a:schemeClr val="accent1"/>
+          </a:fillRef>
+          <a:effectRef idx="2">
+            <a:schemeClr val="accent1"/>
+          </a:effectRef>
+          <a:fontRef idx="minor">
+            <a:schemeClr val="lt1"/>
+          </a:fontRef>
+        </p:style>
+        <p:txBody>
+          <a:bodyPr rtlCol="0" anchor="ctr"/>
+          <a:lstStyle/>
+          <a:p>
+            <a:pPr algn="ctr"/>
+          </a:p>
+        </p:txBody>
+      </p:sp>
+      <p:sp>
+        <p:nvSpPr>
+          <p:cNvPr id="4" name="TextBox 3"/>
+          <p:cNvSpPr txBox="1"/>
+          <p:nvPr/>
+        </p:nvSpPr>
+        <p:spPr>
+          <a:xfrm>
+            <a:off x="822960" y="365760"/>
+            <a:ext cx="10515600" cy="640080"/>
+          </a:xfrm>
+          <a:prstGeom prst="rect">
+            <a:avLst/>
+          </a:prstGeom>
+          <a:noFill/>
+        </p:spPr>
+        <p:txBody>
+          <a:bodyPr wrap="none">
+            <a:spAutoFit/>
+          </a:bodyPr>
+          <a:lstStyle/>
+          <a:p>
             <a:pPr algn="l">
               <a:spcAft>
                 <a:spcPts val="600"/>
@@ -5561,6 +7856,22 @@
                 </a:solidFill>
                 <a:latin typeface="Calibri"/>
               </a:rPr>
+              <a:t>✓  Back-office admin : ACL dynamique + révocation de clé en direct</a:t>
+            </a:r>
+          </a:p>
+          <a:p>
+            <a:pPr algn="l">
+              <a:spcAft>
+                <a:spcPts val="600"/>
+              </a:spcAft>
+            </a:pPr>
+            <a:r>
+              <a:rPr sz="1600" b="0">
+                <a:solidFill>
+                  <a:srgbClr val="FFFFFF"/>
+                </a:solidFill>
+                <a:latin typeface="Calibri"/>
+              </a:rPr>
               <a:t>✓  Plan d'intégration livré au front (P1)</a:t>
             </a:r>
           </a:p>
@@ -5609,7 +7920,7 @@
                 </a:solidFill>
                 <a:latin typeface="Calibri"/>
               </a:rPr>
-              <a:t>•  Rotation / révocation de clé en direct</a:t>
+              <a:t>•  Back-office React (UI) branché sur les endpoints /admin</a:t>
             </a:r>
           </a:p>
           <a:p>
@@ -5625,7 +7936,7 @@
                 </a:solidFill>
                 <a:latin typeface="Calibri"/>
               </a:rPr>
-              <a:t>•  Back-office admin (droits, contenus, sécurité)</a:t>
+              <a:t>•  Révocation par session / spectateur (pas seulement par contenu)</a:t>
             </a:r>
           </a:p>
           <a:p>
@@ -5641,7 +7952,7 @@
                 </a:solidFill>
                 <a:latin typeface="Calibri"/>
               </a:rPr>
-              <a:t>•  Watermark visible + branchement complet du lecteur</a:t>
+              <a:t>•  Watermark visible + branchement complet du lecteur (avec P1)</a:t>
             </a:r>
           </a:p>
         </p:txBody>

</xml_diff>

<commit_message>
docs(P2): présentation soutenance backend (18 slides, multi-tenant + invitation)
Co-Authored-By: Claude Opus 4.8 <noreply@anthropic.com>
</commit_message>
<xml_diff>
--- a/P2-Backend-Soutenance.pptx
+++ b/P2-Backend-Soutenance.pptx
@@ -21,6 +21,8 @@
     <p:sldId id="269" r:id="rId20"/>
     <p:sldId id="270" r:id="rId21"/>
     <p:sldId id="271" r:id="rId22"/>
+    <p:sldId id="272" r:id="rId23"/>
+    <p:sldId id="273" r:id="rId24"/>
   </p:sldIdLst>
   <p:sldSz cx="12191695" cy="6858000" type="screen4x3"/>
   <p:notesSz cx="6858000" cy="9144000"/>
@@ -5943,7 +5945,7 @@
                 </a:solidFill>
                 <a:latin typeface="Calibri"/>
               </a:rPr>
-              <a:t>Récap des routes backend</a:t>
+              <a:t>Multi-tenant — 3 niveaux d'accès</a:t>
             </a:r>
           </a:p>
         </p:txBody>
@@ -5982,7 +5984,7 @@
                 </a:solidFill>
                 <a:latin typeface="Calibri"/>
               </a:rPr>
-              <a:t>Surface d'API exposée par le Core</a:t>
+              <a:t>Isolation stricte par entreprise (tenant)</a:t>
             </a:r>
           </a:p>
         </p:txBody>
@@ -5995,8 +5997,107 @@
         </p:nvSpPr>
         <p:spPr>
           <a:xfrm>
-            <a:off x="640080" y="1371600"/>
-            <a:ext cx="1554480" cy="420624"/>
+            <a:off x="640080" y="1828800"/>
+            <a:ext cx="3383280" cy="1371600"/>
+          </a:xfrm>
+          <a:prstGeom prst="rect">
+            <a:avLst/>
+          </a:prstGeom>
+          <a:solidFill>
+            <a:srgbClr val="0B1F3A"/>
+          </a:solidFill>
+          <a:ln>
+            <a:noFill/>
+          </a:ln>
+          <a:effectLst/>
+        </p:spPr>
+        <p:style>
+          <a:lnRef idx="1">
+            <a:schemeClr val="accent1"/>
+          </a:lnRef>
+          <a:fillRef idx="3">
+            <a:schemeClr val="accent1"/>
+          </a:fillRef>
+          <a:effectRef idx="2">
+            <a:schemeClr val="accent1"/>
+          </a:effectRef>
+          <a:fontRef idx="minor">
+            <a:schemeClr val="lt1"/>
+          </a:fontRef>
+        </p:style>
+        <p:txBody>
+          <a:bodyPr rtlCol="0" anchor="ctr"/>
+          <a:lstStyle/>
+          <a:p>
+            <a:pPr algn="ctr"/>
+          </a:p>
+        </p:txBody>
+      </p:sp>
+      <p:sp>
+        <p:nvSpPr>
+          <p:cNvPr id="8" name="TextBox 7"/>
+          <p:cNvSpPr txBox="1"/>
+          <p:nvPr/>
+        </p:nvSpPr>
+        <p:spPr>
+          <a:xfrm>
+            <a:off x="777240" y="2011680"/>
+            <a:ext cx="3108960" cy="1051560"/>
+          </a:xfrm>
+          <a:prstGeom prst="rect">
+            <a:avLst/>
+          </a:prstGeom>
+          <a:noFill/>
+        </p:spPr>
+        <p:txBody>
+          <a:bodyPr wrap="square">
+            <a:spAutoFit/>
+          </a:bodyPr>
+          <a:lstStyle/>
+          <a:p>
+            <a:pPr algn="ctr">
+              <a:spcAft>
+                <a:spcPts val="600"/>
+              </a:spcAft>
+            </a:pPr>
+            <a:r>
+              <a:rPr sz="1500" b="1">
+                <a:solidFill>
+                  <a:srgbClr val="FFFFFF"/>
+                </a:solidFill>
+                <a:latin typeface="Calibri"/>
+              </a:rPr>
+              <a:t>SUPER-ADMIN</a:t>
+            </a:r>
+          </a:p>
+          <a:p>
+            <a:pPr algn="ctr">
+              <a:spcAft>
+                <a:spcPts val="600"/>
+              </a:spcAft>
+            </a:pPr>
+            <a:r>
+              <a:rPr sz="1100" b="0">
+                <a:solidFill>
+                  <a:srgbClr val="E6F0F5"/>
+                </a:solidFill>
+                <a:latin typeface="Calibri"/>
+              </a:rPr>
+              <a:t>crée les entreprises + invite leurs admins</a:t>
+            </a:r>
+          </a:p>
+        </p:txBody>
+      </p:sp>
+      <p:sp>
+        <p:nvSpPr>
+          <p:cNvPr id="9" name="Rectangle 8"/>
+          <p:cNvSpPr/>
+          <p:nvPr/>
+        </p:nvSpPr>
+        <p:spPr>
+          <a:xfrm>
+            <a:off x="4389120" y="1828800"/>
+            <a:ext cx="3383280" cy="1371600"/>
           </a:xfrm>
           <a:prstGeom prst="rect">
             <a:avLst/>
@@ -6033,14 +6134,14 @@
       </p:sp>
       <p:sp>
         <p:nvSpPr>
-          <p:cNvPr id="8" name="TextBox 7"/>
+          <p:cNvPr id="10" name="TextBox 9"/>
           <p:cNvSpPr txBox="1"/>
           <p:nvPr/>
         </p:nvSpPr>
         <p:spPr>
           <a:xfrm>
-            <a:off x="658368" y="1426464"/>
-            <a:ext cx="1517904" cy="310896"/>
+            <a:off x="4526280" y="2011680"/>
+            <a:ext cx="3108960" cy="1051560"/>
           </a:xfrm>
           <a:prstGeom prst="rect">
             <a:avLst/>
@@ -6048,7 +6149,7 @@
           <a:noFill/>
         </p:spPr>
         <p:txBody>
-          <a:bodyPr wrap="none">
+          <a:bodyPr wrap="square">
             <a:spAutoFit/>
           </a:bodyPr>
           <a:lstStyle/>
@@ -6059,91 +6160,29 @@
               </a:spcAft>
             </a:pPr>
             <a:r>
-              <a:rPr sz="1100" b="1">
+              <a:rPr sz="1500" b="1">
                 <a:solidFill>
                   <a:srgbClr val="FFFFFF"/>
                 </a:solidFill>
                 <a:latin typeface="Calibri"/>
               </a:rPr>
-              <a:t>POST</a:t>
-            </a:r>
-          </a:p>
-        </p:txBody>
-      </p:sp>
-      <p:sp>
-        <p:nvSpPr>
-          <p:cNvPr id="9" name="TextBox 8"/>
-          <p:cNvSpPr txBox="1"/>
-          <p:nvPr/>
-        </p:nvSpPr>
-        <p:spPr>
-          <a:xfrm>
-            <a:off x="2331720" y="1417320"/>
-            <a:ext cx="5577840" cy="365760"/>
-          </a:xfrm>
-          <a:prstGeom prst="rect">
-            <a:avLst/>
-          </a:prstGeom>
-          <a:noFill/>
-        </p:spPr>
-        <p:txBody>
-          <a:bodyPr wrap="none">
-            <a:spAutoFit/>
-          </a:bodyPr>
-          <a:lstStyle/>
-          <a:p>
-            <a:pPr algn="l">
+              <a:t>ADMIN d'entreprise</a:t>
+            </a:r>
+          </a:p>
+          <a:p>
+            <a:pPr algn="ctr">
               <a:spcAft>
                 <a:spcPts val="600"/>
               </a:spcAft>
             </a:pPr>
             <a:r>
-              <a:rPr sz="1300" b="1">
-                <a:solidFill>
-                  <a:srgbClr val="17202A"/>
-                </a:solidFill>
-                <a:latin typeface="Calibri"/>
-              </a:rPr>
-              <a:t>/auth/login</a:t>
-            </a:r>
-          </a:p>
-        </p:txBody>
-      </p:sp>
-      <p:sp>
-        <p:nvSpPr>
-          <p:cNvPr id="10" name="TextBox 9"/>
-          <p:cNvSpPr txBox="1"/>
-          <p:nvPr/>
-        </p:nvSpPr>
-        <p:spPr>
-          <a:xfrm>
-            <a:off x="8092440" y="1426464"/>
-            <a:ext cx="3566160" cy="365760"/>
-          </a:xfrm>
-          <a:prstGeom prst="rect">
-            <a:avLst/>
-          </a:prstGeom>
-          <a:noFill/>
-        </p:spPr>
-        <p:txBody>
-          <a:bodyPr wrap="none">
-            <a:spAutoFit/>
-          </a:bodyPr>
-          <a:lstStyle/>
-          <a:p>
-            <a:pPr algn="l">
-              <a:spcAft>
-                <a:spcPts val="600"/>
-              </a:spcAft>
-            </a:pPr>
-            <a:r>
-              <a:rPr sz="1200" b="0">
-                <a:solidFill>
-                  <a:srgbClr val="52606D"/>
-                </a:solidFill>
-                <a:latin typeface="Calibri"/>
-              </a:rPr>
-              <a:t>public (10/min + lockout)</a:t>
+              <a:rPr sz="1100" b="0">
+                <a:solidFill>
+                  <a:srgbClr val="E6F0F5"/>
+                </a:solidFill>
+                <a:latin typeface="Calibri"/>
+              </a:rPr>
+              <a:t>crée ses users · gère contenus &amp; droits</a:t>
             </a:r>
           </a:p>
         </p:txBody>
@@ -6156,14 +6195,14 @@
         </p:nvSpPr>
         <p:spPr>
           <a:xfrm>
-            <a:off x="640080" y="1874519"/>
-            <a:ext cx="1554480" cy="420624"/>
+            <a:off x="8183879" y="1828800"/>
+            <a:ext cx="3383280" cy="1371600"/>
           </a:xfrm>
           <a:prstGeom prst="rect">
             <a:avLst/>
           </a:prstGeom>
           <a:solidFill>
-            <a:srgbClr val="155FA0"/>
+            <a:srgbClr val="52606D"/>
           </a:solidFill>
           <a:ln>
             <a:noFill/>
@@ -6200,8 +6239,8 @@
         </p:nvSpPr>
         <p:spPr>
           <a:xfrm>
-            <a:off x="658368" y="1929384"/>
-            <a:ext cx="1517904" cy="310896"/>
+            <a:off x="8321040" y="2011680"/>
+            <a:ext cx="3108960" cy="1051560"/>
           </a:xfrm>
           <a:prstGeom prst="rect">
             <a:avLst/>
@@ -6209,7 +6248,7 @@
           <a:noFill/>
         </p:spPr>
         <p:txBody>
-          <a:bodyPr wrap="none">
+          <a:bodyPr wrap="square">
             <a:spAutoFit/>
           </a:bodyPr>
           <a:lstStyle/>
@@ -6220,13 +6259,29 @@
               </a:spcAft>
             </a:pPr>
             <a:r>
-              <a:rPr sz="1100" b="1">
+              <a:rPr sz="1500" b="1">
                 <a:solidFill>
                   <a:srgbClr val="FFFFFF"/>
                 </a:solidFill>
                 <a:latin typeface="Calibri"/>
               </a:rPr>
-              <a:t>GET</a:t>
+              <a:t>USER</a:t>
+            </a:r>
+          </a:p>
+          <a:p>
+            <a:pPr algn="ctr">
+              <a:spcAft>
+                <a:spcPts val="600"/>
+              </a:spcAft>
+            </a:pPr>
+            <a:r>
+              <a:rPr sz="1100" b="0">
+                <a:solidFill>
+                  <a:srgbClr val="E6F0F5"/>
+                </a:solidFill>
+                <a:latin typeface="Calibri"/>
+              </a:rPr>
+              <a:t>accède aux contenus autorisés</a:t>
             </a:r>
           </a:p>
         </p:txBody>
@@ -6239,8 +6294,8 @@
         </p:nvSpPr>
         <p:spPr>
           <a:xfrm>
-            <a:off x="2331720" y="1920239"/>
-            <a:ext cx="5577840" cy="365760"/>
+            <a:off x="640080" y="3566160"/>
+            <a:ext cx="10972800" cy="5029200"/>
           </a:xfrm>
           <a:prstGeom prst="rect">
             <a:avLst/>
@@ -6248,1351 +6303,110 @@
           <a:noFill/>
         </p:spPr>
         <p:txBody>
-          <a:bodyPr wrap="none">
+          <a:bodyPr wrap="square">
             <a:spAutoFit/>
           </a:bodyPr>
           <a:lstStyle/>
           <a:p>
             <a:pPr algn="l">
               <a:spcAft>
-                <a:spcPts val="600"/>
-              </a:spcAft>
-            </a:pPr>
-            <a:r>
-              <a:rPr sz="1300" b="1">
+                <a:spcPts val="1000"/>
+              </a:spcAft>
+            </a:pPr>
+            <a:r>
+              <a:rPr sz="1600" b="1">
+                <a:solidFill>
+                  <a:srgbClr val="2EC4B6"/>
+                </a:solidFill>
+                <a:latin typeface="Calibri"/>
+              </a:rPr>
+              <a:t>▸  </a:t>
+            </a:r>
+            <a:r>
+              <a:rPr sz="1600" b="1">
                 <a:solidFill>
                   <a:srgbClr val="17202A"/>
                 </a:solidFill>
                 <a:latin typeface="Calibri"/>
               </a:rPr>
-              <a:t>/auth/me</a:t>
-            </a:r>
-          </a:p>
-        </p:txBody>
-      </p:sp>
-      <p:sp>
-        <p:nvSpPr>
-          <p:cNvPr id="14" name="TextBox 13"/>
-          <p:cNvSpPr txBox="1"/>
-          <p:nvPr/>
-        </p:nvSpPr>
-        <p:spPr>
-          <a:xfrm>
-            <a:off x="8092440" y="1929384"/>
-            <a:ext cx="3566160" cy="365760"/>
-          </a:xfrm>
-          <a:prstGeom prst="rect">
-            <a:avLst/>
-          </a:prstGeom>
-          <a:noFill/>
-        </p:spPr>
-        <p:txBody>
-          <a:bodyPr wrap="none">
-            <a:spAutoFit/>
-          </a:bodyPr>
-          <a:lstStyle/>
-          <a:p>
-            <a:pPr algn="l">
-              <a:spcAft>
-                <a:spcPts val="600"/>
-              </a:spcAft>
-            </a:pPr>
-            <a:r>
-              <a:rPr sz="1200" b="0">
+              <a:t>JWT enrichi</a:t>
+            </a:r>
+            <a:r>
+              <a:rPr sz="1600" b="0">
                 <a:solidFill>
                   <a:srgbClr val="52606D"/>
                 </a:solidFill>
                 <a:latin typeface="Calibri"/>
               </a:rPr>
-              <a:t>Bearer</a:t>
-            </a:r>
-          </a:p>
-        </p:txBody>
-      </p:sp>
-      <p:sp>
-        <p:nvSpPr>
-          <p:cNvPr id="15" name="Rectangle 14"/>
-          <p:cNvSpPr/>
-          <p:nvPr/>
-        </p:nvSpPr>
-        <p:spPr>
-          <a:xfrm>
-            <a:off x="640080" y="2377439"/>
-            <a:ext cx="1554480" cy="420624"/>
-          </a:xfrm>
-          <a:prstGeom prst="rect">
-            <a:avLst/>
-          </a:prstGeom>
-          <a:solidFill>
-            <a:srgbClr val="155FA0"/>
-          </a:solidFill>
-          <a:ln>
-            <a:noFill/>
-          </a:ln>
-          <a:effectLst/>
-        </p:spPr>
-        <p:style>
-          <a:lnRef idx="1">
-            <a:schemeClr val="accent1"/>
-          </a:lnRef>
-          <a:fillRef idx="3">
-            <a:schemeClr val="accent1"/>
-          </a:fillRef>
-          <a:effectRef idx="2">
-            <a:schemeClr val="accent1"/>
-          </a:effectRef>
-          <a:fontRef idx="minor">
-            <a:schemeClr val="lt1"/>
-          </a:fontRef>
-        </p:style>
-        <p:txBody>
-          <a:bodyPr rtlCol="0" anchor="ctr"/>
-          <a:lstStyle/>
-          <a:p>
-            <a:pPr algn="ctr"/>
-          </a:p>
-        </p:txBody>
-      </p:sp>
-      <p:sp>
-        <p:nvSpPr>
-          <p:cNvPr id="16" name="TextBox 15"/>
-          <p:cNvSpPr txBox="1"/>
-          <p:nvPr/>
-        </p:nvSpPr>
-        <p:spPr>
-          <a:xfrm>
-            <a:off x="658368" y="2432303"/>
-            <a:ext cx="1517904" cy="310896"/>
-          </a:xfrm>
-          <a:prstGeom prst="rect">
-            <a:avLst/>
-          </a:prstGeom>
-          <a:noFill/>
-        </p:spPr>
-        <p:txBody>
-          <a:bodyPr wrap="none">
-            <a:spAutoFit/>
-          </a:bodyPr>
-          <a:lstStyle/>
-          <a:p>
-            <a:pPr algn="ctr">
-              <a:spcAft>
-                <a:spcPts val="600"/>
-              </a:spcAft>
-            </a:pPr>
-            <a:r>
-              <a:rPr sz="1100" b="1">
-                <a:solidFill>
-                  <a:srgbClr val="FFFFFF"/>
-                </a:solidFill>
-                <a:latin typeface="Calibri"/>
-              </a:rPr>
-              <a:t>GET</a:t>
-            </a:r>
-          </a:p>
-        </p:txBody>
-      </p:sp>
-      <p:sp>
-        <p:nvSpPr>
-          <p:cNvPr id="17" name="TextBox 16"/>
-          <p:cNvSpPr txBox="1"/>
-          <p:nvPr/>
-        </p:nvSpPr>
-        <p:spPr>
-          <a:xfrm>
-            <a:off x="2331720" y="2423159"/>
-            <a:ext cx="5577840" cy="365760"/>
-          </a:xfrm>
-          <a:prstGeom prst="rect">
-            <a:avLst/>
-          </a:prstGeom>
-          <a:noFill/>
-        </p:spPr>
-        <p:txBody>
-          <a:bodyPr wrap="none">
-            <a:spAutoFit/>
-          </a:bodyPr>
-          <a:lstStyle/>
-          <a:p>
-            <a:pPr algn="l">
-              <a:spcAft>
-                <a:spcPts val="600"/>
-              </a:spcAft>
-            </a:pPr>
-            <a:r>
-              <a:rPr sz="1300" b="1">
+              <a:t> — role + companyId portés dans le token</a:t>
+            </a:r>
+          </a:p>
+          <a:p>
+            <a:pPr algn="l">
+              <a:spcAft>
+                <a:spcPts val="1000"/>
+              </a:spcAft>
+            </a:pPr>
+            <a:r>
+              <a:rPr sz="1600" b="1">
+                <a:solidFill>
+                  <a:srgbClr val="2EC4B6"/>
+                </a:solidFill>
+                <a:latin typeface="Calibri"/>
+              </a:rPr>
+              <a:t>▸  </a:t>
+            </a:r>
+            <a:r>
+              <a:rPr sz="1600" b="1">
                 <a:solidFill>
                   <a:srgbClr val="17202A"/>
                 </a:solidFill>
                 <a:latin typeface="Calibri"/>
               </a:rPr>
-              <a:t>/keys/:contentId</a:t>
-            </a:r>
-          </a:p>
-        </p:txBody>
-      </p:sp>
-      <p:sp>
-        <p:nvSpPr>
-          <p:cNvPr id="18" name="TextBox 17"/>
-          <p:cNvSpPr txBox="1"/>
-          <p:nvPr/>
-        </p:nvSpPr>
-        <p:spPr>
-          <a:xfrm>
-            <a:off x="8092440" y="2432303"/>
-            <a:ext cx="3566160" cy="365760"/>
-          </a:xfrm>
-          <a:prstGeom prst="rect">
-            <a:avLst/>
-          </a:prstGeom>
-          <a:noFill/>
-        </p:spPr>
-        <p:txBody>
-          <a:bodyPr wrap="none">
-            <a:spAutoFit/>
-          </a:bodyPr>
-          <a:lstStyle/>
-          <a:p>
-            <a:pPr algn="l">
-              <a:spcAft>
-                <a:spcPts val="600"/>
-              </a:spcAft>
-            </a:pPr>
-            <a:r>
-              <a:rPr sz="1200" b="0">
+              <a:t>Isolation</a:t>
+            </a:r>
+            <a:r>
+              <a:rPr sz="1600" b="0">
                 <a:solidFill>
                   <a:srgbClr val="52606D"/>
                 </a:solidFill>
                 <a:latin typeface="Calibri"/>
               </a:rPr>
-              <a:t>Bearer + droits + non révoqué</a:t>
-            </a:r>
-          </a:p>
-        </p:txBody>
-      </p:sp>
-      <p:sp>
-        <p:nvSpPr>
-          <p:cNvPr id="19" name="Rectangle 18"/>
-          <p:cNvSpPr/>
-          <p:nvPr/>
-        </p:nvSpPr>
-        <p:spPr>
-          <a:xfrm>
-            <a:off x="640080" y="2880359"/>
-            <a:ext cx="1554480" cy="420624"/>
-          </a:xfrm>
-          <a:prstGeom prst="rect">
-            <a:avLst/>
-          </a:prstGeom>
-          <a:solidFill>
-            <a:srgbClr val="155FA0"/>
-          </a:solidFill>
-          <a:ln>
-            <a:noFill/>
-          </a:ln>
-          <a:effectLst/>
-        </p:spPr>
-        <p:style>
-          <a:lnRef idx="1">
-            <a:schemeClr val="accent1"/>
-          </a:lnRef>
-          <a:fillRef idx="3">
-            <a:schemeClr val="accent1"/>
-          </a:fillRef>
-          <a:effectRef idx="2">
-            <a:schemeClr val="accent1"/>
-          </a:effectRef>
-          <a:fontRef idx="minor">
-            <a:schemeClr val="lt1"/>
-          </a:fontRef>
-        </p:style>
-        <p:txBody>
-          <a:bodyPr rtlCol="0" anchor="ctr"/>
-          <a:lstStyle/>
-          <a:p>
-            <a:pPr algn="ctr"/>
-          </a:p>
-        </p:txBody>
-      </p:sp>
-      <p:sp>
-        <p:nvSpPr>
-          <p:cNvPr id="20" name="TextBox 19"/>
-          <p:cNvSpPr txBox="1"/>
-          <p:nvPr/>
-        </p:nvSpPr>
-        <p:spPr>
-          <a:xfrm>
-            <a:off x="658368" y="2935223"/>
-            <a:ext cx="1517904" cy="310896"/>
-          </a:xfrm>
-          <a:prstGeom prst="rect">
-            <a:avLst/>
-          </a:prstGeom>
-          <a:noFill/>
-        </p:spPr>
-        <p:txBody>
-          <a:bodyPr wrap="none">
-            <a:spAutoFit/>
-          </a:bodyPr>
-          <a:lstStyle/>
-          <a:p>
-            <a:pPr algn="ctr">
-              <a:spcAft>
-                <a:spcPts val="600"/>
-              </a:spcAft>
-            </a:pPr>
-            <a:r>
-              <a:rPr sz="1100" b="1">
-                <a:solidFill>
-                  <a:srgbClr val="FFFFFF"/>
-                </a:solidFill>
-                <a:latin typeface="Calibri"/>
-              </a:rPr>
-              <a:t>GET</a:t>
-            </a:r>
-          </a:p>
-        </p:txBody>
-      </p:sp>
-      <p:sp>
-        <p:nvSpPr>
-          <p:cNvPr id="21" name="TextBox 20"/>
-          <p:cNvSpPr txBox="1"/>
-          <p:nvPr/>
-        </p:nvSpPr>
-        <p:spPr>
-          <a:xfrm>
-            <a:off x="2331720" y="2926079"/>
-            <a:ext cx="5577840" cy="365760"/>
-          </a:xfrm>
-          <a:prstGeom prst="rect">
-            <a:avLst/>
-          </a:prstGeom>
-          <a:noFill/>
-        </p:spPr>
-        <p:txBody>
-          <a:bodyPr wrap="none">
-            <a:spAutoFit/>
-          </a:bodyPr>
-          <a:lstStyle/>
-          <a:p>
-            <a:pPr algn="l">
-              <a:spcAft>
-                <a:spcPts val="600"/>
-              </a:spcAft>
-            </a:pPr>
-            <a:r>
-              <a:rPr sz="1300" b="1">
+              <a:t> — un admin/user ne voit que SA companyId (cross-tenant → 404)</a:t>
+            </a:r>
+          </a:p>
+          <a:p>
+            <a:pPr algn="l">
+              <a:spcAft>
+                <a:spcPts val="1000"/>
+              </a:spcAft>
+            </a:pPr>
+            <a:r>
+              <a:rPr sz="1600" b="1">
+                <a:solidFill>
+                  <a:srgbClr val="2EC4B6"/>
+                </a:solidFill>
+                <a:latin typeface="Calibri"/>
+              </a:rPr>
+              <a:t>▸  </a:t>
+            </a:r>
+            <a:r>
+              <a:rPr sz="1600" b="1">
                 <a:solidFill>
                   <a:srgbClr val="17202A"/>
                 </a:solidFill>
                 <a:latin typeface="Calibri"/>
               </a:rPr>
-              <a:t>/security/dashboard</a:t>
-            </a:r>
-          </a:p>
-        </p:txBody>
-      </p:sp>
-      <p:sp>
-        <p:nvSpPr>
-          <p:cNvPr id="22" name="TextBox 21"/>
-          <p:cNvSpPr txBox="1"/>
-          <p:nvPr/>
-        </p:nvSpPr>
-        <p:spPr>
-          <a:xfrm>
-            <a:off x="8092440" y="2935223"/>
-            <a:ext cx="3566160" cy="365760"/>
-          </a:xfrm>
-          <a:prstGeom prst="rect">
-            <a:avLst/>
-          </a:prstGeom>
-          <a:noFill/>
-        </p:spPr>
-        <p:txBody>
-          <a:bodyPr wrap="none">
-            <a:spAutoFit/>
-          </a:bodyPr>
-          <a:lstStyle/>
-          <a:p>
-            <a:pPr algn="l">
-              <a:spcAft>
-                <a:spcPts val="600"/>
-              </a:spcAft>
-            </a:pPr>
-            <a:r>
-              <a:rPr sz="1200" b="0">
+              <a:t>Révocation de clé</a:t>
+            </a:r>
+            <a:r>
+              <a:rPr sz="1600" b="0">
                 <a:solidFill>
                   <a:srgbClr val="52606D"/>
                 </a:solidFill>
                 <a:latin typeface="Calibri"/>
               </a:rPr>
-              <a:t>Bearer admin</a:t>
-            </a:r>
-          </a:p>
-        </p:txBody>
-      </p:sp>
-      <p:sp>
-        <p:nvSpPr>
-          <p:cNvPr id="23" name="Rectangle 22"/>
-          <p:cNvSpPr/>
-          <p:nvPr/>
-        </p:nvSpPr>
-        <p:spPr>
-          <a:xfrm>
-            <a:off x="640080" y="3383279"/>
-            <a:ext cx="1554480" cy="420624"/>
-          </a:xfrm>
-          <a:prstGeom prst="rect">
-            <a:avLst/>
-          </a:prstGeom>
-          <a:solidFill>
-            <a:srgbClr val="155FA0"/>
-          </a:solidFill>
-          <a:ln>
-            <a:noFill/>
-          </a:ln>
-          <a:effectLst/>
-        </p:spPr>
-        <p:style>
-          <a:lnRef idx="1">
-            <a:schemeClr val="accent1"/>
-          </a:lnRef>
-          <a:fillRef idx="3">
-            <a:schemeClr val="accent1"/>
-          </a:fillRef>
-          <a:effectRef idx="2">
-            <a:schemeClr val="accent1"/>
-          </a:effectRef>
-          <a:fontRef idx="minor">
-            <a:schemeClr val="lt1"/>
-          </a:fontRef>
-        </p:style>
-        <p:txBody>
-          <a:bodyPr rtlCol="0" anchor="ctr"/>
-          <a:lstStyle/>
-          <a:p>
-            <a:pPr algn="ctr"/>
-          </a:p>
-        </p:txBody>
-      </p:sp>
-      <p:sp>
-        <p:nvSpPr>
-          <p:cNvPr id="24" name="TextBox 23"/>
-          <p:cNvSpPr txBox="1"/>
-          <p:nvPr/>
-        </p:nvSpPr>
-        <p:spPr>
-          <a:xfrm>
-            <a:off x="658368" y="3438143"/>
-            <a:ext cx="1517904" cy="310896"/>
-          </a:xfrm>
-          <a:prstGeom prst="rect">
-            <a:avLst/>
-          </a:prstGeom>
-          <a:noFill/>
-        </p:spPr>
-        <p:txBody>
-          <a:bodyPr wrap="none">
-            <a:spAutoFit/>
-          </a:bodyPr>
-          <a:lstStyle/>
-          <a:p>
-            <a:pPr algn="ctr">
-              <a:spcAft>
-                <a:spcPts val="600"/>
-              </a:spcAft>
-            </a:pPr>
-            <a:r>
-              <a:rPr sz="1100" b="1">
-                <a:solidFill>
-                  <a:srgbClr val="FFFFFF"/>
-                </a:solidFill>
-                <a:latin typeface="Calibri"/>
-              </a:rPr>
-              <a:t>GET</a:t>
-            </a:r>
-          </a:p>
-        </p:txBody>
-      </p:sp>
-      <p:sp>
-        <p:nvSpPr>
-          <p:cNvPr id="25" name="TextBox 24"/>
-          <p:cNvSpPr txBox="1"/>
-          <p:nvPr/>
-        </p:nvSpPr>
-        <p:spPr>
-          <a:xfrm>
-            <a:off x="2331720" y="3428999"/>
-            <a:ext cx="5577840" cy="365760"/>
-          </a:xfrm>
-          <a:prstGeom prst="rect">
-            <a:avLst/>
-          </a:prstGeom>
-          <a:noFill/>
-        </p:spPr>
-        <p:txBody>
-          <a:bodyPr wrap="none">
-            <a:spAutoFit/>
-          </a:bodyPr>
-          <a:lstStyle/>
-          <a:p>
-            <a:pPr algn="l">
-              <a:spcAft>
-                <a:spcPts val="600"/>
-              </a:spcAft>
-            </a:pPr>
-            <a:r>
-              <a:rPr sz="1300" b="1">
-                <a:solidFill>
-                  <a:srgbClr val="17202A"/>
-                </a:solidFill>
-                <a:latin typeface="Calibri"/>
-              </a:rPr>
-              <a:t>/security/watermark</a:t>
-            </a:r>
-          </a:p>
-        </p:txBody>
-      </p:sp>
-      <p:sp>
-        <p:nvSpPr>
-          <p:cNvPr id="26" name="TextBox 25"/>
-          <p:cNvSpPr txBox="1"/>
-          <p:nvPr/>
-        </p:nvSpPr>
-        <p:spPr>
-          <a:xfrm>
-            <a:off x="8092440" y="3438143"/>
-            <a:ext cx="3566160" cy="365760"/>
-          </a:xfrm>
-          <a:prstGeom prst="rect">
-            <a:avLst/>
-          </a:prstGeom>
-          <a:noFill/>
-        </p:spPr>
-        <p:txBody>
-          <a:bodyPr wrap="none">
-            <a:spAutoFit/>
-          </a:bodyPr>
-          <a:lstStyle/>
-          <a:p>
-            <a:pPr algn="l">
-              <a:spcAft>
-                <a:spcPts val="600"/>
-              </a:spcAft>
-            </a:pPr>
-            <a:r>
-              <a:rPr sz="1200" b="0">
-                <a:solidFill>
-                  <a:srgbClr val="52606D"/>
-                </a:solidFill>
-                <a:latin typeface="Calibri"/>
-              </a:rPr>
-              <a:t>Bearer</a:t>
-            </a:r>
-          </a:p>
-        </p:txBody>
-      </p:sp>
-      <p:sp>
-        <p:nvSpPr>
-          <p:cNvPr id="27" name="Rectangle 26"/>
-          <p:cNvSpPr/>
-          <p:nvPr/>
-        </p:nvSpPr>
-        <p:spPr>
-          <a:xfrm>
-            <a:off x="640080" y="3886199"/>
-            <a:ext cx="1554480" cy="420624"/>
-          </a:xfrm>
-          <a:prstGeom prst="rect">
-            <a:avLst/>
-          </a:prstGeom>
-          <a:solidFill>
-            <a:srgbClr val="155FA0"/>
-          </a:solidFill>
-          <a:ln>
-            <a:noFill/>
-          </a:ln>
-          <a:effectLst/>
-        </p:spPr>
-        <p:style>
-          <a:lnRef idx="1">
-            <a:schemeClr val="accent1"/>
-          </a:lnRef>
-          <a:fillRef idx="3">
-            <a:schemeClr val="accent1"/>
-          </a:fillRef>
-          <a:effectRef idx="2">
-            <a:schemeClr val="accent1"/>
-          </a:effectRef>
-          <a:fontRef idx="minor">
-            <a:schemeClr val="lt1"/>
-          </a:fontRef>
-        </p:style>
-        <p:txBody>
-          <a:bodyPr rtlCol="0" anchor="ctr"/>
-          <a:lstStyle/>
-          <a:p>
-            <a:pPr algn="ctr"/>
-          </a:p>
-        </p:txBody>
-      </p:sp>
-      <p:sp>
-        <p:nvSpPr>
-          <p:cNvPr id="28" name="TextBox 27"/>
-          <p:cNvSpPr txBox="1"/>
-          <p:nvPr/>
-        </p:nvSpPr>
-        <p:spPr>
-          <a:xfrm>
-            <a:off x="658368" y="3941063"/>
-            <a:ext cx="1517904" cy="310896"/>
-          </a:xfrm>
-          <a:prstGeom prst="rect">
-            <a:avLst/>
-          </a:prstGeom>
-          <a:noFill/>
-        </p:spPr>
-        <p:txBody>
-          <a:bodyPr wrap="none">
-            <a:spAutoFit/>
-          </a:bodyPr>
-          <a:lstStyle/>
-          <a:p>
-            <a:pPr algn="ctr">
-              <a:spcAft>
-                <a:spcPts val="600"/>
-              </a:spcAft>
-            </a:pPr>
-            <a:r>
-              <a:rPr sz="1100" b="1">
-                <a:solidFill>
-                  <a:srgbClr val="FFFFFF"/>
-                </a:solidFill>
-                <a:latin typeface="Calibri"/>
-              </a:rPr>
-              <a:t>ALL</a:t>
-            </a:r>
-          </a:p>
-        </p:txBody>
-      </p:sp>
-      <p:sp>
-        <p:nvSpPr>
-          <p:cNvPr id="29" name="TextBox 28"/>
-          <p:cNvSpPr txBox="1"/>
-          <p:nvPr/>
-        </p:nvSpPr>
-        <p:spPr>
-          <a:xfrm>
-            <a:off x="2331720" y="3931919"/>
-            <a:ext cx="5577840" cy="365760"/>
-          </a:xfrm>
-          <a:prstGeom prst="rect">
-            <a:avLst/>
-          </a:prstGeom>
-          <a:noFill/>
-        </p:spPr>
-        <p:txBody>
-          <a:bodyPr wrap="none">
-            <a:spAutoFit/>
-          </a:bodyPr>
-          <a:lstStyle/>
-          <a:p>
-            <a:pPr algn="l">
-              <a:spcAft>
-                <a:spcPts val="600"/>
-              </a:spcAft>
-            </a:pPr>
-            <a:r>
-              <a:rPr sz="1300" b="1">
-                <a:solidFill>
-                  <a:srgbClr val="17202A"/>
-                </a:solidFill>
-                <a:latin typeface="Calibri"/>
-              </a:rPr>
-              <a:t>/security/ingest</a:t>
-            </a:r>
-          </a:p>
-        </p:txBody>
-      </p:sp>
-      <p:sp>
-        <p:nvSpPr>
-          <p:cNvPr id="30" name="TextBox 29"/>
-          <p:cNvSpPr txBox="1"/>
-          <p:nvPr/>
-        </p:nvSpPr>
-        <p:spPr>
-          <a:xfrm>
-            <a:off x="8092440" y="3941063"/>
-            <a:ext cx="3566160" cy="365760"/>
-          </a:xfrm>
-          <a:prstGeom prst="rect">
-            <a:avLst/>
-          </a:prstGeom>
-          <a:noFill/>
-        </p:spPr>
-        <p:txBody>
-          <a:bodyPr wrap="none">
-            <a:spAutoFit/>
-          </a:bodyPr>
-          <a:lstStyle/>
-          <a:p>
-            <a:pPr algn="l">
-              <a:spcAft>
-                <a:spcPts val="600"/>
-              </a:spcAft>
-            </a:pPr>
-            <a:r>
-              <a:rPr sz="1200" b="0">
-                <a:solidFill>
-                  <a:srgbClr val="52606D"/>
-                </a:solidFill>
-                <a:latin typeface="Calibri"/>
-              </a:rPr>
-              <a:t>interne (nginx/loopback)</a:t>
-            </a:r>
-          </a:p>
-        </p:txBody>
-      </p:sp>
-      <p:sp>
-        <p:nvSpPr>
-          <p:cNvPr id="31" name="Rectangle 30"/>
-          <p:cNvSpPr/>
-          <p:nvPr/>
-        </p:nvSpPr>
-        <p:spPr>
-          <a:xfrm>
-            <a:off x="640080" y="4389119"/>
-            <a:ext cx="1554480" cy="420624"/>
-          </a:xfrm>
-          <a:prstGeom prst="rect">
-            <a:avLst/>
-          </a:prstGeom>
-          <a:solidFill>
-            <a:srgbClr val="155FA0"/>
-          </a:solidFill>
-          <a:ln>
-            <a:noFill/>
-          </a:ln>
-          <a:effectLst/>
-        </p:spPr>
-        <p:style>
-          <a:lnRef idx="1">
-            <a:schemeClr val="accent1"/>
-          </a:lnRef>
-          <a:fillRef idx="3">
-            <a:schemeClr val="accent1"/>
-          </a:fillRef>
-          <a:effectRef idx="2">
-            <a:schemeClr val="accent1"/>
-          </a:effectRef>
-          <a:fontRef idx="minor">
-            <a:schemeClr val="lt1"/>
-          </a:fontRef>
-        </p:style>
-        <p:txBody>
-          <a:bodyPr rtlCol="0" anchor="ctr"/>
-          <a:lstStyle/>
-          <a:p>
-            <a:pPr algn="ctr"/>
-          </a:p>
-        </p:txBody>
-      </p:sp>
-      <p:sp>
-        <p:nvSpPr>
-          <p:cNvPr id="32" name="TextBox 31"/>
-          <p:cNvSpPr txBox="1"/>
-          <p:nvPr/>
-        </p:nvSpPr>
-        <p:spPr>
-          <a:xfrm>
-            <a:off x="658368" y="4443983"/>
-            <a:ext cx="1517904" cy="310896"/>
-          </a:xfrm>
-          <a:prstGeom prst="rect">
-            <a:avLst/>
-          </a:prstGeom>
-          <a:noFill/>
-        </p:spPr>
-        <p:txBody>
-          <a:bodyPr wrap="none">
-            <a:spAutoFit/>
-          </a:bodyPr>
-          <a:lstStyle/>
-          <a:p>
-            <a:pPr algn="ctr">
-              <a:spcAft>
-                <a:spcPts val="600"/>
-              </a:spcAft>
-            </a:pPr>
-            <a:r>
-              <a:rPr sz="1100" b="1">
-                <a:solidFill>
-                  <a:srgbClr val="FFFFFF"/>
-                </a:solidFill>
-                <a:latin typeface="Calibri"/>
-              </a:rPr>
-              <a:t>GET</a:t>
-            </a:r>
-          </a:p>
-        </p:txBody>
-      </p:sp>
-      <p:sp>
-        <p:nvSpPr>
-          <p:cNvPr id="33" name="TextBox 32"/>
-          <p:cNvSpPr txBox="1"/>
-          <p:nvPr/>
-        </p:nvSpPr>
-        <p:spPr>
-          <a:xfrm>
-            <a:off x="2331720" y="4434839"/>
-            <a:ext cx="5577840" cy="365760"/>
-          </a:xfrm>
-          <a:prstGeom prst="rect">
-            <a:avLst/>
-          </a:prstGeom>
-          <a:noFill/>
-        </p:spPr>
-        <p:txBody>
-          <a:bodyPr wrap="none">
-            <a:spAutoFit/>
-          </a:bodyPr>
-          <a:lstStyle/>
-          <a:p>
-            <a:pPr algn="l">
-              <a:spcAft>
-                <a:spcPts val="600"/>
-              </a:spcAft>
-            </a:pPr>
-            <a:r>
-              <a:rPr sz="1300" b="1">
-                <a:solidFill>
-                  <a:srgbClr val="17202A"/>
-                </a:solidFill>
-                <a:latin typeface="Calibri"/>
-              </a:rPr>
-              <a:t>/admin/users</a:t>
-            </a:r>
-          </a:p>
-        </p:txBody>
-      </p:sp>
-      <p:sp>
-        <p:nvSpPr>
-          <p:cNvPr id="34" name="TextBox 33"/>
-          <p:cNvSpPr txBox="1"/>
-          <p:nvPr/>
-        </p:nvSpPr>
-        <p:spPr>
-          <a:xfrm>
-            <a:off x="8092440" y="4443983"/>
-            <a:ext cx="3566160" cy="365760"/>
-          </a:xfrm>
-          <a:prstGeom prst="rect">
-            <a:avLst/>
-          </a:prstGeom>
-          <a:noFill/>
-        </p:spPr>
-        <p:txBody>
-          <a:bodyPr wrap="none">
-            <a:spAutoFit/>
-          </a:bodyPr>
-          <a:lstStyle/>
-          <a:p>
-            <a:pPr algn="l">
-              <a:spcAft>
-                <a:spcPts val="600"/>
-              </a:spcAft>
-            </a:pPr>
-            <a:r>
-              <a:rPr sz="1200" b="0">
-                <a:solidFill>
-                  <a:srgbClr val="52606D"/>
-                </a:solidFill>
-                <a:latin typeface="Calibri"/>
-              </a:rPr>
-              <a:t>Bearer admin</a:t>
-            </a:r>
-          </a:p>
-        </p:txBody>
-      </p:sp>
-      <p:sp>
-        <p:nvSpPr>
-          <p:cNvPr id="35" name="Rectangle 34"/>
-          <p:cNvSpPr/>
-          <p:nvPr/>
-        </p:nvSpPr>
-        <p:spPr>
-          <a:xfrm>
-            <a:off x="640080" y="4892039"/>
-            <a:ext cx="1554480" cy="420624"/>
-          </a:xfrm>
-          <a:prstGeom prst="rect">
-            <a:avLst/>
-          </a:prstGeom>
-          <a:solidFill>
-            <a:srgbClr val="155FA0"/>
-          </a:solidFill>
-          <a:ln>
-            <a:noFill/>
-          </a:ln>
-          <a:effectLst/>
-        </p:spPr>
-        <p:style>
-          <a:lnRef idx="1">
-            <a:schemeClr val="accent1"/>
-          </a:lnRef>
-          <a:fillRef idx="3">
-            <a:schemeClr val="accent1"/>
-          </a:fillRef>
-          <a:effectRef idx="2">
-            <a:schemeClr val="accent1"/>
-          </a:effectRef>
-          <a:fontRef idx="minor">
-            <a:schemeClr val="lt1"/>
-          </a:fontRef>
-        </p:style>
-        <p:txBody>
-          <a:bodyPr rtlCol="0" anchor="ctr"/>
-          <a:lstStyle/>
-          <a:p>
-            <a:pPr algn="ctr"/>
-          </a:p>
-        </p:txBody>
-      </p:sp>
-      <p:sp>
-        <p:nvSpPr>
-          <p:cNvPr id="36" name="TextBox 35"/>
-          <p:cNvSpPr txBox="1"/>
-          <p:nvPr/>
-        </p:nvSpPr>
-        <p:spPr>
-          <a:xfrm>
-            <a:off x="658368" y="4946903"/>
-            <a:ext cx="1517904" cy="310896"/>
-          </a:xfrm>
-          <a:prstGeom prst="rect">
-            <a:avLst/>
-          </a:prstGeom>
-          <a:noFill/>
-        </p:spPr>
-        <p:txBody>
-          <a:bodyPr wrap="none">
-            <a:spAutoFit/>
-          </a:bodyPr>
-          <a:lstStyle/>
-          <a:p>
-            <a:pPr algn="ctr">
-              <a:spcAft>
-                <a:spcPts val="600"/>
-              </a:spcAft>
-            </a:pPr>
-            <a:r>
-              <a:rPr sz="1100" b="1">
-                <a:solidFill>
-                  <a:srgbClr val="FFFFFF"/>
-                </a:solidFill>
-                <a:latin typeface="Calibri"/>
-              </a:rPr>
-              <a:t>GET</a:t>
-            </a:r>
-          </a:p>
-        </p:txBody>
-      </p:sp>
-      <p:sp>
-        <p:nvSpPr>
-          <p:cNvPr id="37" name="TextBox 36"/>
-          <p:cNvSpPr txBox="1"/>
-          <p:nvPr/>
-        </p:nvSpPr>
-        <p:spPr>
-          <a:xfrm>
-            <a:off x="2331720" y="4937759"/>
-            <a:ext cx="5577840" cy="365760"/>
-          </a:xfrm>
-          <a:prstGeom prst="rect">
-            <a:avLst/>
-          </a:prstGeom>
-          <a:noFill/>
-        </p:spPr>
-        <p:txBody>
-          <a:bodyPr wrap="none">
-            <a:spAutoFit/>
-          </a:bodyPr>
-          <a:lstStyle/>
-          <a:p>
-            <a:pPr algn="l">
-              <a:spcAft>
-                <a:spcPts val="600"/>
-              </a:spcAft>
-            </a:pPr>
-            <a:r>
-              <a:rPr sz="1300" b="1">
-                <a:solidFill>
-                  <a:srgbClr val="17202A"/>
-                </a:solidFill>
-                <a:latin typeface="Calibri"/>
-              </a:rPr>
-              <a:t>/admin/contents</a:t>
-            </a:r>
-          </a:p>
-        </p:txBody>
-      </p:sp>
-      <p:sp>
-        <p:nvSpPr>
-          <p:cNvPr id="38" name="TextBox 37"/>
-          <p:cNvSpPr txBox="1"/>
-          <p:nvPr/>
-        </p:nvSpPr>
-        <p:spPr>
-          <a:xfrm>
-            <a:off x="8092440" y="4946903"/>
-            <a:ext cx="3566160" cy="365760"/>
-          </a:xfrm>
-          <a:prstGeom prst="rect">
-            <a:avLst/>
-          </a:prstGeom>
-          <a:noFill/>
-        </p:spPr>
-        <p:txBody>
-          <a:bodyPr wrap="none">
-            <a:spAutoFit/>
-          </a:bodyPr>
-          <a:lstStyle/>
-          <a:p>
-            <a:pPr algn="l">
-              <a:spcAft>
-                <a:spcPts val="600"/>
-              </a:spcAft>
-            </a:pPr>
-            <a:r>
-              <a:rPr sz="1200" b="0">
-                <a:solidFill>
-                  <a:srgbClr val="52606D"/>
-                </a:solidFill>
-                <a:latin typeface="Calibri"/>
-              </a:rPr>
-              <a:t>Bearer admin</a:t>
-            </a:r>
-          </a:p>
-        </p:txBody>
-      </p:sp>
-      <p:sp>
-        <p:nvSpPr>
-          <p:cNvPr id="39" name="Rectangle 38"/>
-          <p:cNvSpPr/>
-          <p:nvPr/>
-        </p:nvSpPr>
-        <p:spPr>
-          <a:xfrm>
-            <a:off x="640080" y="5394959"/>
-            <a:ext cx="1554480" cy="420624"/>
-          </a:xfrm>
-          <a:prstGeom prst="rect">
-            <a:avLst/>
-          </a:prstGeom>
-          <a:solidFill>
-            <a:srgbClr val="155FA0"/>
-          </a:solidFill>
-          <a:ln>
-            <a:noFill/>
-          </a:ln>
-          <a:effectLst/>
-        </p:spPr>
-        <p:style>
-          <a:lnRef idx="1">
-            <a:schemeClr val="accent1"/>
-          </a:lnRef>
-          <a:fillRef idx="3">
-            <a:schemeClr val="accent1"/>
-          </a:fillRef>
-          <a:effectRef idx="2">
-            <a:schemeClr val="accent1"/>
-          </a:effectRef>
-          <a:fontRef idx="minor">
-            <a:schemeClr val="lt1"/>
-          </a:fontRef>
-        </p:style>
-        <p:txBody>
-          <a:bodyPr rtlCol="0" anchor="ctr"/>
-          <a:lstStyle/>
-          <a:p>
-            <a:pPr algn="ctr"/>
-          </a:p>
-        </p:txBody>
-      </p:sp>
-      <p:sp>
-        <p:nvSpPr>
-          <p:cNvPr id="40" name="TextBox 39"/>
-          <p:cNvSpPr txBox="1"/>
-          <p:nvPr/>
-        </p:nvSpPr>
-        <p:spPr>
-          <a:xfrm>
-            <a:off x="658368" y="5449823"/>
-            <a:ext cx="1517904" cy="310896"/>
-          </a:xfrm>
-          <a:prstGeom prst="rect">
-            <a:avLst/>
-          </a:prstGeom>
-          <a:noFill/>
-        </p:spPr>
-        <p:txBody>
-          <a:bodyPr wrap="none">
-            <a:spAutoFit/>
-          </a:bodyPr>
-          <a:lstStyle/>
-          <a:p>
-            <a:pPr algn="ctr">
-              <a:spcAft>
-                <a:spcPts val="600"/>
-              </a:spcAft>
-            </a:pPr>
-            <a:r>
-              <a:rPr sz="1100" b="1">
-                <a:solidFill>
-                  <a:srgbClr val="FFFFFF"/>
-                </a:solidFill>
-                <a:latin typeface="Calibri"/>
-              </a:rPr>
-              <a:t>POST/DELETE</a:t>
-            </a:r>
-          </a:p>
-        </p:txBody>
-      </p:sp>
-      <p:sp>
-        <p:nvSpPr>
-          <p:cNvPr id="41" name="TextBox 40"/>
-          <p:cNvSpPr txBox="1"/>
-          <p:nvPr/>
-        </p:nvSpPr>
-        <p:spPr>
-          <a:xfrm>
-            <a:off x="2331720" y="5440679"/>
-            <a:ext cx="5577840" cy="365760"/>
-          </a:xfrm>
-          <a:prstGeom prst="rect">
-            <a:avLst/>
-          </a:prstGeom>
-          <a:noFill/>
-        </p:spPr>
-        <p:txBody>
-          <a:bodyPr wrap="none">
-            <a:spAutoFit/>
-          </a:bodyPr>
-          <a:lstStyle/>
-          <a:p>
-            <a:pPr algn="l">
-              <a:spcAft>
-                <a:spcPts val="600"/>
-              </a:spcAft>
-            </a:pPr>
-            <a:r>
-              <a:rPr sz="1300" b="1">
-                <a:solidFill>
-                  <a:srgbClr val="17202A"/>
-                </a:solidFill>
-                <a:latin typeface="Calibri"/>
-              </a:rPr>
-              <a:t>/admin/contents/:id/access</a:t>
-            </a:r>
-          </a:p>
-        </p:txBody>
-      </p:sp>
-      <p:sp>
-        <p:nvSpPr>
-          <p:cNvPr id="42" name="TextBox 41"/>
-          <p:cNvSpPr txBox="1"/>
-          <p:nvPr/>
-        </p:nvSpPr>
-        <p:spPr>
-          <a:xfrm>
-            <a:off x="8092440" y="5449823"/>
-            <a:ext cx="3566160" cy="365760"/>
-          </a:xfrm>
-          <a:prstGeom prst="rect">
-            <a:avLst/>
-          </a:prstGeom>
-          <a:noFill/>
-        </p:spPr>
-        <p:txBody>
-          <a:bodyPr wrap="none">
-            <a:spAutoFit/>
-          </a:bodyPr>
-          <a:lstStyle/>
-          <a:p>
-            <a:pPr algn="l">
-              <a:spcAft>
-                <a:spcPts val="600"/>
-              </a:spcAft>
-            </a:pPr>
-            <a:r>
-              <a:rPr sz="1200" b="0">
-                <a:solidFill>
-                  <a:srgbClr val="52606D"/>
-                </a:solidFill>
-                <a:latin typeface="Calibri"/>
-              </a:rPr>
-              <a:t>Bearer admin</a:t>
-            </a:r>
-          </a:p>
-        </p:txBody>
-      </p:sp>
-      <p:sp>
-        <p:nvSpPr>
-          <p:cNvPr id="43" name="Rectangle 42"/>
-          <p:cNvSpPr/>
-          <p:nvPr/>
-        </p:nvSpPr>
-        <p:spPr>
-          <a:xfrm>
-            <a:off x="640080" y="5897879"/>
-            <a:ext cx="1554480" cy="420624"/>
-          </a:xfrm>
-          <a:prstGeom prst="rect">
-            <a:avLst/>
-          </a:prstGeom>
-          <a:solidFill>
-            <a:srgbClr val="155FA0"/>
-          </a:solidFill>
-          <a:ln>
-            <a:noFill/>
-          </a:ln>
-          <a:effectLst/>
-        </p:spPr>
-        <p:style>
-          <a:lnRef idx="1">
-            <a:schemeClr val="accent1"/>
-          </a:lnRef>
-          <a:fillRef idx="3">
-            <a:schemeClr val="accent1"/>
-          </a:fillRef>
-          <a:effectRef idx="2">
-            <a:schemeClr val="accent1"/>
-          </a:effectRef>
-          <a:fontRef idx="minor">
-            <a:schemeClr val="lt1"/>
-          </a:fontRef>
-        </p:style>
-        <p:txBody>
-          <a:bodyPr rtlCol="0" anchor="ctr"/>
-          <a:lstStyle/>
-          <a:p>
-            <a:pPr algn="ctr"/>
-          </a:p>
-        </p:txBody>
-      </p:sp>
-      <p:sp>
-        <p:nvSpPr>
-          <p:cNvPr id="44" name="TextBox 43"/>
-          <p:cNvSpPr txBox="1"/>
-          <p:nvPr/>
-        </p:nvSpPr>
-        <p:spPr>
-          <a:xfrm>
-            <a:off x="658368" y="5952743"/>
-            <a:ext cx="1517904" cy="310896"/>
-          </a:xfrm>
-          <a:prstGeom prst="rect">
-            <a:avLst/>
-          </a:prstGeom>
-          <a:noFill/>
-        </p:spPr>
-        <p:txBody>
-          <a:bodyPr wrap="none">
-            <a:spAutoFit/>
-          </a:bodyPr>
-          <a:lstStyle/>
-          <a:p>
-            <a:pPr algn="ctr">
-              <a:spcAft>
-                <a:spcPts val="600"/>
-              </a:spcAft>
-            </a:pPr>
-            <a:r>
-              <a:rPr sz="1100" b="1">
-                <a:solidFill>
-                  <a:srgbClr val="FFFFFF"/>
-                </a:solidFill>
-                <a:latin typeface="Calibri"/>
-              </a:rPr>
-              <a:t>POST</a:t>
-            </a:r>
-          </a:p>
-        </p:txBody>
-      </p:sp>
-      <p:sp>
-        <p:nvSpPr>
-          <p:cNvPr id="45" name="TextBox 44"/>
-          <p:cNvSpPr txBox="1"/>
-          <p:nvPr/>
-        </p:nvSpPr>
-        <p:spPr>
-          <a:xfrm>
-            <a:off x="2331720" y="5943599"/>
-            <a:ext cx="5577840" cy="365760"/>
-          </a:xfrm>
-          <a:prstGeom prst="rect">
-            <a:avLst/>
-          </a:prstGeom>
-          <a:noFill/>
-        </p:spPr>
-        <p:txBody>
-          <a:bodyPr wrap="none">
-            <a:spAutoFit/>
-          </a:bodyPr>
-          <a:lstStyle/>
-          <a:p>
-            <a:pPr algn="l">
-              <a:spcAft>
-                <a:spcPts val="600"/>
-              </a:spcAft>
-            </a:pPr>
-            <a:r>
-              <a:rPr sz="1300" b="1">
-                <a:solidFill>
-                  <a:srgbClr val="17202A"/>
-                </a:solidFill>
-                <a:latin typeface="Calibri"/>
-              </a:rPr>
-              <a:t>/admin/contents/:id/revoke | restore</a:t>
-            </a:r>
-          </a:p>
-        </p:txBody>
-      </p:sp>
-      <p:sp>
-        <p:nvSpPr>
-          <p:cNvPr id="46" name="TextBox 45"/>
-          <p:cNvSpPr txBox="1"/>
-          <p:nvPr/>
-        </p:nvSpPr>
-        <p:spPr>
-          <a:xfrm>
-            <a:off x="8092440" y="5952743"/>
-            <a:ext cx="3566160" cy="365760"/>
-          </a:xfrm>
-          <a:prstGeom prst="rect">
-            <a:avLst/>
-          </a:prstGeom>
-          <a:noFill/>
-        </p:spPr>
-        <p:txBody>
-          <a:bodyPr wrap="none">
-            <a:spAutoFit/>
-          </a:bodyPr>
-          <a:lstStyle/>
-          <a:p>
-            <a:pPr algn="l">
-              <a:spcAft>
-                <a:spcPts val="600"/>
-              </a:spcAft>
-            </a:pPr>
-            <a:r>
-              <a:rPr sz="1200" b="0">
-                <a:solidFill>
-                  <a:srgbClr val="52606D"/>
-                </a:solidFill>
-                <a:latin typeface="Calibri"/>
-              </a:rPr>
-              <a:t>Bearer admin</a:t>
+              <a:t> — couper l'accès à un contenu en direct</a:t>
             </a:r>
           </a:p>
         </p:txBody>
@@ -7630,6 +6444,50 @@
             <a:avLst/>
           </a:prstGeom>
           <a:solidFill>
+            <a:srgbClr val="FFFFFF"/>
+          </a:solidFill>
+          <a:ln>
+            <a:noFill/>
+          </a:ln>
+          <a:effectLst/>
+        </p:spPr>
+        <p:style>
+          <a:lnRef idx="1">
+            <a:schemeClr val="accent1"/>
+          </a:lnRef>
+          <a:fillRef idx="3">
+            <a:schemeClr val="accent1"/>
+          </a:fillRef>
+          <a:effectRef idx="2">
+            <a:schemeClr val="accent1"/>
+          </a:effectRef>
+          <a:fontRef idx="minor">
+            <a:schemeClr val="lt1"/>
+          </a:fontRef>
+        </p:style>
+        <p:txBody>
+          <a:bodyPr rtlCol="0" anchor="ctr"/>
+          <a:lstStyle/>
+          <a:p>
+            <a:pPr algn="ctr"/>
+          </a:p>
+        </p:txBody>
+      </p:sp>
+      <p:sp>
+        <p:nvSpPr>
+          <p:cNvPr id="3" name="Rectangle 2"/>
+          <p:cNvSpPr/>
+          <p:nvPr/>
+        </p:nvSpPr>
+        <p:spPr>
+          <a:xfrm>
+            <a:off x="0" y="0"/>
+            <a:ext cx="12191695" cy="1051560"/>
+          </a:xfrm>
+          <a:prstGeom prst="rect">
+            <a:avLst/>
+          </a:prstGeom>
+          <a:solidFill>
             <a:srgbClr val="0B1F3A"/>
           </a:solidFill>
           <a:ln>
@@ -7661,13 +6519,13 @@
       </p:sp>
       <p:sp>
         <p:nvSpPr>
-          <p:cNvPr id="3" name="Rectangle 2"/>
+          <p:cNvPr id="4" name="Rectangle 3"/>
           <p:cNvSpPr/>
           <p:nvPr/>
         </p:nvSpPr>
         <p:spPr>
           <a:xfrm>
-            <a:off x="0" y="914400"/>
+            <a:off x="0" y="1051560"/>
             <a:ext cx="12191695" cy="73152"/>
           </a:xfrm>
           <a:prstGeom prst="rect">
@@ -7705,14 +6563,591 @@
       </p:sp>
       <p:sp>
         <p:nvSpPr>
-          <p:cNvPr id="4" name="TextBox 3"/>
+          <p:cNvPr id="5" name="TextBox 4"/>
           <p:cNvSpPr txBox="1"/>
           <p:nvPr/>
         </p:nvSpPr>
         <p:spPr>
           <a:xfrm>
-            <a:off x="822960" y="365760"/>
-            <a:ext cx="10515600" cy="640080"/>
+            <a:off x="548640" y="164592"/>
+            <a:ext cx="11064240" cy="868680"/>
+          </a:xfrm>
+          <a:prstGeom prst="rect">
+            <a:avLst/>
+          </a:prstGeom>
+          <a:noFill/>
+        </p:spPr>
+        <p:txBody>
+          <a:bodyPr wrap="square">
+            <a:spAutoFit/>
+          </a:bodyPr>
+          <a:lstStyle/>
+          <a:p>
+            <a:pPr algn="l">
+              <a:spcAft>
+                <a:spcPts val="600"/>
+              </a:spcAft>
+            </a:pPr>
+            <a:r>
+              <a:rPr sz="2800" b="1">
+                <a:solidFill>
+                  <a:srgbClr val="FFFFFF"/>
+                </a:solidFill>
+                <a:latin typeface="Calibri"/>
+              </a:rPr>
+              <a:t>Onboarding par invitation</a:t>
+            </a:r>
+          </a:p>
+        </p:txBody>
+      </p:sp>
+      <p:sp>
+        <p:nvSpPr>
+          <p:cNvPr id="6" name="TextBox 5"/>
+          <p:cNvSpPr txBox="1"/>
+          <p:nvPr/>
+        </p:nvSpPr>
+        <p:spPr>
+          <a:xfrm>
+            <a:off x="566928" y="786384"/>
+            <a:ext cx="11064240" cy="365760"/>
+          </a:xfrm>
+          <a:prstGeom prst="rect">
+            <a:avLst/>
+          </a:prstGeom>
+          <a:noFill/>
+        </p:spPr>
+        <p:txBody>
+          <a:bodyPr wrap="square">
+            <a:spAutoFit/>
+          </a:bodyPr>
+          <a:lstStyle/>
+          <a:p>
+            <a:pPr algn="l">
+              <a:spcAft>
+                <a:spcPts val="600"/>
+              </a:spcAft>
+            </a:pPr>
+            <a:r>
+              <a:rPr sz="1200" b="1">
+                <a:solidFill>
+                  <a:srgbClr val="2EC4B6"/>
+                </a:solidFill>
+                <a:latin typeface="Calibri"/>
+              </a:rPr>
+              <a:t>Mot de passe temporaire 24 h + changement forcé</a:t>
+            </a:r>
+          </a:p>
+        </p:txBody>
+      </p:sp>
+      <p:sp>
+        <p:nvSpPr>
+          <p:cNvPr id="7" name="TextBox 6"/>
+          <p:cNvSpPr txBox="1"/>
+          <p:nvPr/>
+        </p:nvSpPr>
+        <p:spPr>
+          <a:xfrm>
+            <a:off x="640080" y="1463040"/>
+            <a:ext cx="10972800" cy="5029200"/>
+          </a:xfrm>
+          <a:prstGeom prst="rect">
+            <a:avLst/>
+          </a:prstGeom>
+          <a:noFill/>
+        </p:spPr>
+        <p:txBody>
+          <a:bodyPr wrap="square">
+            <a:spAutoFit/>
+          </a:bodyPr>
+          <a:lstStyle/>
+          <a:p>
+            <a:pPr algn="l">
+              <a:spcAft>
+                <a:spcPts val="900"/>
+              </a:spcAft>
+            </a:pPr>
+            <a:r>
+              <a:rPr sz="1600" b="1">
+                <a:solidFill>
+                  <a:srgbClr val="2EC4B6"/>
+                </a:solidFill>
+                <a:latin typeface="Calibri"/>
+              </a:rPr>
+              <a:t>▸  </a:t>
+            </a:r>
+            <a:r>
+              <a:rPr sz="1600" b="1">
+                <a:solidFill>
+                  <a:srgbClr val="17202A"/>
+                </a:solidFill>
+                <a:latin typeface="Calibri"/>
+              </a:rPr>
+              <a:t>1. Super-admin invite</a:t>
+            </a:r>
+            <a:r>
+              <a:rPr sz="1600" b="0">
+                <a:solidFill>
+                  <a:srgbClr val="52606D"/>
+                </a:solidFill>
+                <a:latin typeface="Calibri"/>
+              </a:rPr>
+              <a:t> — POST /admin/companies/:id/invite-admin { email }</a:t>
+            </a:r>
+          </a:p>
+          <a:p>
+            <a:pPr algn="l">
+              <a:spcAft>
+                <a:spcPts val="900"/>
+              </a:spcAft>
+            </a:pPr>
+            <a:r>
+              <a:rPr sz="1600" b="1">
+                <a:solidFill>
+                  <a:srgbClr val="2EC4B6"/>
+                </a:solidFill>
+                <a:latin typeface="Calibri"/>
+              </a:rPr>
+              <a:t>▸  </a:t>
+            </a:r>
+            <a:r>
+              <a:rPr sz="1600" b="1">
+                <a:solidFill>
+                  <a:srgbClr val="17202A"/>
+                </a:solidFill>
+                <a:latin typeface="Calibri"/>
+              </a:rPr>
+              <a:t>Mot de passe temporaire</a:t>
+            </a:r>
+            <a:r>
+              <a:rPr sz="1600" b="0">
+                <a:solidFill>
+                  <a:srgbClr val="52606D"/>
+                </a:solidFill>
+                <a:latin typeface="Calibri"/>
+              </a:rPr>
+              <a:t> — aléatoire, valable 24 h, envoyé au mail du représentant</a:t>
+            </a:r>
+          </a:p>
+          <a:p>
+            <a:pPr algn="l">
+              <a:spcAft>
+                <a:spcPts val="900"/>
+              </a:spcAft>
+            </a:pPr>
+            <a:r>
+              <a:rPr sz="1600" b="1">
+                <a:solidFill>
+                  <a:srgbClr val="2EC4B6"/>
+                </a:solidFill>
+                <a:latin typeface="Calibri"/>
+              </a:rPr>
+              <a:t>▸  </a:t>
+            </a:r>
+            <a:r>
+              <a:rPr sz="1600" b="1">
+                <a:solidFill>
+                  <a:srgbClr val="17202A"/>
+                </a:solidFill>
+                <a:latin typeface="Calibri"/>
+              </a:rPr>
+              <a:t>2. Admin se connecte</a:t>
+            </a:r>
+            <a:r>
+              <a:rPr sz="1600" b="0">
+                <a:solidFill>
+                  <a:srgbClr val="52606D"/>
+                </a:solidFill>
+                <a:latin typeface="Calibri"/>
+              </a:rPr>
+              <a:t> — token avec mustChangePassword = true</a:t>
+            </a:r>
+          </a:p>
+          <a:p>
+            <a:pPr algn="l">
+              <a:spcAft>
+                <a:spcPts val="900"/>
+              </a:spcAft>
+            </a:pPr>
+            <a:r>
+              <a:rPr sz="1600" b="1">
+                <a:solidFill>
+                  <a:srgbClr val="2EC4B6"/>
+                </a:solidFill>
+                <a:latin typeface="Calibri"/>
+              </a:rPr>
+              <a:t>▸  </a:t>
+            </a:r>
+            <a:r>
+              <a:rPr sz="1600" b="1">
+                <a:solidFill>
+                  <a:srgbClr val="17202A"/>
+                </a:solidFill>
+                <a:latin typeface="Calibri"/>
+              </a:rPr>
+              <a:t>Panel bloqué</a:t>
+            </a:r>
+            <a:r>
+              <a:rPr sz="1600" b="0">
+                <a:solidFill>
+                  <a:srgbClr val="52606D"/>
+                </a:solidFill>
+                <a:latin typeface="Calibri"/>
+              </a:rPr>
+              <a:t> — 403 tant que le mot de passe n'est pas changé</a:t>
+            </a:r>
+          </a:p>
+          <a:p>
+            <a:pPr algn="l">
+              <a:spcAft>
+                <a:spcPts val="900"/>
+              </a:spcAft>
+            </a:pPr>
+            <a:r>
+              <a:rPr sz="1600" b="1">
+                <a:solidFill>
+                  <a:srgbClr val="2EC4B6"/>
+                </a:solidFill>
+                <a:latin typeface="Calibri"/>
+              </a:rPr>
+              <a:t>▸  </a:t>
+            </a:r>
+            <a:r>
+              <a:rPr sz="1600" b="1">
+                <a:solidFill>
+                  <a:srgbClr val="17202A"/>
+                </a:solidFill>
+                <a:latin typeface="Calibri"/>
+              </a:rPr>
+              <a:t>3. Changement de mdp</a:t>
+            </a:r>
+            <a:r>
+              <a:rPr sz="1600" b="0">
+                <a:solidFill>
+                  <a:srgbClr val="52606D"/>
+                </a:solidFill>
+                <a:latin typeface="Calibri"/>
+              </a:rPr>
+              <a:t> — POST /auth/change-password → nouveau token, panel ouvert</a:t>
+            </a:r>
+          </a:p>
+          <a:p>
+            <a:pPr algn="l">
+              <a:spcAft>
+                <a:spcPts val="900"/>
+              </a:spcAft>
+            </a:pPr>
+            <a:r>
+              <a:rPr sz="1600" b="1">
+                <a:solidFill>
+                  <a:srgbClr val="2EC4B6"/>
+                </a:solidFill>
+                <a:latin typeface="Calibri"/>
+              </a:rPr>
+              <a:t>▸  </a:t>
+            </a:r>
+            <a:r>
+              <a:rPr sz="1600" b="1">
+                <a:solidFill>
+                  <a:srgbClr val="17202A"/>
+                </a:solidFill>
+                <a:latin typeface="Calibri"/>
+              </a:rPr>
+              <a:t>Sécurité</a:t>
+            </a:r>
+            <a:r>
+              <a:rPr sz="1600" b="0">
+                <a:solidFill>
+                  <a:srgbClr val="52606D"/>
+                </a:solidFill>
+                <a:latin typeface="Calibri"/>
+              </a:rPr>
+              <a:t> — ancien mdp invalidé · mdp temporaire expiré refusé au login</a:t>
+            </a:r>
+          </a:p>
+        </p:txBody>
+      </p:sp>
+    </p:spTree>
+  </p:cSld>
+  <p:clrMapOvr>
+    <a:masterClrMapping/>
+  </p:clrMapOvr>
+</p:sld>
+</file>
+
+<file path=ppt/slides/slide17.xml><?xml version="1.0" encoding="utf-8"?>
+<p:sld xmlns:a="http://schemas.openxmlformats.org/drawingml/2006/main" xmlns:p="http://schemas.openxmlformats.org/presentationml/2006/main" xmlns:r="http://schemas.openxmlformats.org/officeDocument/2006/relationships">
+  <p:cSld>
+    <p:spTree>
+      <p:nvGrpSpPr>
+        <p:cNvPr id="1" name=""/>
+        <p:cNvGrpSpPr/>
+        <p:nvPr/>
+      </p:nvGrpSpPr>
+      <p:grpSpPr/>
+      <p:sp>
+        <p:nvSpPr>
+          <p:cNvPr id="2" name="Rectangle 1"/>
+          <p:cNvSpPr/>
+          <p:nvPr/>
+        </p:nvSpPr>
+        <p:spPr>
+          <a:xfrm>
+            <a:off x="-91440" y="-91440"/>
+            <a:ext cx="12435840" cy="7040880"/>
+          </a:xfrm>
+          <a:prstGeom prst="rect">
+            <a:avLst/>
+          </a:prstGeom>
+          <a:solidFill>
+            <a:srgbClr val="FFFFFF"/>
+          </a:solidFill>
+          <a:ln>
+            <a:noFill/>
+          </a:ln>
+          <a:effectLst/>
+        </p:spPr>
+        <p:style>
+          <a:lnRef idx="1">
+            <a:schemeClr val="accent1"/>
+          </a:lnRef>
+          <a:fillRef idx="3">
+            <a:schemeClr val="accent1"/>
+          </a:fillRef>
+          <a:effectRef idx="2">
+            <a:schemeClr val="accent1"/>
+          </a:effectRef>
+          <a:fontRef idx="minor">
+            <a:schemeClr val="lt1"/>
+          </a:fontRef>
+        </p:style>
+        <p:txBody>
+          <a:bodyPr rtlCol="0" anchor="ctr"/>
+          <a:lstStyle/>
+          <a:p>
+            <a:pPr algn="ctr"/>
+          </a:p>
+        </p:txBody>
+      </p:sp>
+      <p:sp>
+        <p:nvSpPr>
+          <p:cNvPr id="3" name="Rectangle 2"/>
+          <p:cNvSpPr/>
+          <p:nvPr/>
+        </p:nvSpPr>
+        <p:spPr>
+          <a:xfrm>
+            <a:off x="0" y="0"/>
+            <a:ext cx="12191695" cy="1051560"/>
+          </a:xfrm>
+          <a:prstGeom prst="rect">
+            <a:avLst/>
+          </a:prstGeom>
+          <a:solidFill>
+            <a:srgbClr val="0B1F3A"/>
+          </a:solidFill>
+          <a:ln>
+            <a:noFill/>
+          </a:ln>
+          <a:effectLst/>
+        </p:spPr>
+        <p:style>
+          <a:lnRef idx="1">
+            <a:schemeClr val="accent1"/>
+          </a:lnRef>
+          <a:fillRef idx="3">
+            <a:schemeClr val="accent1"/>
+          </a:fillRef>
+          <a:effectRef idx="2">
+            <a:schemeClr val="accent1"/>
+          </a:effectRef>
+          <a:fontRef idx="minor">
+            <a:schemeClr val="lt1"/>
+          </a:fontRef>
+        </p:style>
+        <p:txBody>
+          <a:bodyPr rtlCol="0" anchor="ctr"/>
+          <a:lstStyle/>
+          <a:p>
+            <a:pPr algn="ctr"/>
+          </a:p>
+        </p:txBody>
+      </p:sp>
+      <p:sp>
+        <p:nvSpPr>
+          <p:cNvPr id="4" name="Rectangle 3"/>
+          <p:cNvSpPr/>
+          <p:nvPr/>
+        </p:nvSpPr>
+        <p:spPr>
+          <a:xfrm>
+            <a:off x="0" y="1051560"/>
+            <a:ext cx="12191695" cy="73152"/>
+          </a:xfrm>
+          <a:prstGeom prst="rect">
+            <a:avLst/>
+          </a:prstGeom>
+          <a:solidFill>
+            <a:srgbClr val="2EC4B6"/>
+          </a:solidFill>
+          <a:ln>
+            <a:noFill/>
+          </a:ln>
+          <a:effectLst/>
+        </p:spPr>
+        <p:style>
+          <a:lnRef idx="1">
+            <a:schemeClr val="accent1"/>
+          </a:lnRef>
+          <a:fillRef idx="3">
+            <a:schemeClr val="accent1"/>
+          </a:fillRef>
+          <a:effectRef idx="2">
+            <a:schemeClr val="accent1"/>
+          </a:effectRef>
+          <a:fontRef idx="minor">
+            <a:schemeClr val="lt1"/>
+          </a:fontRef>
+        </p:style>
+        <p:txBody>
+          <a:bodyPr rtlCol="0" anchor="ctr"/>
+          <a:lstStyle/>
+          <a:p>
+            <a:pPr algn="ctr"/>
+          </a:p>
+        </p:txBody>
+      </p:sp>
+      <p:sp>
+        <p:nvSpPr>
+          <p:cNvPr id="5" name="TextBox 4"/>
+          <p:cNvSpPr txBox="1"/>
+          <p:nvPr/>
+        </p:nvSpPr>
+        <p:spPr>
+          <a:xfrm>
+            <a:off x="548640" y="164592"/>
+            <a:ext cx="11064240" cy="868680"/>
+          </a:xfrm>
+          <a:prstGeom prst="rect">
+            <a:avLst/>
+          </a:prstGeom>
+          <a:noFill/>
+        </p:spPr>
+        <p:txBody>
+          <a:bodyPr wrap="square">
+            <a:spAutoFit/>
+          </a:bodyPr>
+          <a:lstStyle/>
+          <a:p>
+            <a:pPr algn="l">
+              <a:spcAft>
+                <a:spcPts val="600"/>
+              </a:spcAft>
+            </a:pPr>
+            <a:r>
+              <a:rPr sz="2800" b="1">
+                <a:solidFill>
+                  <a:srgbClr val="FFFFFF"/>
+                </a:solidFill>
+                <a:latin typeface="Calibri"/>
+              </a:rPr>
+              <a:t>Récap des routes backend</a:t>
+            </a:r>
+          </a:p>
+        </p:txBody>
+      </p:sp>
+      <p:sp>
+        <p:nvSpPr>
+          <p:cNvPr id="6" name="TextBox 5"/>
+          <p:cNvSpPr txBox="1"/>
+          <p:nvPr/>
+        </p:nvSpPr>
+        <p:spPr>
+          <a:xfrm>
+            <a:off x="566928" y="786384"/>
+            <a:ext cx="11064240" cy="365760"/>
+          </a:xfrm>
+          <a:prstGeom prst="rect">
+            <a:avLst/>
+          </a:prstGeom>
+          <a:noFill/>
+        </p:spPr>
+        <p:txBody>
+          <a:bodyPr wrap="square">
+            <a:spAutoFit/>
+          </a:bodyPr>
+          <a:lstStyle/>
+          <a:p>
+            <a:pPr algn="l">
+              <a:spcAft>
+                <a:spcPts val="600"/>
+              </a:spcAft>
+            </a:pPr>
+            <a:r>
+              <a:rPr sz="1200" b="1">
+                <a:solidFill>
+                  <a:srgbClr val="2EC4B6"/>
+                </a:solidFill>
+                <a:latin typeface="Calibri"/>
+              </a:rPr>
+              <a:t>Surface d'API exposée par le Core</a:t>
+            </a:r>
+          </a:p>
+        </p:txBody>
+      </p:sp>
+      <p:sp>
+        <p:nvSpPr>
+          <p:cNvPr id="7" name="Rectangle 6"/>
+          <p:cNvSpPr/>
+          <p:nvPr/>
+        </p:nvSpPr>
+        <p:spPr>
+          <a:xfrm>
+            <a:off x="640080" y="1371600"/>
+            <a:ext cx="1554480" cy="420624"/>
+          </a:xfrm>
+          <a:prstGeom prst="rect">
+            <a:avLst/>
+          </a:prstGeom>
+          <a:solidFill>
+            <a:srgbClr val="155FA0"/>
+          </a:solidFill>
+          <a:ln>
+            <a:noFill/>
+          </a:ln>
+          <a:effectLst/>
+        </p:spPr>
+        <p:style>
+          <a:lnRef idx="1">
+            <a:schemeClr val="accent1"/>
+          </a:lnRef>
+          <a:fillRef idx="3">
+            <a:schemeClr val="accent1"/>
+          </a:fillRef>
+          <a:effectRef idx="2">
+            <a:schemeClr val="accent1"/>
+          </a:effectRef>
+          <a:fontRef idx="minor">
+            <a:schemeClr val="lt1"/>
+          </a:fontRef>
+        </p:style>
+        <p:txBody>
+          <a:bodyPr rtlCol="0" anchor="ctr"/>
+          <a:lstStyle/>
+          <a:p>
+            <a:pPr algn="ctr"/>
+          </a:p>
+        </p:txBody>
+      </p:sp>
+      <p:sp>
+        <p:nvSpPr>
+          <p:cNvPr id="8" name="TextBox 7"/>
+          <p:cNvSpPr txBox="1"/>
+          <p:nvPr/>
+        </p:nvSpPr>
+        <p:spPr>
+          <a:xfrm>
+            <a:off x="658368" y="1426464"/>
+            <a:ext cx="1517904" cy="310896"/>
           </a:xfrm>
           <a:prstGeom prst="rect">
             <a:avLst/>
@@ -7725,6 +7160,1678 @@
           </a:bodyPr>
           <a:lstStyle/>
           <a:p>
+            <a:pPr algn="ctr">
+              <a:spcAft>
+                <a:spcPts val="600"/>
+              </a:spcAft>
+            </a:pPr>
+            <a:r>
+              <a:rPr sz="1100" b="1">
+                <a:solidFill>
+                  <a:srgbClr val="FFFFFF"/>
+                </a:solidFill>
+                <a:latin typeface="Calibri"/>
+              </a:rPr>
+              <a:t>POST</a:t>
+            </a:r>
+          </a:p>
+        </p:txBody>
+      </p:sp>
+      <p:sp>
+        <p:nvSpPr>
+          <p:cNvPr id="9" name="TextBox 8"/>
+          <p:cNvSpPr txBox="1"/>
+          <p:nvPr/>
+        </p:nvSpPr>
+        <p:spPr>
+          <a:xfrm>
+            <a:off x="2331720" y="1417320"/>
+            <a:ext cx="5577840" cy="365760"/>
+          </a:xfrm>
+          <a:prstGeom prst="rect">
+            <a:avLst/>
+          </a:prstGeom>
+          <a:noFill/>
+        </p:spPr>
+        <p:txBody>
+          <a:bodyPr wrap="none">
+            <a:spAutoFit/>
+          </a:bodyPr>
+          <a:lstStyle/>
+          <a:p>
+            <a:pPr algn="l">
+              <a:spcAft>
+                <a:spcPts val="600"/>
+              </a:spcAft>
+            </a:pPr>
+            <a:r>
+              <a:rPr sz="1300" b="1">
+                <a:solidFill>
+                  <a:srgbClr val="17202A"/>
+                </a:solidFill>
+                <a:latin typeface="Calibri"/>
+              </a:rPr>
+              <a:t>/auth/login</a:t>
+            </a:r>
+          </a:p>
+        </p:txBody>
+      </p:sp>
+      <p:sp>
+        <p:nvSpPr>
+          <p:cNvPr id="10" name="TextBox 9"/>
+          <p:cNvSpPr txBox="1"/>
+          <p:nvPr/>
+        </p:nvSpPr>
+        <p:spPr>
+          <a:xfrm>
+            <a:off x="8092440" y="1426464"/>
+            <a:ext cx="3566160" cy="365760"/>
+          </a:xfrm>
+          <a:prstGeom prst="rect">
+            <a:avLst/>
+          </a:prstGeom>
+          <a:noFill/>
+        </p:spPr>
+        <p:txBody>
+          <a:bodyPr wrap="none">
+            <a:spAutoFit/>
+          </a:bodyPr>
+          <a:lstStyle/>
+          <a:p>
+            <a:pPr algn="l">
+              <a:spcAft>
+                <a:spcPts val="600"/>
+              </a:spcAft>
+            </a:pPr>
+            <a:r>
+              <a:rPr sz="1200" b="0">
+                <a:solidFill>
+                  <a:srgbClr val="52606D"/>
+                </a:solidFill>
+                <a:latin typeface="Calibri"/>
+              </a:rPr>
+              <a:t>public (10/min + lockout)</a:t>
+            </a:r>
+          </a:p>
+        </p:txBody>
+      </p:sp>
+      <p:sp>
+        <p:nvSpPr>
+          <p:cNvPr id="11" name="Rectangle 10"/>
+          <p:cNvSpPr/>
+          <p:nvPr/>
+        </p:nvSpPr>
+        <p:spPr>
+          <a:xfrm>
+            <a:off x="640080" y="1874519"/>
+            <a:ext cx="1554480" cy="420624"/>
+          </a:xfrm>
+          <a:prstGeom prst="rect">
+            <a:avLst/>
+          </a:prstGeom>
+          <a:solidFill>
+            <a:srgbClr val="155FA0"/>
+          </a:solidFill>
+          <a:ln>
+            <a:noFill/>
+          </a:ln>
+          <a:effectLst/>
+        </p:spPr>
+        <p:style>
+          <a:lnRef idx="1">
+            <a:schemeClr val="accent1"/>
+          </a:lnRef>
+          <a:fillRef idx="3">
+            <a:schemeClr val="accent1"/>
+          </a:fillRef>
+          <a:effectRef idx="2">
+            <a:schemeClr val="accent1"/>
+          </a:effectRef>
+          <a:fontRef idx="minor">
+            <a:schemeClr val="lt1"/>
+          </a:fontRef>
+        </p:style>
+        <p:txBody>
+          <a:bodyPr rtlCol="0" anchor="ctr"/>
+          <a:lstStyle/>
+          <a:p>
+            <a:pPr algn="ctr"/>
+          </a:p>
+        </p:txBody>
+      </p:sp>
+      <p:sp>
+        <p:nvSpPr>
+          <p:cNvPr id="12" name="TextBox 11"/>
+          <p:cNvSpPr txBox="1"/>
+          <p:nvPr/>
+        </p:nvSpPr>
+        <p:spPr>
+          <a:xfrm>
+            <a:off x="658368" y="1929384"/>
+            <a:ext cx="1517904" cy="310896"/>
+          </a:xfrm>
+          <a:prstGeom prst="rect">
+            <a:avLst/>
+          </a:prstGeom>
+          <a:noFill/>
+        </p:spPr>
+        <p:txBody>
+          <a:bodyPr wrap="none">
+            <a:spAutoFit/>
+          </a:bodyPr>
+          <a:lstStyle/>
+          <a:p>
+            <a:pPr algn="ctr">
+              <a:spcAft>
+                <a:spcPts val="600"/>
+              </a:spcAft>
+            </a:pPr>
+            <a:r>
+              <a:rPr sz="1100" b="1">
+                <a:solidFill>
+                  <a:srgbClr val="FFFFFF"/>
+                </a:solidFill>
+                <a:latin typeface="Calibri"/>
+              </a:rPr>
+              <a:t>POST</a:t>
+            </a:r>
+          </a:p>
+        </p:txBody>
+      </p:sp>
+      <p:sp>
+        <p:nvSpPr>
+          <p:cNvPr id="13" name="TextBox 12"/>
+          <p:cNvSpPr txBox="1"/>
+          <p:nvPr/>
+        </p:nvSpPr>
+        <p:spPr>
+          <a:xfrm>
+            <a:off x="2331720" y="1920239"/>
+            <a:ext cx="5577840" cy="365760"/>
+          </a:xfrm>
+          <a:prstGeom prst="rect">
+            <a:avLst/>
+          </a:prstGeom>
+          <a:noFill/>
+        </p:spPr>
+        <p:txBody>
+          <a:bodyPr wrap="none">
+            <a:spAutoFit/>
+          </a:bodyPr>
+          <a:lstStyle/>
+          <a:p>
+            <a:pPr algn="l">
+              <a:spcAft>
+                <a:spcPts val="600"/>
+              </a:spcAft>
+            </a:pPr>
+            <a:r>
+              <a:rPr sz="1300" b="1">
+                <a:solidFill>
+                  <a:srgbClr val="17202A"/>
+                </a:solidFill>
+                <a:latin typeface="Calibri"/>
+              </a:rPr>
+              <a:t>/auth/change-password</a:t>
+            </a:r>
+          </a:p>
+        </p:txBody>
+      </p:sp>
+      <p:sp>
+        <p:nvSpPr>
+          <p:cNvPr id="14" name="TextBox 13"/>
+          <p:cNvSpPr txBox="1"/>
+          <p:nvPr/>
+        </p:nvSpPr>
+        <p:spPr>
+          <a:xfrm>
+            <a:off x="8092440" y="1929384"/>
+            <a:ext cx="3566160" cy="365760"/>
+          </a:xfrm>
+          <a:prstGeom prst="rect">
+            <a:avLst/>
+          </a:prstGeom>
+          <a:noFill/>
+        </p:spPr>
+        <p:txBody>
+          <a:bodyPr wrap="none">
+            <a:spAutoFit/>
+          </a:bodyPr>
+          <a:lstStyle/>
+          <a:p>
+            <a:pPr algn="l">
+              <a:spcAft>
+                <a:spcPts val="600"/>
+              </a:spcAft>
+            </a:pPr>
+            <a:r>
+              <a:rPr sz="1200" b="0">
+                <a:solidFill>
+                  <a:srgbClr val="52606D"/>
+                </a:solidFill>
+                <a:latin typeface="Calibri"/>
+              </a:rPr>
+              <a:t>Bearer</a:t>
+            </a:r>
+          </a:p>
+        </p:txBody>
+      </p:sp>
+      <p:sp>
+        <p:nvSpPr>
+          <p:cNvPr id="15" name="Rectangle 14"/>
+          <p:cNvSpPr/>
+          <p:nvPr/>
+        </p:nvSpPr>
+        <p:spPr>
+          <a:xfrm>
+            <a:off x="640080" y="2377439"/>
+            <a:ext cx="1554480" cy="420624"/>
+          </a:xfrm>
+          <a:prstGeom prst="rect">
+            <a:avLst/>
+          </a:prstGeom>
+          <a:solidFill>
+            <a:srgbClr val="155FA0"/>
+          </a:solidFill>
+          <a:ln>
+            <a:noFill/>
+          </a:ln>
+          <a:effectLst/>
+        </p:spPr>
+        <p:style>
+          <a:lnRef idx="1">
+            <a:schemeClr val="accent1"/>
+          </a:lnRef>
+          <a:fillRef idx="3">
+            <a:schemeClr val="accent1"/>
+          </a:fillRef>
+          <a:effectRef idx="2">
+            <a:schemeClr val="accent1"/>
+          </a:effectRef>
+          <a:fontRef idx="minor">
+            <a:schemeClr val="lt1"/>
+          </a:fontRef>
+        </p:style>
+        <p:txBody>
+          <a:bodyPr rtlCol="0" anchor="ctr"/>
+          <a:lstStyle/>
+          <a:p>
+            <a:pPr algn="ctr"/>
+          </a:p>
+        </p:txBody>
+      </p:sp>
+      <p:sp>
+        <p:nvSpPr>
+          <p:cNvPr id="16" name="TextBox 15"/>
+          <p:cNvSpPr txBox="1"/>
+          <p:nvPr/>
+        </p:nvSpPr>
+        <p:spPr>
+          <a:xfrm>
+            <a:off x="658368" y="2432303"/>
+            <a:ext cx="1517904" cy="310896"/>
+          </a:xfrm>
+          <a:prstGeom prst="rect">
+            <a:avLst/>
+          </a:prstGeom>
+          <a:noFill/>
+        </p:spPr>
+        <p:txBody>
+          <a:bodyPr wrap="none">
+            <a:spAutoFit/>
+          </a:bodyPr>
+          <a:lstStyle/>
+          <a:p>
+            <a:pPr algn="ctr">
+              <a:spcAft>
+                <a:spcPts val="600"/>
+              </a:spcAft>
+            </a:pPr>
+            <a:r>
+              <a:rPr sz="1100" b="1">
+                <a:solidFill>
+                  <a:srgbClr val="FFFFFF"/>
+                </a:solidFill>
+                <a:latin typeface="Calibri"/>
+              </a:rPr>
+              <a:t>GET</a:t>
+            </a:r>
+          </a:p>
+        </p:txBody>
+      </p:sp>
+      <p:sp>
+        <p:nvSpPr>
+          <p:cNvPr id="17" name="TextBox 16"/>
+          <p:cNvSpPr txBox="1"/>
+          <p:nvPr/>
+        </p:nvSpPr>
+        <p:spPr>
+          <a:xfrm>
+            <a:off x="2331720" y="2423159"/>
+            <a:ext cx="5577840" cy="365760"/>
+          </a:xfrm>
+          <a:prstGeom prst="rect">
+            <a:avLst/>
+          </a:prstGeom>
+          <a:noFill/>
+        </p:spPr>
+        <p:txBody>
+          <a:bodyPr wrap="none">
+            <a:spAutoFit/>
+          </a:bodyPr>
+          <a:lstStyle/>
+          <a:p>
+            <a:pPr algn="l">
+              <a:spcAft>
+                <a:spcPts val="600"/>
+              </a:spcAft>
+            </a:pPr>
+            <a:r>
+              <a:rPr sz="1300" b="1">
+                <a:solidFill>
+                  <a:srgbClr val="17202A"/>
+                </a:solidFill>
+                <a:latin typeface="Calibri"/>
+              </a:rPr>
+              <a:t>/keys/:contentId</a:t>
+            </a:r>
+          </a:p>
+        </p:txBody>
+      </p:sp>
+      <p:sp>
+        <p:nvSpPr>
+          <p:cNvPr id="18" name="TextBox 17"/>
+          <p:cNvSpPr txBox="1"/>
+          <p:nvPr/>
+        </p:nvSpPr>
+        <p:spPr>
+          <a:xfrm>
+            <a:off x="8092440" y="2432303"/>
+            <a:ext cx="3566160" cy="365760"/>
+          </a:xfrm>
+          <a:prstGeom prst="rect">
+            <a:avLst/>
+          </a:prstGeom>
+          <a:noFill/>
+        </p:spPr>
+        <p:txBody>
+          <a:bodyPr wrap="none">
+            <a:spAutoFit/>
+          </a:bodyPr>
+          <a:lstStyle/>
+          <a:p>
+            <a:pPr algn="l">
+              <a:spcAft>
+                <a:spcPts val="600"/>
+              </a:spcAft>
+            </a:pPr>
+            <a:r>
+              <a:rPr sz="1200" b="0">
+                <a:solidFill>
+                  <a:srgbClr val="52606D"/>
+                </a:solidFill>
+                <a:latin typeface="Calibri"/>
+              </a:rPr>
+              <a:t>Bearer + droits + tenant</a:t>
+            </a:r>
+          </a:p>
+        </p:txBody>
+      </p:sp>
+      <p:sp>
+        <p:nvSpPr>
+          <p:cNvPr id="19" name="Rectangle 18"/>
+          <p:cNvSpPr/>
+          <p:nvPr/>
+        </p:nvSpPr>
+        <p:spPr>
+          <a:xfrm>
+            <a:off x="640080" y="2880359"/>
+            <a:ext cx="1554480" cy="420624"/>
+          </a:xfrm>
+          <a:prstGeom prst="rect">
+            <a:avLst/>
+          </a:prstGeom>
+          <a:solidFill>
+            <a:srgbClr val="155FA0"/>
+          </a:solidFill>
+          <a:ln>
+            <a:noFill/>
+          </a:ln>
+          <a:effectLst/>
+        </p:spPr>
+        <p:style>
+          <a:lnRef idx="1">
+            <a:schemeClr val="accent1"/>
+          </a:lnRef>
+          <a:fillRef idx="3">
+            <a:schemeClr val="accent1"/>
+          </a:fillRef>
+          <a:effectRef idx="2">
+            <a:schemeClr val="accent1"/>
+          </a:effectRef>
+          <a:fontRef idx="minor">
+            <a:schemeClr val="lt1"/>
+          </a:fontRef>
+        </p:style>
+        <p:txBody>
+          <a:bodyPr rtlCol="0" anchor="ctr"/>
+          <a:lstStyle/>
+          <a:p>
+            <a:pPr algn="ctr"/>
+          </a:p>
+        </p:txBody>
+      </p:sp>
+      <p:sp>
+        <p:nvSpPr>
+          <p:cNvPr id="20" name="TextBox 19"/>
+          <p:cNvSpPr txBox="1"/>
+          <p:nvPr/>
+        </p:nvSpPr>
+        <p:spPr>
+          <a:xfrm>
+            <a:off x="658368" y="2935223"/>
+            <a:ext cx="1517904" cy="310896"/>
+          </a:xfrm>
+          <a:prstGeom prst="rect">
+            <a:avLst/>
+          </a:prstGeom>
+          <a:noFill/>
+        </p:spPr>
+        <p:txBody>
+          <a:bodyPr wrap="none">
+            <a:spAutoFit/>
+          </a:bodyPr>
+          <a:lstStyle/>
+          <a:p>
+            <a:pPr algn="ctr">
+              <a:spcAft>
+                <a:spcPts val="600"/>
+              </a:spcAft>
+            </a:pPr>
+            <a:r>
+              <a:rPr sz="1100" b="1">
+                <a:solidFill>
+                  <a:srgbClr val="FFFFFF"/>
+                </a:solidFill>
+                <a:latin typeface="Calibri"/>
+              </a:rPr>
+              <a:t>GET</a:t>
+            </a:r>
+          </a:p>
+        </p:txBody>
+      </p:sp>
+      <p:sp>
+        <p:nvSpPr>
+          <p:cNvPr id="21" name="TextBox 20"/>
+          <p:cNvSpPr txBox="1"/>
+          <p:nvPr/>
+        </p:nvSpPr>
+        <p:spPr>
+          <a:xfrm>
+            <a:off x="2331720" y="2926079"/>
+            <a:ext cx="5577840" cy="365760"/>
+          </a:xfrm>
+          <a:prstGeom prst="rect">
+            <a:avLst/>
+          </a:prstGeom>
+          <a:noFill/>
+        </p:spPr>
+        <p:txBody>
+          <a:bodyPr wrap="none">
+            <a:spAutoFit/>
+          </a:bodyPr>
+          <a:lstStyle/>
+          <a:p>
+            <a:pPr algn="l">
+              <a:spcAft>
+                <a:spcPts val="600"/>
+              </a:spcAft>
+            </a:pPr>
+            <a:r>
+              <a:rPr sz="1300" b="1">
+                <a:solidFill>
+                  <a:srgbClr val="17202A"/>
+                </a:solidFill>
+                <a:latin typeface="Calibri"/>
+              </a:rPr>
+              <a:t>/security/dashboard</a:t>
+            </a:r>
+          </a:p>
+        </p:txBody>
+      </p:sp>
+      <p:sp>
+        <p:nvSpPr>
+          <p:cNvPr id="22" name="TextBox 21"/>
+          <p:cNvSpPr txBox="1"/>
+          <p:nvPr/>
+        </p:nvSpPr>
+        <p:spPr>
+          <a:xfrm>
+            <a:off x="8092440" y="2935223"/>
+            <a:ext cx="3566160" cy="365760"/>
+          </a:xfrm>
+          <a:prstGeom prst="rect">
+            <a:avLst/>
+          </a:prstGeom>
+          <a:noFill/>
+        </p:spPr>
+        <p:txBody>
+          <a:bodyPr wrap="none">
+            <a:spAutoFit/>
+          </a:bodyPr>
+          <a:lstStyle/>
+          <a:p>
+            <a:pPr algn="l">
+              <a:spcAft>
+                <a:spcPts val="600"/>
+              </a:spcAft>
+            </a:pPr>
+            <a:r>
+              <a:rPr sz="1200" b="0">
+                <a:solidFill>
+                  <a:srgbClr val="52606D"/>
+                </a:solidFill>
+                <a:latin typeface="Calibri"/>
+              </a:rPr>
+              <a:t>Bearer admin</a:t>
+            </a:r>
+          </a:p>
+        </p:txBody>
+      </p:sp>
+      <p:sp>
+        <p:nvSpPr>
+          <p:cNvPr id="23" name="Rectangle 22"/>
+          <p:cNvSpPr/>
+          <p:nvPr/>
+        </p:nvSpPr>
+        <p:spPr>
+          <a:xfrm>
+            <a:off x="640080" y="3383279"/>
+            <a:ext cx="1554480" cy="420624"/>
+          </a:xfrm>
+          <a:prstGeom prst="rect">
+            <a:avLst/>
+          </a:prstGeom>
+          <a:solidFill>
+            <a:srgbClr val="155FA0"/>
+          </a:solidFill>
+          <a:ln>
+            <a:noFill/>
+          </a:ln>
+          <a:effectLst/>
+        </p:spPr>
+        <p:style>
+          <a:lnRef idx="1">
+            <a:schemeClr val="accent1"/>
+          </a:lnRef>
+          <a:fillRef idx="3">
+            <a:schemeClr val="accent1"/>
+          </a:fillRef>
+          <a:effectRef idx="2">
+            <a:schemeClr val="accent1"/>
+          </a:effectRef>
+          <a:fontRef idx="minor">
+            <a:schemeClr val="lt1"/>
+          </a:fontRef>
+        </p:style>
+        <p:txBody>
+          <a:bodyPr rtlCol="0" anchor="ctr"/>
+          <a:lstStyle/>
+          <a:p>
+            <a:pPr algn="ctr"/>
+          </a:p>
+        </p:txBody>
+      </p:sp>
+      <p:sp>
+        <p:nvSpPr>
+          <p:cNvPr id="24" name="TextBox 23"/>
+          <p:cNvSpPr txBox="1"/>
+          <p:nvPr/>
+        </p:nvSpPr>
+        <p:spPr>
+          <a:xfrm>
+            <a:off x="658368" y="3438143"/>
+            <a:ext cx="1517904" cy="310896"/>
+          </a:xfrm>
+          <a:prstGeom prst="rect">
+            <a:avLst/>
+          </a:prstGeom>
+          <a:noFill/>
+        </p:spPr>
+        <p:txBody>
+          <a:bodyPr wrap="none">
+            <a:spAutoFit/>
+          </a:bodyPr>
+          <a:lstStyle/>
+          <a:p>
+            <a:pPr algn="ctr">
+              <a:spcAft>
+                <a:spcPts val="600"/>
+              </a:spcAft>
+            </a:pPr>
+            <a:r>
+              <a:rPr sz="1100" b="1">
+                <a:solidFill>
+                  <a:srgbClr val="FFFFFF"/>
+                </a:solidFill>
+                <a:latin typeface="Calibri"/>
+              </a:rPr>
+              <a:t>ALL</a:t>
+            </a:r>
+          </a:p>
+        </p:txBody>
+      </p:sp>
+      <p:sp>
+        <p:nvSpPr>
+          <p:cNvPr id="25" name="TextBox 24"/>
+          <p:cNvSpPr txBox="1"/>
+          <p:nvPr/>
+        </p:nvSpPr>
+        <p:spPr>
+          <a:xfrm>
+            <a:off x="2331720" y="3428999"/>
+            <a:ext cx="5577840" cy="365760"/>
+          </a:xfrm>
+          <a:prstGeom prst="rect">
+            <a:avLst/>
+          </a:prstGeom>
+          <a:noFill/>
+        </p:spPr>
+        <p:txBody>
+          <a:bodyPr wrap="none">
+            <a:spAutoFit/>
+          </a:bodyPr>
+          <a:lstStyle/>
+          <a:p>
+            <a:pPr algn="l">
+              <a:spcAft>
+                <a:spcPts val="600"/>
+              </a:spcAft>
+            </a:pPr>
+            <a:r>
+              <a:rPr sz="1300" b="1">
+                <a:solidFill>
+                  <a:srgbClr val="17202A"/>
+                </a:solidFill>
+                <a:latin typeface="Calibri"/>
+              </a:rPr>
+              <a:t>/security/ingest</a:t>
+            </a:r>
+          </a:p>
+        </p:txBody>
+      </p:sp>
+      <p:sp>
+        <p:nvSpPr>
+          <p:cNvPr id="26" name="TextBox 25"/>
+          <p:cNvSpPr txBox="1"/>
+          <p:nvPr/>
+        </p:nvSpPr>
+        <p:spPr>
+          <a:xfrm>
+            <a:off x="8092440" y="3438143"/>
+            <a:ext cx="3566160" cy="365760"/>
+          </a:xfrm>
+          <a:prstGeom prst="rect">
+            <a:avLst/>
+          </a:prstGeom>
+          <a:noFill/>
+        </p:spPr>
+        <p:txBody>
+          <a:bodyPr wrap="none">
+            <a:spAutoFit/>
+          </a:bodyPr>
+          <a:lstStyle/>
+          <a:p>
+            <a:pPr algn="l">
+              <a:spcAft>
+                <a:spcPts val="600"/>
+              </a:spcAft>
+            </a:pPr>
+            <a:r>
+              <a:rPr sz="1200" b="0">
+                <a:solidFill>
+                  <a:srgbClr val="52606D"/>
+                </a:solidFill>
+                <a:latin typeface="Calibri"/>
+              </a:rPr>
+              <a:t>interne (nginx/loopback)</a:t>
+            </a:r>
+          </a:p>
+        </p:txBody>
+      </p:sp>
+      <p:sp>
+        <p:nvSpPr>
+          <p:cNvPr id="27" name="Rectangle 26"/>
+          <p:cNvSpPr/>
+          <p:nvPr/>
+        </p:nvSpPr>
+        <p:spPr>
+          <a:xfrm>
+            <a:off x="640080" y="3886199"/>
+            <a:ext cx="1554480" cy="420624"/>
+          </a:xfrm>
+          <a:prstGeom prst="rect">
+            <a:avLst/>
+          </a:prstGeom>
+          <a:solidFill>
+            <a:srgbClr val="155FA0"/>
+          </a:solidFill>
+          <a:ln>
+            <a:noFill/>
+          </a:ln>
+          <a:effectLst/>
+        </p:spPr>
+        <p:style>
+          <a:lnRef idx="1">
+            <a:schemeClr val="accent1"/>
+          </a:lnRef>
+          <a:fillRef idx="3">
+            <a:schemeClr val="accent1"/>
+          </a:fillRef>
+          <a:effectRef idx="2">
+            <a:schemeClr val="accent1"/>
+          </a:effectRef>
+          <a:fontRef idx="minor">
+            <a:schemeClr val="lt1"/>
+          </a:fontRef>
+        </p:style>
+        <p:txBody>
+          <a:bodyPr rtlCol="0" anchor="ctr"/>
+          <a:lstStyle/>
+          <a:p>
+            <a:pPr algn="ctr"/>
+          </a:p>
+        </p:txBody>
+      </p:sp>
+      <p:sp>
+        <p:nvSpPr>
+          <p:cNvPr id="28" name="TextBox 27"/>
+          <p:cNvSpPr txBox="1"/>
+          <p:nvPr/>
+        </p:nvSpPr>
+        <p:spPr>
+          <a:xfrm>
+            <a:off x="658368" y="3941063"/>
+            <a:ext cx="1517904" cy="310896"/>
+          </a:xfrm>
+          <a:prstGeom prst="rect">
+            <a:avLst/>
+          </a:prstGeom>
+          <a:noFill/>
+        </p:spPr>
+        <p:txBody>
+          <a:bodyPr wrap="none">
+            <a:spAutoFit/>
+          </a:bodyPr>
+          <a:lstStyle/>
+          <a:p>
+            <a:pPr algn="ctr">
+              <a:spcAft>
+                <a:spcPts val="600"/>
+              </a:spcAft>
+            </a:pPr>
+            <a:r>
+              <a:rPr sz="1100" b="1">
+                <a:solidFill>
+                  <a:srgbClr val="FFFFFF"/>
+                </a:solidFill>
+                <a:latin typeface="Calibri"/>
+              </a:rPr>
+              <a:t>GET/POST</a:t>
+            </a:r>
+          </a:p>
+        </p:txBody>
+      </p:sp>
+      <p:sp>
+        <p:nvSpPr>
+          <p:cNvPr id="29" name="TextBox 28"/>
+          <p:cNvSpPr txBox="1"/>
+          <p:nvPr/>
+        </p:nvSpPr>
+        <p:spPr>
+          <a:xfrm>
+            <a:off x="2331720" y="3931919"/>
+            <a:ext cx="5577840" cy="365760"/>
+          </a:xfrm>
+          <a:prstGeom prst="rect">
+            <a:avLst/>
+          </a:prstGeom>
+          <a:noFill/>
+        </p:spPr>
+        <p:txBody>
+          <a:bodyPr wrap="none">
+            <a:spAutoFit/>
+          </a:bodyPr>
+          <a:lstStyle/>
+          <a:p>
+            <a:pPr algn="l">
+              <a:spcAft>
+                <a:spcPts val="600"/>
+              </a:spcAft>
+            </a:pPr>
+            <a:r>
+              <a:rPr sz="1300" b="1">
+                <a:solidFill>
+                  <a:srgbClr val="17202A"/>
+                </a:solidFill>
+                <a:latin typeface="Calibri"/>
+              </a:rPr>
+              <a:t>/admin/companies</a:t>
+            </a:r>
+          </a:p>
+        </p:txBody>
+      </p:sp>
+      <p:sp>
+        <p:nvSpPr>
+          <p:cNvPr id="30" name="TextBox 29"/>
+          <p:cNvSpPr txBox="1"/>
+          <p:nvPr/>
+        </p:nvSpPr>
+        <p:spPr>
+          <a:xfrm>
+            <a:off x="8092440" y="3941063"/>
+            <a:ext cx="3566160" cy="365760"/>
+          </a:xfrm>
+          <a:prstGeom prst="rect">
+            <a:avLst/>
+          </a:prstGeom>
+          <a:noFill/>
+        </p:spPr>
+        <p:txBody>
+          <a:bodyPr wrap="none">
+            <a:spAutoFit/>
+          </a:bodyPr>
+          <a:lstStyle/>
+          <a:p>
+            <a:pPr algn="l">
+              <a:spcAft>
+                <a:spcPts val="600"/>
+              </a:spcAft>
+            </a:pPr>
+            <a:r>
+              <a:rPr sz="1200" b="0">
+                <a:solidFill>
+                  <a:srgbClr val="52606D"/>
+                </a:solidFill>
+                <a:latin typeface="Calibri"/>
+              </a:rPr>
+              <a:t>superadmin</a:t>
+            </a:r>
+          </a:p>
+        </p:txBody>
+      </p:sp>
+      <p:sp>
+        <p:nvSpPr>
+          <p:cNvPr id="31" name="Rectangle 30"/>
+          <p:cNvSpPr/>
+          <p:nvPr/>
+        </p:nvSpPr>
+        <p:spPr>
+          <a:xfrm>
+            <a:off x="640080" y="4389119"/>
+            <a:ext cx="1554480" cy="420624"/>
+          </a:xfrm>
+          <a:prstGeom prst="rect">
+            <a:avLst/>
+          </a:prstGeom>
+          <a:solidFill>
+            <a:srgbClr val="155FA0"/>
+          </a:solidFill>
+          <a:ln>
+            <a:noFill/>
+          </a:ln>
+          <a:effectLst/>
+        </p:spPr>
+        <p:style>
+          <a:lnRef idx="1">
+            <a:schemeClr val="accent1"/>
+          </a:lnRef>
+          <a:fillRef idx="3">
+            <a:schemeClr val="accent1"/>
+          </a:fillRef>
+          <a:effectRef idx="2">
+            <a:schemeClr val="accent1"/>
+          </a:effectRef>
+          <a:fontRef idx="minor">
+            <a:schemeClr val="lt1"/>
+          </a:fontRef>
+        </p:style>
+        <p:txBody>
+          <a:bodyPr rtlCol="0" anchor="ctr"/>
+          <a:lstStyle/>
+          <a:p>
+            <a:pPr algn="ctr"/>
+          </a:p>
+        </p:txBody>
+      </p:sp>
+      <p:sp>
+        <p:nvSpPr>
+          <p:cNvPr id="32" name="TextBox 31"/>
+          <p:cNvSpPr txBox="1"/>
+          <p:nvPr/>
+        </p:nvSpPr>
+        <p:spPr>
+          <a:xfrm>
+            <a:off x="658368" y="4443983"/>
+            <a:ext cx="1517904" cy="310896"/>
+          </a:xfrm>
+          <a:prstGeom prst="rect">
+            <a:avLst/>
+          </a:prstGeom>
+          <a:noFill/>
+        </p:spPr>
+        <p:txBody>
+          <a:bodyPr wrap="none">
+            <a:spAutoFit/>
+          </a:bodyPr>
+          <a:lstStyle/>
+          <a:p>
+            <a:pPr algn="ctr">
+              <a:spcAft>
+                <a:spcPts val="600"/>
+              </a:spcAft>
+            </a:pPr>
+            <a:r>
+              <a:rPr sz="1100" b="1">
+                <a:solidFill>
+                  <a:srgbClr val="FFFFFF"/>
+                </a:solidFill>
+                <a:latin typeface="Calibri"/>
+              </a:rPr>
+              <a:t>POST</a:t>
+            </a:r>
+          </a:p>
+        </p:txBody>
+      </p:sp>
+      <p:sp>
+        <p:nvSpPr>
+          <p:cNvPr id="33" name="TextBox 32"/>
+          <p:cNvSpPr txBox="1"/>
+          <p:nvPr/>
+        </p:nvSpPr>
+        <p:spPr>
+          <a:xfrm>
+            <a:off x="2331720" y="4434839"/>
+            <a:ext cx="5577840" cy="365760"/>
+          </a:xfrm>
+          <a:prstGeom prst="rect">
+            <a:avLst/>
+          </a:prstGeom>
+          <a:noFill/>
+        </p:spPr>
+        <p:txBody>
+          <a:bodyPr wrap="none">
+            <a:spAutoFit/>
+          </a:bodyPr>
+          <a:lstStyle/>
+          <a:p>
+            <a:pPr algn="l">
+              <a:spcAft>
+                <a:spcPts val="600"/>
+              </a:spcAft>
+            </a:pPr>
+            <a:r>
+              <a:rPr sz="1300" b="1">
+                <a:solidFill>
+                  <a:srgbClr val="17202A"/>
+                </a:solidFill>
+                <a:latin typeface="Calibri"/>
+              </a:rPr>
+              <a:t>/admin/companies/:id/invite-admin</a:t>
+            </a:r>
+          </a:p>
+        </p:txBody>
+      </p:sp>
+      <p:sp>
+        <p:nvSpPr>
+          <p:cNvPr id="34" name="TextBox 33"/>
+          <p:cNvSpPr txBox="1"/>
+          <p:nvPr/>
+        </p:nvSpPr>
+        <p:spPr>
+          <a:xfrm>
+            <a:off x="8092440" y="4443983"/>
+            <a:ext cx="3566160" cy="365760"/>
+          </a:xfrm>
+          <a:prstGeom prst="rect">
+            <a:avLst/>
+          </a:prstGeom>
+          <a:noFill/>
+        </p:spPr>
+        <p:txBody>
+          <a:bodyPr wrap="none">
+            <a:spAutoFit/>
+          </a:bodyPr>
+          <a:lstStyle/>
+          <a:p>
+            <a:pPr algn="l">
+              <a:spcAft>
+                <a:spcPts val="600"/>
+              </a:spcAft>
+            </a:pPr>
+            <a:r>
+              <a:rPr sz="1200" b="0">
+                <a:solidFill>
+                  <a:srgbClr val="52606D"/>
+                </a:solidFill>
+                <a:latin typeface="Calibri"/>
+              </a:rPr>
+              <a:t>superadmin</a:t>
+            </a:r>
+          </a:p>
+        </p:txBody>
+      </p:sp>
+      <p:sp>
+        <p:nvSpPr>
+          <p:cNvPr id="35" name="Rectangle 34"/>
+          <p:cNvSpPr/>
+          <p:nvPr/>
+        </p:nvSpPr>
+        <p:spPr>
+          <a:xfrm>
+            <a:off x="640080" y="4892039"/>
+            <a:ext cx="1554480" cy="420624"/>
+          </a:xfrm>
+          <a:prstGeom prst="rect">
+            <a:avLst/>
+          </a:prstGeom>
+          <a:solidFill>
+            <a:srgbClr val="155FA0"/>
+          </a:solidFill>
+          <a:ln>
+            <a:noFill/>
+          </a:ln>
+          <a:effectLst/>
+        </p:spPr>
+        <p:style>
+          <a:lnRef idx="1">
+            <a:schemeClr val="accent1"/>
+          </a:lnRef>
+          <a:fillRef idx="3">
+            <a:schemeClr val="accent1"/>
+          </a:fillRef>
+          <a:effectRef idx="2">
+            <a:schemeClr val="accent1"/>
+          </a:effectRef>
+          <a:fontRef idx="minor">
+            <a:schemeClr val="lt1"/>
+          </a:fontRef>
+        </p:style>
+        <p:txBody>
+          <a:bodyPr rtlCol="0" anchor="ctr"/>
+          <a:lstStyle/>
+          <a:p>
+            <a:pPr algn="ctr"/>
+          </a:p>
+        </p:txBody>
+      </p:sp>
+      <p:sp>
+        <p:nvSpPr>
+          <p:cNvPr id="36" name="TextBox 35"/>
+          <p:cNvSpPr txBox="1"/>
+          <p:nvPr/>
+        </p:nvSpPr>
+        <p:spPr>
+          <a:xfrm>
+            <a:off x="658368" y="4946903"/>
+            <a:ext cx="1517904" cy="310896"/>
+          </a:xfrm>
+          <a:prstGeom prst="rect">
+            <a:avLst/>
+          </a:prstGeom>
+          <a:noFill/>
+        </p:spPr>
+        <p:txBody>
+          <a:bodyPr wrap="none">
+            <a:spAutoFit/>
+          </a:bodyPr>
+          <a:lstStyle/>
+          <a:p>
+            <a:pPr algn="ctr">
+              <a:spcAft>
+                <a:spcPts val="600"/>
+              </a:spcAft>
+            </a:pPr>
+            <a:r>
+              <a:rPr sz="1100" b="1">
+                <a:solidFill>
+                  <a:srgbClr val="FFFFFF"/>
+                </a:solidFill>
+                <a:latin typeface="Calibri"/>
+              </a:rPr>
+              <a:t>GET/POST</a:t>
+            </a:r>
+          </a:p>
+        </p:txBody>
+      </p:sp>
+      <p:sp>
+        <p:nvSpPr>
+          <p:cNvPr id="37" name="TextBox 36"/>
+          <p:cNvSpPr txBox="1"/>
+          <p:nvPr/>
+        </p:nvSpPr>
+        <p:spPr>
+          <a:xfrm>
+            <a:off x="2331720" y="4937759"/>
+            <a:ext cx="5577840" cy="365760"/>
+          </a:xfrm>
+          <a:prstGeom prst="rect">
+            <a:avLst/>
+          </a:prstGeom>
+          <a:noFill/>
+        </p:spPr>
+        <p:txBody>
+          <a:bodyPr wrap="none">
+            <a:spAutoFit/>
+          </a:bodyPr>
+          <a:lstStyle/>
+          <a:p>
+            <a:pPr algn="l">
+              <a:spcAft>
+                <a:spcPts val="600"/>
+              </a:spcAft>
+            </a:pPr>
+            <a:r>
+              <a:rPr sz="1300" b="1">
+                <a:solidFill>
+                  <a:srgbClr val="17202A"/>
+                </a:solidFill>
+                <a:latin typeface="Calibri"/>
+              </a:rPr>
+              <a:t>/admin/users</a:t>
+            </a:r>
+          </a:p>
+        </p:txBody>
+      </p:sp>
+      <p:sp>
+        <p:nvSpPr>
+          <p:cNvPr id="38" name="TextBox 37"/>
+          <p:cNvSpPr txBox="1"/>
+          <p:nvPr/>
+        </p:nvSpPr>
+        <p:spPr>
+          <a:xfrm>
+            <a:off x="8092440" y="4946903"/>
+            <a:ext cx="3566160" cy="365760"/>
+          </a:xfrm>
+          <a:prstGeom prst="rect">
+            <a:avLst/>
+          </a:prstGeom>
+          <a:noFill/>
+        </p:spPr>
+        <p:txBody>
+          <a:bodyPr wrap="none">
+            <a:spAutoFit/>
+          </a:bodyPr>
+          <a:lstStyle/>
+          <a:p>
+            <a:pPr algn="l">
+              <a:spcAft>
+                <a:spcPts val="600"/>
+              </a:spcAft>
+            </a:pPr>
+            <a:r>
+              <a:rPr sz="1200" b="0">
+                <a:solidFill>
+                  <a:srgbClr val="52606D"/>
+                </a:solidFill>
+                <a:latin typeface="Calibri"/>
+              </a:rPr>
+              <a:t>admin (son entreprise)</a:t>
+            </a:r>
+          </a:p>
+        </p:txBody>
+      </p:sp>
+      <p:sp>
+        <p:nvSpPr>
+          <p:cNvPr id="39" name="Rectangle 38"/>
+          <p:cNvSpPr/>
+          <p:nvPr/>
+        </p:nvSpPr>
+        <p:spPr>
+          <a:xfrm>
+            <a:off x="640080" y="5394959"/>
+            <a:ext cx="1554480" cy="420624"/>
+          </a:xfrm>
+          <a:prstGeom prst="rect">
+            <a:avLst/>
+          </a:prstGeom>
+          <a:solidFill>
+            <a:srgbClr val="155FA0"/>
+          </a:solidFill>
+          <a:ln>
+            <a:noFill/>
+          </a:ln>
+          <a:effectLst/>
+        </p:spPr>
+        <p:style>
+          <a:lnRef idx="1">
+            <a:schemeClr val="accent1"/>
+          </a:lnRef>
+          <a:fillRef idx="3">
+            <a:schemeClr val="accent1"/>
+          </a:fillRef>
+          <a:effectRef idx="2">
+            <a:schemeClr val="accent1"/>
+          </a:effectRef>
+          <a:fontRef idx="minor">
+            <a:schemeClr val="lt1"/>
+          </a:fontRef>
+        </p:style>
+        <p:txBody>
+          <a:bodyPr rtlCol="0" anchor="ctr"/>
+          <a:lstStyle/>
+          <a:p>
+            <a:pPr algn="ctr"/>
+          </a:p>
+        </p:txBody>
+      </p:sp>
+      <p:sp>
+        <p:nvSpPr>
+          <p:cNvPr id="40" name="TextBox 39"/>
+          <p:cNvSpPr txBox="1"/>
+          <p:nvPr/>
+        </p:nvSpPr>
+        <p:spPr>
+          <a:xfrm>
+            <a:off x="658368" y="5449823"/>
+            <a:ext cx="1517904" cy="310896"/>
+          </a:xfrm>
+          <a:prstGeom prst="rect">
+            <a:avLst/>
+          </a:prstGeom>
+          <a:noFill/>
+        </p:spPr>
+        <p:txBody>
+          <a:bodyPr wrap="none">
+            <a:spAutoFit/>
+          </a:bodyPr>
+          <a:lstStyle/>
+          <a:p>
+            <a:pPr algn="ctr">
+              <a:spcAft>
+                <a:spcPts val="600"/>
+              </a:spcAft>
+            </a:pPr>
+            <a:r>
+              <a:rPr sz="1100" b="1">
+                <a:solidFill>
+                  <a:srgbClr val="FFFFFF"/>
+                </a:solidFill>
+                <a:latin typeface="Calibri"/>
+              </a:rPr>
+              <a:t>GET/POST</a:t>
+            </a:r>
+          </a:p>
+        </p:txBody>
+      </p:sp>
+      <p:sp>
+        <p:nvSpPr>
+          <p:cNvPr id="41" name="TextBox 40"/>
+          <p:cNvSpPr txBox="1"/>
+          <p:nvPr/>
+        </p:nvSpPr>
+        <p:spPr>
+          <a:xfrm>
+            <a:off x="2331720" y="5440679"/>
+            <a:ext cx="5577840" cy="365760"/>
+          </a:xfrm>
+          <a:prstGeom prst="rect">
+            <a:avLst/>
+          </a:prstGeom>
+          <a:noFill/>
+        </p:spPr>
+        <p:txBody>
+          <a:bodyPr wrap="none">
+            <a:spAutoFit/>
+          </a:bodyPr>
+          <a:lstStyle/>
+          <a:p>
+            <a:pPr algn="l">
+              <a:spcAft>
+                <a:spcPts val="600"/>
+              </a:spcAft>
+            </a:pPr>
+            <a:r>
+              <a:rPr sz="1300" b="1">
+                <a:solidFill>
+                  <a:srgbClr val="17202A"/>
+                </a:solidFill>
+                <a:latin typeface="Calibri"/>
+              </a:rPr>
+              <a:t>/admin/contents</a:t>
+            </a:r>
+          </a:p>
+        </p:txBody>
+      </p:sp>
+      <p:sp>
+        <p:nvSpPr>
+          <p:cNvPr id="42" name="TextBox 41"/>
+          <p:cNvSpPr txBox="1"/>
+          <p:nvPr/>
+        </p:nvSpPr>
+        <p:spPr>
+          <a:xfrm>
+            <a:off x="8092440" y="5449823"/>
+            <a:ext cx="3566160" cy="365760"/>
+          </a:xfrm>
+          <a:prstGeom prst="rect">
+            <a:avLst/>
+          </a:prstGeom>
+          <a:noFill/>
+        </p:spPr>
+        <p:txBody>
+          <a:bodyPr wrap="none">
+            <a:spAutoFit/>
+          </a:bodyPr>
+          <a:lstStyle/>
+          <a:p>
+            <a:pPr algn="l">
+              <a:spcAft>
+                <a:spcPts val="600"/>
+              </a:spcAft>
+            </a:pPr>
+            <a:r>
+              <a:rPr sz="1200" b="0">
+                <a:solidFill>
+                  <a:srgbClr val="52606D"/>
+                </a:solidFill>
+                <a:latin typeface="Calibri"/>
+              </a:rPr>
+              <a:t>admin (son entreprise)</a:t>
+            </a:r>
+          </a:p>
+        </p:txBody>
+      </p:sp>
+      <p:sp>
+        <p:nvSpPr>
+          <p:cNvPr id="43" name="Rectangle 42"/>
+          <p:cNvSpPr/>
+          <p:nvPr/>
+        </p:nvSpPr>
+        <p:spPr>
+          <a:xfrm>
+            <a:off x="640080" y="5897879"/>
+            <a:ext cx="1554480" cy="420624"/>
+          </a:xfrm>
+          <a:prstGeom prst="rect">
+            <a:avLst/>
+          </a:prstGeom>
+          <a:solidFill>
+            <a:srgbClr val="155FA0"/>
+          </a:solidFill>
+          <a:ln>
+            <a:noFill/>
+          </a:ln>
+          <a:effectLst/>
+        </p:spPr>
+        <p:style>
+          <a:lnRef idx="1">
+            <a:schemeClr val="accent1"/>
+          </a:lnRef>
+          <a:fillRef idx="3">
+            <a:schemeClr val="accent1"/>
+          </a:fillRef>
+          <a:effectRef idx="2">
+            <a:schemeClr val="accent1"/>
+          </a:effectRef>
+          <a:fontRef idx="minor">
+            <a:schemeClr val="lt1"/>
+          </a:fontRef>
+        </p:style>
+        <p:txBody>
+          <a:bodyPr rtlCol="0" anchor="ctr"/>
+          <a:lstStyle/>
+          <a:p>
+            <a:pPr algn="ctr"/>
+          </a:p>
+        </p:txBody>
+      </p:sp>
+      <p:sp>
+        <p:nvSpPr>
+          <p:cNvPr id="44" name="TextBox 43"/>
+          <p:cNvSpPr txBox="1"/>
+          <p:nvPr/>
+        </p:nvSpPr>
+        <p:spPr>
+          <a:xfrm>
+            <a:off x="658368" y="5952743"/>
+            <a:ext cx="1517904" cy="310896"/>
+          </a:xfrm>
+          <a:prstGeom prst="rect">
+            <a:avLst/>
+          </a:prstGeom>
+          <a:noFill/>
+        </p:spPr>
+        <p:txBody>
+          <a:bodyPr wrap="none">
+            <a:spAutoFit/>
+          </a:bodyPr>
+          <a:lstStyle/>
+          <a:p>
+            <a:pPr algn="ctr">
+              <a:spcAft>
+                <a:spcPts val="600"/>
+              </a:spcAft>
+            </a:pPr>
+            <a:r>
+              <a:rPr sz="1100" b="1">
+                <a:solidFill>
+                  <a:srgbClr val="FFFFFF"/>
+                </a:solidFill>
+                <a:latin typeface="Calibri"/>
+              </a:rPr>
+              <a:t>POST</a:t>
+            </a:r>
+          </a:p>
+        </p:txBody>
+      </p:sp>
+      <p:sp>
+        <p:nvSpPr>
+          <p:cNvPr id="45" name="TextBox 44"/>
+          <p:cNvSpPr txBox="1"/>
+          <p:nvPr/>
+        </p:nvSpPr>
+        <p:spPr>
+          <a:xfrm>
+            <a:off x="2331720" y="5943599"/>
+            <a:ext cx="5577840" cy="365760"/>
+          </a:xfrm>
+          <a:prstGeom prst="rect">
+            <a:avLst/>
+          </a:prstGeom>
+          <a:noFill/>
+        </p:spPr>
+        <p:txBody>
+          <a:bodyPr wrap="none">
+            <a:spAutoFit/>
+          </a:bodyPr>
+          <a:lstStyle/>
+          <a:p>
+            <a:pPr algn="l">
+              <a:spcAft>
+                <a:spcPts val="600"/>
+              </a:spcAft>
+            </a:pPr>
+            <a:r>
+              <a:rPr sz="1300" b="1">
+                <a:solidFill>
+                  <a:srgbClr val="17202A"/>
+                </a:solidFill>
+                <a:latin typeface="Calibri"/>
+              </a:rPr>
+              <a:t>/admin/contents/:id/revoke | restore</a:t>
+            </a:r>
+          </a:p>
+        </p:txBody>
+      </p:sp>
+      <p:sp>
+        <p:nvSpPr>
+          <p:cNvPr id="46" name="TextBox 45"/>
+          <p:cNvSpPr txBox="1"/>
+          <p:nvPr/>
+        </p:nvSpPr>
+        <p:spPr>
+          <a:xfrm>
+            <a:off x="8092440" y="5952743"/>
+            <a:ext cx="3566160" cy="365760"/>
+          </a:xfrm>
+          <a:prstGeom prst="rect">
+            <a:avLst/>
+          </a:prstGeom>
+          <a:noFill/>
+        </p:spPr>
+        <p:txBody>
+          <a:bodyPr wrap="none">
+            <a:spAutoFit/>
+          </a:bodyPr>
+          <a:lstStyle/>
+          <a:p>
+            <a:pPr algn="l">
+              <a:spcAft>
+                <a:spcPts val="600"/>
+              </a:spcAft>
+            </a:pPr>
+            <a:r>
+              <a:rPr sz="1200" b="0">
+                <a:solidFill>
+                  <a:srgbClr val="52606D"/>
+                </a:solidFill>
+                <a:latin typeface="Calibri"/>
+              </a:rPr>
+              <a:t>admin</a:t>
+            </a:r>
+          </a:p>
+        </p:txBody>
+      </p:sp>
+    </p:spTree>
+  </p:cSld>
+  <p:clrMapOvr>
+    <a:masterClrMapping/>
+  </p:clrMapOvr>
+</p:sld>
+</file>
+
+<file path=ppt/slides/slide18.xml><?xml version="1.0" encoding="utf-8"?>
+<p:sld xmlns:a="http://schemas.openxmlformats.org/drawingml/2006/main" xmlns:p="http://schemas.openxmlformats.org/presentationml/2006/main" xmlns:r="http://schemas.openxmlformats.org/officeDocument/2006/relationships">
+  <p:cSld>
+    <p:spTree>
+      <p:nvGrpSpPr>
+        <p:cNvPr id="1" name=""/>
+        <p:cNvGrpSpPr/>
+        <p:nvPr/>
+      </p:nvGrpSpPr>
+      <p:grpSpPr/>
+      <p:sp>
+        <p:nvSpPr>
+          <p:cNvPr id="2" name="Rectangle 1"/>
+          <p:cNvSpPr/>
+          <p:nvPr/>
+        </p:nvSpPr>
+        <p:spPr>
+          <a:xfrm>
+            <a:off x="-91440" y="-91440"/>
+            <a:ext cx="12435840" cy="7040880"/>
+          </a:xfrm>
+          <a:prstGeom prst="rect">
+            <a:avLst/>
+          </a:prstGeom>
+          <a:solidFill>
+            <a:srgbClr val="0B1F3A"/>
+          </a:solidFill>
+          <a:ln>
+            <a:noFill/>
+          </a:ln>
+          <a:effectLst/>
+        </p:spPr>
+        <p:style>
+          <a:lnRef idx="1">
+            <a:schemeClr val="accent1"/>
+          </a:lnRef>
+          <a:fillRef idx="3">
+            <a:schemeClr val="accent1"/>
+          </a:fillRef>
+          <a:effectRef idx="2">
+            <a:schemeClr val="accent1"/>
+          </a:effectRef>
+          <a:fontRef idx="minor">
+            <a:schemeClr val="lt1"/>
+          </a:fontRef>
+        </p:style>
+        <p:txBody>
+          <a:bodyPr rtlCol="0" anchor="ctr"/>
+          <a:lstStyle/>
+          <a:p>
+            <a:pPr algn="ctr"/>
+          </a:p>
+        </p:txBody>
+      </p:sp>
+      <p:sp>
+        <p:nvSpPr>
+          <p:cNvPr id="3" name="Rectangle 2"/>
+          <p:cNvSpPr/>
+          <p:nvPr/>
+        </p:nvSpPr>
+        <p:spPr>
+          <a:xfrm>
+            <a:off x="0" y="914400"/>
+            <a:ext cx="12191695" cy="73152"/>
+          </a:xfrm>
+          <a:prstGeom prst="rect">
+            <a:avLst/>
+          </a:prstGeom>
+          <a:solidFill>
+            <a:srgbClr val="2EC4B6"/>
+          </a:solidFill>
+          <a:ln>
+            <a:noFill/>
+          </a:ln>
+          <a:effectLst/>
+        </p:spPr>
+        <p:style>
+          <a:lnRef idx="1">
+            <a:schemeClr val="accent1"/>
+          </a:lnRef>
+          <a:fillRef idx="3">
+            <a:schemeClr val="accent1"/>
+          </a:fillRef>
+          <a:effectRef idx="2">
+            <a:schemeClr val="accent1"/>
+          </a:effectRef>
+          <a:fontRef idx="minor">
+            <a:schemeClr val="lt1"/>
+          </a:fontRef>
+        </p:style>
+        <p:txBody>
+          <a:bodyPr rtlCol="0" anchor="ctr"/>
+          <a:lstStyle/>
+          <a:p>
+            <a:pPr algn="ctr"/>
+          </a:p>
+        </p:txBody>
+      </p:sp>
+      <p:sp>
+        <p:nvSpPr>
+          <p:cNvPr id="4" name="TextBox 3"/>
+          <p:cNvSpPr txBox="1"/>
+          <p:nvPr/>
+        </p:nvSpPr>
+        <p:spPr>
+          <a:xfrm>
+            <a:off x="822960" y="365760"/>
+            <a:ext cx="10515600" cy="640080"/>
+          </a:xfrm>
+          <a:prstGeom prst="rect">
+            <a:avLst/>
+          </a:prstGeom>
+          <a:noFill/>
+        </p:spPr>
+        <p:txBody>
+          <a:bodyPr wrap="none">
+            <a:spAutoFit/>
+          </a:bodyPr>
+          <a:lstStyle/>
+          <a:p>
             <a:pPr algn="l">
               <a:spcAft>
                 <a:spcPts val="600"/>
@@ -7856,7 +8963,7 @@
                 </a:solidFill>
                 <a:latin typeface="Calibri"/>
               </a:rPr>
-              <a:t>✓  Back-office admin : ACL dynamique + révocation de clé en direct</a:t>
+              <a:t>✓  Back-office multi-tenant : 3 rôles, ACL dynamique, révocation de clé</a:t>
             </a:r>
           </a:p>
           <a:p>
@@ -7872,6 +8979,22 @@
                 </a:solidFill>
                 <a:latin typeface="Calibri"/>
               </a:rPr>
+              <a:t>✓  Onboarding par invitation (mdp temporaire 24 h + changement forcé)</a:t>
+            </a:r>
+          </a:p>
+          <a:p>
+            <a:pPr algn="l">
+              <a:spcAft>
+                <a:spcPts val="600"/>
+              </a:spcAft>
+            </a:pPr>
+            <a:r>
+              <a:rPr sz="1600" b="0">
+                <a:solidFill>
+                  <a:srgbClr val="FFFFFF"/>
+                </a:solidFill>
+                <a:latin typeface="Calibri"/>
+              </a:rPr>
               <a:t>✓  Plan d'intégration livré au front (P1)</a:t>
             </a:r>
           </a:p>
@@ -7936,7 +9059,7 @@
                 </a:solidFill>
                 <a:latin typeface="Calibri"/>
               </a:rPr>
-              <a:t>•  Révocation par session / spectateur (pas seulement par contenu)</a:t>
+              <a:t>•  Envoi d'email réel (SMTP/API) au lieu de la simulation</a:t>
             </a:r>
           </a:p>
           <a:p>

</xml_diff>